<commit_message>
Polish competition showcase UI
</commit_message>
<xml_diff>
--- a/deliverables/SHORIR_AI_Project_Presentation.pptx
+++ b/deliverables/SHORIR_AI_Project_Presentation.pptx
@@ -2,20 +2,20 @@
 <file path=ppt/presentation.xml><?xml version="1.0" encoding="utf-8"?>
 <p:presentation xmlns:p="http://schemas.openxmlformats.org/presentationml/2006/main">
   <p:sldMasterIdLst>
-    <p:sldMasterId xmlns:r="http://schemas.openxmlformats.org/officeDocument/2006/relationships" id="2147483648" r:id="Rd2413bf2ccd345eb"/>
+    <p:sldMasterId xmlns:r="http://schemas.openxmlformats.org/officeDocument/2006/relationships" id="2147483648" r:id="Rb74b0248f3574eab"/>
   </p:sldMasterIdLst>
   <p:notesMasterIdLst>
-    <p:notesMasterId xmlns:r="http://schemas.openxmlformats.org/officeDocument/2006/relationships" r:id="Rf2113c269d8c41c2"/>
+    <p:notesMasterId xmlns:r="http://schemas.openxmlformats.org/officeDocument/2006/relationships" r:id="Re55e452fd64946a7"/>
   </p:notesMasterIdLst>
   <p:sldIdLst>
-    <p:sldId xmlns:r="http://schemas.openxmlformats.org/officeDocument/2006/relationships" id="256" r:id="Rac84c1ee56274466"/>
-    <p:sldId xmlns:r="http://schemas.openxmlformats.org/officeDocument/2006/relationships" id="257" r:id="R64922605f3ea4cd0"/>
-    <p:sldId xmlns:r="http://schemas.openxmlformats.org/officeDocument/2006/relationships" id="258" r:id="R268a0f42249e4697"/>
-    <p:sldId xmlns:r="http://schemas.openxmlformats.org/officeDocument/2006/relationships" id="259" r:id="R9431709c7fe94e55"/>
-    <p:sldId xmlns:r="http://schemas.openxmlformats.org/officeDocument/2006/relationships" id="260" r:id="R16421a067ae44e2f"/>
-    <p:sldId xmlns:r="http://schemas.openxmlformats.org/officeDocument/2006/relationships" id="261" r:id="R6f98f5afc8e64acf"/>
-    <p:sldId xmlns:r="http://schemas.openxmlformats.org/officeDocument/2006/relationships" id="262" r:id="R99fa17da7a784a55"/>
-    <p:sldId xmlns:r="http://schemas.openxmlformats.org/officeDocument/2006/relationships" id="263" r:id="R102f156dfba04bfe"/>
+    <p:sldId xmlns:r="http://schemas.openxmlformats.org/officeDocument/2006/relationships" id="256" r:id="Rb428755165b44efe"/>
+    <p:sldId xmlns:r="http://schemas.openxmlformats.org/officeDocument/2006/relationships" id="257" r:id="R83351197edc54ea0"/>
+    <p:sldId xmlns:r="http://schemas.openxmlformats.org/officeDocument/2006/relationships" id="258" r:id="R6568befb028b4fbf"/>
+    <p:sldId xmlns:r="http://schemas.openxmlformats.org/officeDocument/2006/relationships" id="259" r:id="Ree10a9a8b77b422e"/>
+    <p:sldId xmlns:r="http://schemas.openxmlformats.org/officeDocument/2006/relationships" id="260" r:id="R8dcf4e6077ec4a90"/>
+    <p:sldId xmlns:r="http://schemas.openxmlformats.org/officeDocument/2006/relationships" id="261" r:id="R3093826d7bb348e1"/>
+    <p:sldId xmlns:r="http://schemas.openxmlformats.org/officeDocument/2006/relationships" id="262" r:id="Rf5410dfa863e4144"/>
+    <p:sldId xmlns:r="http://schemas.openxmlformats.org/officeDocument/2006/relationships" id="263" r:id="Rae43e6eddc124887"/>
   </p:sldIdLst>
   <p:sldSz cx="12192000" cy="6858000"/>
   <p:notesSz cx="6858000" cy="9144000"/>
@@ -1070,7 +1070,7 @@
   </p:cSld>
   <p:clrMap bg1="lt1" tx1="dk1" bg2="lt2" tx2="dk2" accent1="accent1" accent2="accent2" accent3="accent3" accent4="accent4" accent5="accent5" accent6="accent6" hlink="hlink" folHlink="folHlink"/>
   <p:sldLayoutIdLst>
-    <p:sldLayoutId xmlns:r="http://schemas.openxmlformats.org/officeDocument/2006/relationships" id="2147483649" r:id="R746211c7c946456f"/>
+    <p:sldLayoutId xmlns:r="http://schemas.openxmlformats.org/officeDocument/2006/relationships" id="2147483649" r:id="R112f4e4277054b45"/>
   </p:sldLayoutIdLst>
   <p:txStyles>
     <p:titleStyle>
@@ -1621,7 +1621,7 @@
           <p:cNvPr id="1" name="">
             <a:extLst xmlns:a="http://schemas.openxmlformats.org/drawingml/2006/main">
               <a:ext uri="{FF2B5EF4-FFF2-40B4-BE49-F238E27FC236}">
-                <a16:creationId xmlns:a16="http://schemas.microsoft.com/office/drawing/2014/main" id="{1CC3A62E-9843-4A99-97EA-74591CD5102E}"/>
+                <a16:creationId xmlns:a16="http://schemas.microsoft.com/office/drawing/2014/main" id="{A920FBB1-4110-4DBC-B9D7-6CB1AFB69E2D}"/>
               </a:ext>
             </a:extLst>
           </p:cNvPr>
@@ -1671,7 +1671,7 @@
           <p:cNvPr id="2" name="">
             <a:extLst xmlns:a="http://schemas.openxmlformats.org/drawingml/2006/main">
               <a:ext uri="{FF2B5EF4-FFF2-40B4-BE49-F238E27FC236}">
-                <a16:creationId xmlns:a16="http://schemas.microsoft.com/office/drawing/2014/main" id="{6538D828-B4CA-42BE-9A61-D7962D246248}"/>
+                <a16:creationId xmlns:a16="http://schemas.microsoft.com/office/drawing/2014/main" id="{CA8B3492-C971-48CE-8F6B-DD50B25916B4}"/>
               </a:ext>
             </a:extLst>
           </p:cNvPr>
@@ -1721,7 +1721,7 @@
           <p:cNvPr id="3" name="">
             <a:extLst xmlns:a="http://schemas.openxmlformats.org/drawingml/2006/main">
               <a:ext uri="{FF2B5EF4-FFF2-40B4-BE49-F238E27FC236}">
-                <a16:creationId xmlns:a16="http://schemas.microsoft.com/office/drawing/2014/main" id="{41FB1046-AC5F-4041-9813-029DA9ECFF5C}"/>
+                <a16:creationId xmlns:a16="http://schemas.microsoft.com/office/drawing/2014/main" id="{64D823EE-B8A5-4A46-853F-33AF35BD980C}"/>
               </a:ext>
             </a:extLst>
           </p:cNvPr>
@@ -1771,7 +1771,7 @@
           <p:cNvPr id="4" name="">
             <a:extLst xmlns:a="http://schemas.openxmlformats.org/drawingml/2006/main">
               <a:ext uri="{FF2B5EF4-FFF2-40B4-BE49-F238E27FC236}">
-                <a16:creationId xmlns:a16="http://schemas.microsoft.com/office/drawing/2014/main" id="{FABEDD09-6AE3-4AB2-8E97-86BCB27B0849}"/>
+                <a16:creationId xmlns:a16="http://schemas.microsoft.com/office/drawing/2014/main" id="{A4BC8567-4CF2-490B-B421-78A4FF997059}"/>
               </a:ext>
             </a:extLst>
           </p:cNvPr>
@@ -1810,7 +1810,7 @@
           <p:nvPr/>
         </p:nvPicPr>
         <p:blipFill>
-          <a:blip xmlns:r="http://schemas.openxmlformats.org/officeDocument/2006/relationships" xmlns:a="http://schemas.openxmlformats.org/drawingml/2006/main" r:embed="Rf8a7a5e2a16c478e"/>
+          <a:blip xmlns:r="http://schemas.openxmlformats.org/officeDocument/2006/relationships" xmlns:a="http://schemas.openxmlformats.org/drawingml/2006/main" r:embed="R6094f7bb1fe3488f"/>
           <a:srcRect xmlns:a="http://schemas.openxmlformats.org/drawingml/2006/main" l="12678" t="0" r="12678" b="0"/>
           <a:stretch xmlns:a="http://schemas.openxmlformats.org/drawingml/2006/main">
             <a:fillRect l="0" t="0" r="0" b="0"/>
@@ -1833,7 +1833,7 @@
           <p:cNvPr id="6" name="">
             <a:extLst xmlns:a="http://schemas.openxmlformats.org/drawingml/2006/main">
               <a:ext uri="{FF2B5EF4-FFF2-40B4-BE49-F238E27FC236}">
-                <a16:creationId xmlns:a16="http://schemas.microsoft.com/office/drawing/2014/main" id="{60B74621-18A6-4393-9F6C-2394AEA48653}"/>
+                <a16:creationId xmlns:a16="http://schemas.microsoft.com/office/drawing/2014/main" id="{8DCCCD3B-7EAF-46CB-B663-40E26A7AB6FB}"/>
               </a:ext>
             </a:extLst>
           </p:cNvPr>
@@ -1881,7 +1881,7 @@
     </p:spTree>
     <p:extLst>
       <p:ext uri="{BB962C8B-B14F-4D97-AF65-F5344CB8AC3E}">
-        <p14:creationId xmlns:p14="http://schemas.microsoft.com/office/powerpoint/2010/main" val="2007973352"/>
+        <p14:creationId xmlns:p14="http://schemas.microsoft.com/office/powerpoint/2010/main" val="1178557630"/>
       </p:ext>
     </p:extLst>
   </p:cSld>
@@ -1912,7 +1912,7 @@
           <p:cNvPr id="1" name="">
             <a:extLst xmlns:a="http://schemas.openxmlformats.org/drawingml/2006/main">
               <a:ext uri="{FF2B5EF4-FFF2-40B4-BE49-F238E27FC236}">
-                <a16:creationId xmlns:a16="http://schemas.microsoft.com/office/drawing/2014/main" id="{8A113CA4-EB44-4F14-8F04-C891617C1D17}"/>
+                <a16:creationId xmlns:a16="http://schemas.microsoft.com/office/drawing/2014/main" id="{8233AAF4-3181-40ED-9E8A-90A954440D97}"/>
               </a:ext>
             </a:extLst>
           </p:cNvPr>
@@ -1962,7 +1962,7 @@
           <p:cNvPr id="2" name="">
             <a:extLst xmlns:a="http://schemas.openxmlformats.org/drawingml/2006/main">
               <a:ext uri="{FF2B5EF4-FFF2-40B4-BE49-F238E27FC236}">
-                <a16:creationId xmlns:a16="http://schemas.microsoft.com/office/drawing/2014/main" id="{3902569A-4C81-4CB9-85F7-910A1131BCB7}"/>
+                <a16:creationId xmlns:a16="http://schemas.microsoft.com/office/drawing/2014/main" id="{8A71D98E-DB64-47CD-96B4-C6A9944A03EF}"/>
               </a:ext>
             </a:extLst>
           </p:cNvPr>
@@ -2012,7 +2012,7 @@
           <p:cNvPr id="3" name="">
             <a:extLst xmlns:a="http://schemas.openxmlformats.org/drawingml/2006/main">
               <a:ext uri="{FF2B5EF4-FFF2-40B4-BE49-F238E27FC236}">
-                <a16:creationId xmlns:a16="http://schemas.microsoft.com/office/drawing/2014/main" id="{8433ACFD-A968-477E-AA7A-A98E6C5EDE51}"/>
+                <a16:creationId xmlns:a16="http://schemas.microsoft.com/office/drawing/2014/main" id="{6E6441F1-6D53-49CF-AD03-56D90BE2B4E4}"/>
               </a:ext>
             </a:extLst>
           </p:cNvPr>
@@ -2045,7 +2045,7 @@
           <p:cNvPr id="4" name="">
             <a:extLst xmlns:a="http://schemas.openxmlformats.org/drawingml/2006/main">
               <a:ext uri="{FF2B5EF4-FFF2-40B4-BE49-F238E27FC236}">
-                <a16:creationId xmlns:a16="http://schemas.microsoft.com/office/drawing/2014/main" id="{03E85807-0DC4-4414-8420-74DE085873F6}"/>
+                <a16:creationId xmlns:a16="http://schemas.microsoft.com/office/drawing/2014/main" id="{76173097-9ABC-4213-8BC1-EBB2819F6884}"/>
               </a:ext>
             </a:extLst>
           </p:cNvPr>
@@ -2095,7 +2095,7 @@
           <p:cNvPr id="5" name="">
             <a:extLst xmlns:a="http://schemas.openxmlformats.org/drawingml/2006/main">
               <a:ext uri="{FF2B5EF4-FFF2-40B4-BE49-F238E27FC236}">
-                <a16:creationId xmlns:a16="http://schemas.microsoft.com/office/drawing/2014/main" id="{FD2DF90D-704A-429A-9CD6-6CDCA43DB961}"/>
+                <a16:creationId xmlns:a16="http://schemas.microsoft.com/office/drawing/2014/main" id="{E53CF2A9-C295-41FB-A740-76DDF73E84FE}"/>
               </a:ext>
             </a:extLst>
           </p:cNvPr>
@@ -2128,7 +2128,7 @@
           <p:cNvPr id="6" name="">
             <a:extLst xmlns:a="http://schemas.openxmlformats.org/drawingml/2006/main">
               <a:ext uri="{FF2B5EF4-FFF2-40B4-BE49-F238E27FC236}">
-                <a16:creationId xmlns:a16="http://schemas.microsoft.com/office/drawing/2014/main" id="{2E56B8FE-86FB-466D-A08C-D5BDB27CD4E2}"/>
+                <a16:creationId xmlns:a16="http://schemas.microsoft.com/office/drawing/2014/main" id="{006C7D95-9F1E-40F4-BC85-B26E460AA3FF}"/>
               </a:ext>
             </a:extLst>
           </p:cNvPr>
@@ -2178,7 +2178,7 @@
           <p:cNvPr id="7" name="">
             <a:extLst xmlns:a="http://schemas.openxmlformats.org/drawingml/2006/main">
               <a:ext uri="{FF2B5EF4-FFF2-40B4-BE49-F238E27FC236}">
-                <a16:creationId xmlns:a16="http://schemas.microsoft.com/office/drawing/2014/main" id="{F641E98D-48A5-45A8-85A8-D72FFB793C20}"/>
+                <a16:creationId xmlns:a16="http://schemas.microsoft.com/office/drawing/2014/main" id="{45815AD4-9EF2-46FA-B029-C690ECE61DEC}"/>
               </a:ext>
             </a:extLst>
           </p:cNvPr>
@@ -2211,7 +2211,7 @@
           <p:cNvPr id="8" name="">
             <a:extLst xmlns:a="http://schemas.openxmlformats.org/drawingml/2006/main">
               <a:ext uri="{FF2B5EF4-FFF2-40B4-BE49-F238E27FC236}">
-                <a16:creationId xmlns:a16="http://schemas.microsoft.com/office/drawing/2014/main" id="{F0448D47-700A-4B40-80B0-2F44A8664C8B}"/>
+                <a16:creationId xmlns:a16="http://schemas.microsoft.com/office/drawing/2014/main" id="{7AB0E1EE-DB39-4AD2-BDC8-622A760F9B9A}"/>
               </a:ext>
             </a:extLst>
           </p:cNvPr>
@@ -2261,7 +2261,7 @@
           <p:cNvPr id="9" name="">
             <a:extLst xmlns:a="http://schemas.openxmlformats.org/drawingml/2006/main">
               <a:ext uri="{FF2B5EF4-FFF2-40B4-BE49-F238E27FC236}">
-                <a16:creationId xmlns:a16="http://schemas.microsoft.com/office/drawing/2014/main" id="{48386C70-386A-418D-A185-32C6FAE4A4C7}"/>
+                <a16:creationId xmlns:a16="http://schemas.microsoft.com/office/drawing/2014/main" id="{E0C97EC9-7E77-487D-8E12-A4045FBBA12D}"/>
               </a:ext>
             </a:extLst>
           </p:cNvPr>
@@ -2294,7 +2294,7 @@
           <p:cNvPr id="10" name="">
             <a:extLst xmlns:a="http://schemas.openxmlformats.org/drawingml/2006/main">
               <a:ext uri="{FF2B5EF4-FFF2-40B4-BE49-F238E27FC236}">
-                <a16:creationId xmlns:a16="http://schemas.microsoft.com/office/drawing/2014/main" id="{6D8CA728-C738-400C-9135-98114DA4A876}"/>
+                <a16:creationId xmlns:a16="http://schemas.microsoft.com/office/drawing/2014/main" id="{A82CAA8C-8108-4001-81D3-FFE03E46040E}"/>
               </a:ext>
             </a:extLst>
           </p:cNvPr>
@@ -2344,7 +2344,7 @@
           <p:cNvPr id="11" name="">
             <a:extLst xmlns:a="http://schemas.openxmlformats.org/drawingml/2006/main">
               <a:ext uri="{FF2B5EF4-FFF2-40B4-BE49-F238E27FC236}">
-                <a16:creationId xmlns:a16="http://schemas.microsoft.com/office/drawing/2014/main" id="{03BA2794-E3C6-4DA5-99B2-945B1A8A17C2}"/>
+                <a16:creationId xmlns:a16="http://schemas.microsoft.com/office/drawing/2014/main" id="{9C2EE1CE-606E-4260-BCE4-0E4CEB58AB76}"/>
               </a:ext>
             </a:extLst>
           </p:cNvPr>
@@ -2379,7 +2379,7 @@
           <p:cNvPr id="12" name="">
             <a:extLst xmlns:a="http://schemas.openxmlformats.org/drawingml/2006/main">
               <a:ext uri="{FF2B5EF4-FFF2-40B4-BE49-F238E27FC236}">
-                <a16:creationId xmlns:a16="http://schemas.microsoft.com/office/drawing/2014/main" id="{1AA5D36D-5C39-49BA-BA0E-15BF42C1A42F}"/>
+                <a16:creationId xmlns:a16="http://schemas.microsoft.com/office/drawing/2014/main" id="{310F218B-8611-456A-82CD-00ED783902CA}"/>
               </a:ext>
             </a:extLst>
           </p:cNvPr>
@@ -2429,7 +2429,7 @@
           <p:cNvPr id="13" name="">
             <a:extLst xmlns:a="http://schemas.openxmlformats.org/drawingml/2006/main">
               <a:ext uri="{FF2B5EF4-FFF2-40B4-BE49-F238E27FC236}">
-                <a16:creationId xmlns:a16="http://schemas.microsoft.com/office/drawing/2014/main" id="{1E0B37BA-850F-43FC-8A31-5E7321BFDBEE}"/>
+                <a16:creationId xmlns:a16="http://schemas.microsoft.com/office/drawing/2014/main" id="{27DF5B6D-7164-4EBC-A6F1-F89538049EF1}"/>
               </a:ext>
             </a:extLst>
           </p:cNvPr>
@@ -2477,7 +2477,7 @@
     </p:spTree>
     <p:extLst>
       <p:ext uri="{BB962C8B-B14F-4D97-AF65-F5344CB8AC3E}">
-        <p14:creationId xmlns:p14="http://schemas.microsoft.com/office/powerpoint/2010/main" val="1402310994"/>
+        <p14:creationId xmlns:p14="http://schemas.microsoft.com/office/powerpoint/2010/main" val="120727610"/>
       </p:ext>
     </p:extLst>
   </p:cSld>
@@ -2508,7 +2508,7 @@
           <p:cNvPr id="1" name="">
             <a:extLst xmlns:a="http://schemas.openxmlformats.org/drawingml/2006/main">
               <a:ext uri="{FF2B5EF4-FFF2-40B4-BE49-F238E27FC236}">
-                <a16:creationId xmlns:a16="http://schemas.microsoft.com/office/drawing/2014/main" id="{7F39ABD9-8CE7-472E-A484-A7A0399F56D3}"/>
+                <a16:creationId xmlns:a16="http://schemas.microsoft.com/office/drawing/2014/main" id="{A73DE0D5-E5E5-47DB-9F83-49318E096AFB}"/>
               </a:ext>
             </a:extLst>
           </p:cNvPr>
@@ -2558,7 +2558,7 @@
           <p:cNvPr id="2" name="">
             <a:extLst xmlns:a="http://schemas.openxmlformats.org/drawingml/2006/main">
               <a:ext uri="{FF2B5EF4-FFF2-40B4-BE49-F238E27FC236}">
-                <a16:creationId xmlns:a16="http://schemas.microsoft.com/office/drawing/2014/main" id="{E3A4750F-F66B-44EB-B314-981F9A8FBA2A}"/>
+                <a16:creationId xmlns:a16="http://schemas.microsoft.com/office/drawing/2014/main" id="{54E5B465-C91F-40B3-961C-0AFBD713A8F9}"/>
               </a:ext>
             </a:extLst>
           </p:cNvPr>
@@ -2608,7 +2608,7 @@
           <p:cNvPr id="3" name="">
             <a:extLst xmlns:a="http://schemas.openxmlformats.org/drawingml/2006/main">
               <a:ext uri="{FF2B5EF4-FFF2-40B4-BE49-F238E27FC236}">
-                <a16:creationId xmlns:a16="http://schemas.microsoft.com/office/drawing/2014/main" id="{343ABEAE-4080-42E5-A85B-373B0740A581}"/>
+                <a16:creationId xmlns:a16="http://schemas.microsoft.com/office/drawing/2014/main" id="{419A6E26-169E-4EE0-9E21-13D30998609A}"/>
               </a:ext>
             </a:extLst>
           </p:cNvPr>
@@ -2641,7 +2641,7 @@
           <p:cNvPr id="4" name="">
             <a:extLst xmlns:a="http://schemas.openxmlformats.org/drawingml/2006/main">
               <a:ext uri="{FF2B5EF4-FFF2-40B4-BE49-F238E27FC236}">
-                <a16:creationId xmlns:a16="http://schemas.microsoft.com/office/drawing/2014/main" id="{761655E5-A0C5-4C73-BEF8-67C45A54EC43}"/>
+                <a16:creationId xmlns:a16="http://schemas.microsoft.com/office/drawing/2014/main" id="{13C86033-0B45-4BCB-955B-11AA6AC89151}"/>
               </a:ext>
             </a:extLst>
           </p:cNvPr>
@@ -2691,7 +2691,7 @@
           <p:cNvPr id="5" name="">
             <a:extLst xmlns:a="http://schemas.openxmlformats.org/drawingml/2006/main">
               <a:ext uri="{FF2B5EF4-FFF2-40B4-BE49-F238E27FC236}">
-                <a16:creationId xmlns:a16="http://schemas.microsoft.com/office/drawing/2014/main" id="{86C80CD8-DD21-4954-AA5A-7EC89AB04517}"/>
+                <a16:creationId xmlns:a16="http://schemas.microsoft.com/office/drawing/2014/main" id="{E6EA200A-61EA-4F38-8C96-D6C861F9FF2C}"/>
               </a:ext>
             </a:extLst>
           </p:cNvPr>
@@ -2726,7 +2726,7 @@
           <p:cNvPr id="6" name="">
             <a:extLst xmlns:a="http://schemas.openxmlformats.org/drawingml/2006/main">
               <a:ext uri="{FF2B5EF4-FFF2-40B4-BE49-F238E27FC236}">
-                <a16:creationId xmlns:a16="http://schemas.microsoft.com/office/drawing/2014/main" id="{31B1863E-4F5C-4A37-92F3-1CD88349FD65}"/>
+                <a16:creationId xmlns:a16="http://schemas.microsoft.com/office/drawing/2014/main" id="{DE37EC8B-FDC7-4E34-AD9B-2A37C35758B5}"/>
               </a:ext>
             </a:extLst>
           </p:cNvPr>
@@ -2776,7 +2776,7 @@
           <p:cNvPr id="7" name="">
             <a:extLst xmlns:a="http://schemas.openxmlformats.org/drawingml/2006/main">
               <a:ext uri="{FF2B5EF4-FFF2-40B4-BE49-F238E27FC236}">
-                <a16:creationId xmlns:a16="http://schemas.microsoft.com/office/drawing/2014/main" id="{F120C712-A85B-41FE-A23E-CBAFB1ED2839}"/>
+                <a16:creationId xmlns:a16="http://schemas.microsoft.com/office/drawing/2014/main" id="{E08A1975-0419-4157-B96E-C456336E1B43}"/>
               </a:ext>
             </a:extLst>
           </p:cNvPr>
@@ -2826,7 +2826,7 @@
           <p:cNvPr id="8" name="">
             <a:extLst xmlns:a="http://schemas.openxmlformats.org/drawingml/2006/main">
               <a:ext uri="{FF2B5EF4-FFF2-40B4-BE49-F238E27FC236}">
-                <a16:creationId xmlns:a16="http://schemas.microsoft.com/office/drawing/2014/main" id="{4A0C7133-FC55-447B-9365-E180A6C95DE4}"/>
+                <a16:creationId xmlns:a16="http://schemas.microsoft.com/office/drawing/2014/main" id="{57B123C1-5568-4925-93A6-A8EA67B26372}"/>
               </a:ext>
             </a:extLst>
           </p:cNvPr>
@@ -2861,7 +2861,7 @@
           <p:cNvPr id="9" name="">
             <a:extLst xmlns:a="http://schemas.openxmlformats.org/drawingml/2006/main">
               <a:ext uri="{FF2B5EF4-FFF2-40B4-BE49-F238E27FC236}">
-                <a16:creationId xmlns:a16="http://schemas.microsoft.com/office/drawing/2014/main" id="{C3B48075-D734-445E-B2A3-737D19E9F5FB}"/>
+                <a16:creationId xmlns:a16="http://schemas.microsoft.com/office/drawing/2014/main" id="{97AE738F-C87D-448B-8F88-5C5AB097D6D0}"/>
               </a:ext>
             </a:extLst>
           </p:cNvPr>
@@ -2911,7 +2911,7 @@
           <p:cNvPr id="10" name="">
             <a:extLst xmlns:a="http://schemas.openxmlformats.org/drawingml/2006/main">
               <a:ext uri="{FF2B5EF4-FFF2-40B4-BE49-F238E27FC236}">
-                <a16:creationId xmlns:a16="http://schemas.microsoft.com/office/drawing/2014/main" id="{21BAACFF-4902-44A4-88FF-3AE074793712}"/>
+                <a16:creationId xmlns:a16="http://schemas.microsoft.com/office/drawing/2014/main" id="{5F2FB0A4-99D0-4CAE-8021-1B312DE6AAA8}"/>
               </a:ext>
             </a:extLst>
           </p:cNvPr>
@@ -2961,7 +2961,7 @@
           <p:cNvPr id="11" name="">
             <a:extLst xmlns:a="http://schemas.openxmlformats.org/drawingml/2006/main">
               <a:ext uri="{FF2B5EF4-FFF2-40B4-BE49-F238E27FC236}">
-                <a16:creationId xmlns:a16="http://schemas.microsoft.com/office/drawing/2014/main" id="{DB838A53-7DC3-4DE7-86EA-EE571E163A8D}"/>
+                <a16:creationId xmlns:a16="http://schemas.microsoft.com/office/drawing/2014/main" id="{506110A8-BB78-4BD5-B593-21AEF77FC1B3}"/>
               </a:ext>
             </a:extLst>
           </p:cNvPr>
@@ -2996,7 +2996,7 @@
           <p:cNvPr id="12" name="">
             <a:extLst xmlns:a="http://schemas.openxmlformats.org/drawingml/2006/main">
               <a:ext uri="{FF2B5EF4-FFF2-40B4-BE49-F238E27FC236}">
-                <a16:creationId xmlns:a16="http://schemas.microsoft.com/office/drawing/2014/main" id="{CAE26D68-745C-4F14-B201-C0FCE8A7F6D9}"/>
+                <a16:creationId xmlns:a16="http://schemas.microsoft.com/office/drawing/2014/main" id="{29C8FACA-5702-4347-BF69-E007682F474B}"/>
               </a:ext>
             </a:extLst>
           </p:cNvPr>
@@ -3046,7 +3046,7 @@
           <p:cNvPr id="13" name="">
             <a:extLst xmlns:a="http://schemas.openxmlformats.org/drawingml/2006/main">
               <a:ext uri="{FF2B5EF4-FFF2-40B4-BE49-F238E27FC236}">
-                <a16:creationId xmlns:a16="http://schemas.microsoft.com/office/drawing/2014/main" id="{162ECFEC-8B93-44CE-BB12-57EFF1AB3A1E}"/>
+                <a16:creationId xmlns:a16="http://schemas.microsoft.com/office/drawing/2014/main" id="{13B4280F-135E-4E65-8DE3-39BFE7F0BCDF}"/>
               </a:ext>
             </a:extLst>
           </p:cNvPr>
@@ -3096,7 +3096,7 @@
           <p:cNvPr id="14" name="">
             <a:extLst xmlns:a="http://schemas.openxmlformats.org/drawingml/2006/main">
               <a:ext uri="{FF2B5EF4-FFF2-40B4-BE49-F238E27FC236}">
-                <a16:creationId xmlns:a16="http://schemas.microsoft.com/office/drawing/2014/main" id="{8423CFA2-9574-461C-9F3B-6E33126C4278}"/>
+                <a16:creationId xmlns:a16="http://schemas.microsoft.com/office/drawing/2014/main" id="{FE944767-27FE-4CBD-A23A-40888D5C6A23}"/>
               </a:ext>
             </a:extLst>
           </p:cNvPr>
@@ -3131,7 +3131,7 @@
           <p:cNvPr id="15" name="">
             <a:extLst xmlns:a="http://schemas.openxmlformats.org/drawingml/2006/main">
               <a:ext uri="{FF2B5EF4-FFF2-40B4-BE49-F238E27FC236}">
-                <a16:creationId xmlns:a16="http://schemas.microsoft.com/office/drawing/2014/main" id="{AC4CAF55-E99A-49E4-A48F-BD84289CE966}"/>
+                <a16:creationId xmlns:a16="http://schemas.microsoft.com/office/drawing/2014/main" id="{117934AC-9D1D-4399-9892-98B4C75ECBE1}"/>
               </a:ext>
             </a:extLst>
           </p:cNvPr>
@@ -3181,7 +3181,7 @@
           <p:cNvPr id="16" name="">
             <a:extLst xmlns:a="http://schemas.openxmlformats.org/drawingml/2006/main">
               <a:ext uri="{FF2B5EF4-FFF2-40B4-BE49-F238E27FC236}">
-                <a16:creationId xmlns:a16="http://schemas.microsoft.com/office/drawing/2014/main" id="{363BB1A2-B27D-4BCB-BA6C-81260842285D}"/>
+                <a16:creationId xmlns:a16="http://schemas.microsoft.com/office/drawing/2014/main" id="{B8D5645F-F210-439E-BDF5-44237E6AD2D7}"/>
               </a:ext>
             </a:extLst>
           </p:cNvPr>
@@ -3231,7 +3231,7 @@
           <p:cNvPr id="17" name="">
             <a:extLst xmlns:a="http://schemas.openxmlformats.org/drawingml/2006/main">
               <a:ext uri="{FF2B5EF4-FFF2-40B4-BE49-F238E27FC236}">
-                <a16:creationId xmlns:a16="http://schemas.microsoft.com/office/drawing/2014/main" id="{E5C1D44E-0371-4602-AF27-C3D2FB93CE7B}"/>
+                <a16:creationId xmlns:a16="http://schemas.microsoft.com/office/drawing/2014/main" id="{D0BE854D-80C3-4D4E-AA80-82979142C3C9}"/>
               </a:ext>
             </a:extLst>
           </p:cNvPr>
@@ -3279,7 +3279,7 @@
     </p:spTree>
     <p:extLst>
       <p:ext uri="{BB962C8B-B14F-4D97-AF65-F5344CB8AC3E}">
-        <p14:creationId xmlns:p14="http://schemas.microsoft.com/office/powerpoint/2010/main" val="1209503703"/>
+        <p14:creationId xmlns:p14="http://schemas.microsoft.com/office/powerpoint/2010/main" val="1867490651"/>
       </p:ext>
     </p:extLst>
   </p:cSld>
@@ -3310,7 +3310,7 @@
           <p:cNvPr id="1" name="">
             <a:extLst xmlns:a="http://schemas.openxmlformats.org/drawingml/2006/main">
               <a:ext uri="{FF2B5EF4-FFF2-40B4-BE49-F238E27FC236}">
-                <a16:creationId xmlns:a16="http://schemas.microsoft.com/office/drawing/2014/main" id="{16DB44A9-36AE-41B8-9722-96D542A986DD}"/>
+                <a16:creationId xmlns:a16="http://schemas.microsoft.com/office/drawing/2014/main" id="{6718F1A0-2858-45AE-943A-A648D05B8398}"/>
               </a:ext>
             </a:extLst>
           </p:cNvPr>
@@ -3360,7 +3360,7 @@
           <p:cNvPr id="2" name="">
             <a:extLst xmlns:a="http://schemas.openxmlformats.org/drawingml/2006/main">
               <a:ext uri="{FF2B5EF4-FFF2-40B4-BE49-F238E27FC236}">
-                <a16:creationId xmlns:a16="http://schemas.microsoft.com/office/drawing/2014/main" id="{4B0C61E4-BF85-4278-B6F4-215E90FD5FCB}"/>
+                <a16:creationId xmlns:a16="http://schemas.microsoft.com/office/drawing/2014/main" id="{4D0350EF-01DD-423D-AC23-D6DFAC6EB27C}"/>
               </a:ext>
             </a:extLst>
           </p:cNvPr>
@@ -3410,7 +3410,7 @@
           <p:cNvPr id="3" name="">
             <a:extLst xmlns:a="http://schemas.openxmlformats.org/drawingml/2006/main">
               <a:ext uri="{FF2B5EF4-FFF2-40B4-BE49-F238E27FC236}">
-                <a16:creationId xmlns:a16="http://schemas.microsoft.com/office/drawing/2014/main" id="{4C89EC4C-7314-47BD-A00B-1D74FF2864C3}"/>
+                <a16:creationId xmlns:a16="http://schemas.microsoft.com/office/drawing/2014/main" id="{FF1D80AF-DC6F-4397-9E15-94F132034C8A}"/>
               </a:ext>
             </a:extLst>
           </p:cNvPr>
@@ -3443,7 +3443,7 @@
           <p:cNvPr id="4" name="">
             <a:extLst xmlns:a="http://schemas.openxmlformats.org/drawingml/2006/main">
               <a:ext uri="{FF2B5EF4-FFF2-40B4-BE49-F238E27FC236}">
-                <a16:creationId xmlns:a16="http://schemas.microsoft.com/office/drawing/2014/main" id="{AB4D628A-0262-4197-995C-ED3C8306A12C}"/>
+                <a16:creationId xmlns:a16="http://schemas.microsoft.com/office/drawing/2014/main" id="{20613FDB-7D7E-4065-9AF7-5F94EAF08FAA}"/>
               </a:ext>
             </a:extLst>
           </p:cNvPr>
@@ -3493,7 +3493,7 @@
           <p:cNvPr id="5" name="">
             <a:extLst xmlns:a="http://schemas.openxmlformats.org/drawingml/2006/main">
               <a:ext uri="{FF2B5EF4-FFF2-40B4-BE49-F238E27FC236}">
-                <a16:creationId xmlns:a16="http://schemas.microsoft.com/office/drawing/2014/main" id="{B44210FC-E62E-4411-94AA-EA939646BB4F}"/>
+                <a16:creationId xmlns:a16="http://schemas.microsoft.com/office/drawing/2014/main" id="{EFF7E1FA-319A-4C09-BE5B-A5B7D47AFAB3}"/>
               </a:ext>
             </a:extLst>
           </p:cNvPr>
@@ -3547,7 +3547,7 @@
           <p:nvPr/>
         </p:nvPicPr>
         <p:blipFill>
-          <a:blip xmlns:r="http://schemas.openxmlformats.org/officeDocument/2006/relationships" xmlns:a="http://schemas.openxmlformats.org/drawingml/2006/main" r:embed="R7ca6f643e8f44453"/>
+          <a:blip xmlns:r="http://schemas.openxmlformats.org/officeDocument/2006/relationships" xmlns:a="http://schemas.openxmlformats.org/drawingml/2006/main" r:embed="Recd881f288af4915"/>
           <a:srcRect xmlns:a="http://schemas.openxmlformats.org/drawingml/2006/main" l="0" t="13" r="0" b="13"/>
           <a:stretch xmlns:a="http://schemas.openxmlformats.org/drawingml/2006/main">
             <a:fillRect l="0" t="0" r="0" b="0"/>
@@ -3568,7 +3568,7 @@
     </p:spTree>
     <p:extLst>
       <p:ext uri="{BB962C8B-B14F-4D97-AF65-F5344CB8AC3E}">
-        <p14:creationId xmlns:p14="http://schemas.microsoft.com/office/powerpoint/2010/main" val="56569649"/>
+        <p14:creationId xmlns:p14="http://schemas.microsoft.com/office/powerpoint/2010/main" val="2001637949"/>
       </p:ext>
     </p:extLst>
   </p:cSld>
@@ -3599,7 +3599,7 @@
           <p:cNvPr id="1" name="">
             <a:extLst xmlns:a="http://schemas.openxmlformats.org/drawingml/2006/main">
               <a:ext uri="{FF2B5EF4-FFF2-40B4-BE49-F238E27FC236}">
-                <a16:creationId xmlns:a16="http://schemas.microsoft.com/office/drawing/2014/main" id="{D736CA7F-82F3-448A-8204-4F45A9B59852}"/>
+                <a16:creationId xmlns:a16="http://schemas.microsoft.com/office/drawing/2014/main" id="{EDD9E26D-D731-43A5-8874-B5EED1951B7C}"/>
               </a:ext>
             </a:extLst>
           </p:cNvPr>
@@ -3649,7 +3649,7 @@
           <p:cNvPr id="2" name="">
             <a:extLst xmlns:a="http://schemas.openxmlformats.org/drawingml/2006/main">
               <a:ext uri="{FF2B5EF4-FFF2-40B4-BE49-F238E27FC236}">
-                <a16:creationId xmlns:a16="http://schemas.microsoft.com/office/drawing/2014/main" id="{598338D5-886C-44E5-B4A8-F9355880C9B8}"/>
+                <a16:creationId xmlns:a16="http://schemas.microsoft.com/office/drawing/2014/main" id="{0088F616-48EB-4835-90CF-C16D48A10365}"/>
               </a:ext>
             </a:extLst>
           </p:cNvPr>
@@ -3699,7 +3699,7 @@
           <p:cNvPr id="3" name="">
             <a:extLst xmlns:a="http://schemas.openxmlformats.org/drawingml/2006/main">
               <a:ext uri="{FF2B5EF4-FFF2-40B4-BE49-F238E27FC236}">
-                <a16:creationId xmlns:a16="http://schemas.microsoft.com/office/drawing/2014/main" id="{6A4E7A3F-7593-4DA7-B44D-147DCBD9A05C}"/>
+                <a16:creationId xmlns:a16="http://schemas.microsoft.com/office/drawing/2014/main" id="{E7ECED8B-A73F-4CED-B5F0-31229D8E4D45}"/>
               </a:ext>
             </a:extLst>
           </p:cNvPr>
@@ -3732,7 +3732,7 @@
           <p:cNvPr id="4" name="">
             <a:extLst xmlns:a="http://schemas.openxmlformats.org/drawingml/2006/main">
               <a:ext uri="{FF2B5EF4-FFF2-40B4-BE49-F238E27FC236}">
-                <a16:creationId xmlns:a16="http://schemas.microsoft.com/office/drawing/2014/main" id="{750BC4AA-2EED-42CF-86F2-FFEE07C38A4D}"/>
+                <a16:creationId xmlns:a16="http://schemas.microsoft.com/office/drawing/2014/main" id="{5769ADB6-02CA-44D7-89EC-6EBC48DE37E0}"/>
               </a:ext>
             </a:extLst>
           </p:cNvPr>
@@ -3786,7 +3786,7 @@
           <p:nvPr/>
         </p:nvPicPr>
         <p:blipFill>
-          <a:blip xmlns:r="http://schemas.openxmlformats.org/officeDocument/2006/relationships" xmlns:a="http://schemas.openxmlformats.org/drawingml/2006/main" r:embed="R43085b1ae9d94880"/>
+          <a:blip xmlns:r="http://schemas.openxmlformats.org/officeDocument/2006/relationships" xmlns:a="http://schemas.openxmlformats.org/drawingml/2006/main" r:embed="R021d13ddc67344fd"/>
           <a:srcRect xmlns:a="http://schemas.openxmlformats.org/drawingml/2006/main" l="0" t="145" r="0" b="145"/>
           <a:stretch xmlns:a="http://schemas.openxmlformats.org/drawingml/2006/main">
             <a:fillRect l="0" t="0" r="0" b="0"/>
@@ -3809,7 +3809,7 @@
           <p:cNvPr id="6" name="">
             <a:extLst xmlns:a="http://schemas.openxmlformats.org/drawingml/2006/main">
               <a:ext uri="{FF2B5EF4-FFF2-40B4-BE49-F238E27FC236}">
-                <a16:creationId xmlns:a16="http://schemas.microsoft.com/office/drawing/2014/main" id="{A6565748-85A0-410A-B5AC-7A057A841594}"/>
+                <a16:creationId xmlns:a16="http://schemas.microsoft.com/office/drawing/2014/main" id="{BFBE4531-48C5-4612-B7E4-7390AB032930}"/>
               </a:ext>
             </a:extLst>
           </p:cNvPr>
@@ -3842,7 +3842,7 @@
           <p:cNvPr id="7" name="">
             <a:extLst xmlns:a="http://schemas.openxmlformats.org/drawingml/2006/main">
               <a:ext uri="{FF2B5EF4-FFF2-40B4-BE49-F238E27FC236}">
-                <a16:creationId xmlns:a16="http://schemas.microsoft.com/office/drawing/2014/main" id="{B95F0B7D-9A43-4081-B1CF-5452995E4CEF}"/>
+                <a16:creationId xmlns:a16="http://schemas.microsoft.com/office/drawing/2014/main" id="{F2E09893-8C43-4670-B9A7-038C21DA0765}"/>
               </a:ext>
             </a:extLst>
           </p:cNvPr>
@@ -3892,7 +3892,7 @@
           <p:cNvPr id="8" name="">
             <a:extLst xmlns:a="http://schemas.openxmlformats.org/drawingml/2006/main">
               <a:ext uri="{FF2B5EF4-FFF2-40B4-BE49-F238E27FC236}">
-                <a16:creationId xmlns:a16="http://schemas.microsoft.com/office/drawing/2014/main" id="{3F2685FA-7EA0-4632-AE5B-73952EA1E37D}"/>
+                <a16:creationId xmlns:a16="http://schemas.microsoft.com/office/drawing/2014/main" id="{C78DDB2F-5815-40E9-968E-4AB018B681A9}"/>
               </a:ext>
             </a:extLst>
           </p:cNvPr>
@@ -3925,7 +3925,7 @@
           <p:cNvPr id="9" name="">
             <a:extLst xmlns:a="http://schemas.openxmlformats.org/drawingml/2006/main">
               <a:ext uri="{FF2B5EF4-FFF2-40B4-BE49-F238E27FC236}">
-                <a16:creationId xmlns:a16="http://schemas.microsoft.com/office/drawing/2014/main" id="{4C5C79B3-4062-4C54-A448-0016A7A8224C}"/>
+                <a16:creationId xmlns:a16="http://schemas.microsoft.com/office/drawing/2014/main" id="{6848438E-8D15-4EBE-866D-05A8403FD961}"/>
               </a:ext>
             </a:extLst>
           </p:cNvPr>
@@ -3975,7 +3975,7 @@
           <p:cNvPr id="10" name="">
             <a:extLst xmlns:a="http://schemas.openxmlformats.org/drawingml/2006/main">
               <a:ext uri="{FF2B5EF4-FFF2-40B4-BE49-F238E27FC236}">
-                <a16:creationId xmlns:a16="http://schemas.microsoft.com/office/drawing/2014/main" id="{23A15AD7-A0A2-430F-A819-B0F7EA7F288A}"/>
+                <a16:creationId xmlns:a16="http://schemas.microsoft.com/office/drawing/2014/main" id="{808E46AF-07EB-4B3B-B58B-7A12B20974F2}"/>
               </a:ext>
             </a:extLst>
           </p:cNvPr>
@@ -4008,7 +4008,7 @@
           <p:cNvPr id="11" name="">
             <a:extLst xmlns:a="http://schemas.openxmlformats.org/drawingml/2006/main">
               <a:ext uri="{FF2B5EF4-FFF2-40B4-BE49-F238E27FC236}">
-                <a16:creationId xmlns:a16="http://schemas.microsoft.com/office/drawing/2014/main" id="{E7E25DCE-FE07-4E4B-81EE-C43A9353CFAE}"/>
+                <a16:creationId xmlns:a16="http://schemas.microsoft.com/office/drawing/2014/main" id="{D82944D3-34DC-428D-9ED2-F0CD9BEB1611}"/>
               </a:ext>
             </a:extLst>
           </p:cNvPr>
@@ -4058,7 +4058,7 @@
           <p:cNvPr id="12" name="">
             <a:extLst xmlns:a="http://schemas.openxmlformats.org/drawingml/2006/main">
               <a:ext uri="{FF2B5EF4-FFF2-40B4-BE49-F238E27FC236}">
-                <a16:creationId xmlns:a16="http://schemas.microsoft.com/office/drawing/2014/main" id="{37463A2C-F82E-423E-A35E-AB931EEA9A30}"/>
+                <a16:creationId xmlns:a16="http://schemas.microsoft.com/office/drawing/2014/main" id="{F9D3C84E-FBBF-46C0-916B-68536D574CBA}"/>
               </a:ext>
             </a:extLst>
           </p:cNvPr>
@@ -4091,7 +4091,7 @@
           <p:cNvPr id="13" name="">
             <a:extLst xmlns:a="http://schemas.openxmlformats.org/drawingml/2006/main">
               <a:ext uri="{FF2B5EF4-FFF2-40B4-BE49-F238E27FC236}">
-                <a16:creationId xmlns:a16="http://schemas.microsoft.com/office/drawing/2014/main" id="{B2D7763C-A2AF-478A-8374-14B168BB15AA}"/>
+                <a16:creationId xmlns:a16="http://schemas.microsoft.com/office/drawing/2014/main" id="{E0A30465-2CA9-425F-B8AB-D67EA4DF010B}"/>
               </a:ext>
             </a:extLst>
           </p:cNvPr>
@@ -4139,7 +4139,7 @@
     </p:spTree>
     <p:extLst>
       <p:ext uri="{BB962C8B-B14F-4D97-AF65-F5344CB8AC3E}">
-        <p14:creationId xmlns:p14="http://schemas.microsoft.com/office/powerpoint/2010/main" val="834305781"/>
+        <p14:creationId xmlns:p14="http://schemas.microsoft.com/office/powerpoint/2010/main" val="1612475631"/>
       </p:ext>
     </p:extLst>
   </p:cSld>
@@ -4170,7 +4170,7 @@
           <p:cNvPr id="1" name="">
             <a:extLst xmlns:a="http://schemas.openxmlformats.org/drawingml/2006/main">
               <a:ext uri="{FF2B5EF4-FFF2-40B4-BE49-F238E27FC236}">
-                <a16:creationId xmlns:a16="http://schemas.microsoft.com/office/drawing/2014/main" id="{2269FABC-0948-4A34-B978-A2B28CC9C8FC}"/>
+                <a16:creationId xmlns:a16="http://schemas.microsoft.com/office/drawing/2014/main" id="{3D0F0E20-C02F-44E3-97B4-119B9BB5BA6E}"/>
               </a:ext>
             </a:extLst>
           </p:cNvPr>
@@ -4220,7 +4220,7 @@
           <p:cNvPr id="2" name="">
             <a:extLst xmlns:a="http://schemas.openxmlformats.org/drawingml/2006/main">
               <a:ext uri="{FF2B5EF4-FFF2-40B4-BE49-F238E27FC236}">
-                <a16:creationId xmlns:a16="http://schemas.microsoft.com/office/drawing/2014/main" id="{39A728ED-582F-47F3-B452-1A1E1228DE15}"/>
+                <a16:creationId xmlns:a16="http://schemas.microsoft.com/office/drawing/2014/main" id="{457163C1-78D8-4036-80A1-006E9C6653D1}"/>
               </a:ext>
             </a:extLst>
           </p:cNvPr>
@@ -4270,7 +4270,7 @@
           <p:cNvPr id="3" name="">
             <a:extLst xmlns:a="http://schemas.openxmlformats.org/drawingml/2006/main">
               <a:ext uri="{FF2B5EF4-FFF2-40B4-BE49-F238E27FC236}">
-                <a16:creationId xmlns:a16="http://schemas.microsoft.com/office/drawing/2014/main" id="{96457BC6-D071-4BD8-B7C4-376F5CE8E89C}"/>
+                <a16:creationId xmlns:a16="http://schemas.microsoft.com/office/drawing/2014/main" id="{149F3124-B6AB-424F-B500-F9B17FC49F54}"/>
               </a:ext>
             </a:extLst>
           </p:cNvPr>
@@ -4303,7 +4303,7 @@
           <p:cNvPr id="4" name="">
             <a:extLst xmlns:a="http://schemas.openxmlformats.org/drawingml/2006/main">
               <a:ext uri="{FF2B5EF4-FFF2-40B4-BE49-F238E27FC236}">
-                <a16:creationId xmlns:a16="http://schemas.microsoft.com/office/drawing/2014/main" id="{DE85414C-B6C8-4A5D-AD50-35F56DDAE8C3}"/>
+                <a16:creationId xmlns:a16="http://schemas.microsoft.com/office/drawing/2014/main" id="{FA9577A1-3612-4B71-846F-DFBD38566AC4}"/>
               </a:ext>
             </a:extLst>
           </p:cNvPr>
@@ -4353,7 +4353,7 @@
           <p:cNvPr id="5" name="">
             <a:extLst xmlns:a="http://schemas.openxmlformats.org/drawingml/2006/main">
               <a:ext uri="{FF2B5EF4-FFF2-40B4-BE49-F238E27FC236}">
-                <a16:creationId xmlns:a16="http://schemas.microsoft.com/office/drawing/2014/main" id="{2558BCAC-AC0F-48A7-88E8-2A3BD38501F9}"/>
+                <a16:creationId xmlns:a16="http://schemas.microsoft.com/office/drawing/2014/main" id="{9FE999E8-ABA9-497D-9EFF-6338A9BF3FE4}"/>
               </a:ext>
             </a:extLst>
           </p:cNvPr>
@@ -4386,7 +4386,7 @@
           <p:cNvPr id="6" name="">
             <a:extLst xmlns:a="http://schemas.openxmlformats.org/drawingml/2006/main">
               <a:ext uri="{FF2B5EF4-FFF2-40B4-BE49-F238E27FC236}">
-                <a16:creationId xmlns:a16="http://schemas.microsoft.com/office/drawing/2014/main" id="{CAE4371F-8FF6-47B4-8C4C-39890D32920D}"/>
+                <a16:creationId xmlns:a16="http://schemas.microsoft.com/office/drawing/2014/main" id="{1D5A5085-BD87-4EFE-9317-1EE21E7D7396}"/>
               </a:ext>
             </a:extLst>
           </p:cNvPr>
@@ -4436,7 +4436,7 @@
           <p:cNvPr id="7" name="">
             <a:extLst xmlns:a="http://schemas.openxmlformats.org/drawingml/2006/main">
               <a:ext uri="{FF2B5EF4-FFF2-40B4-BE49-F238E27FC236}">
-                <a16:creationId xmlns:a16="http://schemas.microsoft.com/office/drawing/2014/main" id="{61DF2758-74C7-4F2D-8E7B-1E75EBFBE792}"/>
+                <a16:creationId xmlns:a16="http://schemas.microsoft.com/office/drawing/2014/main" id="{F173982A-3A4E-44B4-B353-10541801446F}"/>
               </a:ext>
             </a:extLst>
           </p:cNvPr>
@@ -4469,7 +4469,7 @@
           <p:cNvPr id="8" name="">
             <a:extLst xmlns:a="http://schemas.openxmlformats.org/drawingml/2006/main">
               <a:ext uri="{FF2B5EF4-FFF2-40B4-BE49-F238E27FC236}">
-                <a16:creationId xmlns:a16="http://schemas.microsoft.com/office/drawing/2014/main" id="{FFA22EF8-3144-474D-9873-060B2A62970F}"/>
+                <a16:creationId xmlns:a16="http://schemas.microsoft.com/office/drawing/2014/main" id="{2C784E0D-218B-4174-B6E7-812C51C53019}"/>
               </a:ext>
             </a:extLst>
           </p:cNvPr>
@@ -4519,7 +4519,7 @@
           <p:cNvPr id="9" name="">
             <a:extLst xmlns:a="http://schemas.openxmlformats.org/drawingml/2006/main">
               <a:ext uri="{FF2B5EF4-FFF2-40B4-BE49-F238E27FC236}">
-                <a16:creationId xmlns:a16="http://schemas.microsoft.com/office/drawing/2014/main" id="{65BF023A-8484-483E-8FBD-55CEDE16A370}"/>
+                <a16:creationId xmlns:a16="http://schemas.microsoft.com/office/drawing/2014/main" id="{96408754-D6A7-4A82-A6B6-02BCE2B6E862}"/>
               </a:ext>
             </a:extLst>
           </p:cNvPr>
@@ -4552,7 +4552,7 @@
           <p:cNvPr id="10" name="">
             <a:extLst xmlns:a="http://schemas.openxmlformats.org/drawingml/2006/main">
               <a:ext uri="{FF2B5EF4-FFF2-40B4-BE49-F238E27FC236}">
-                <a16:creationId xmlns:a16="http://schemas.microsoft.com/office/drawing/2014/main" id="{5B27EBDD-780D-40EC-BD7C-6CFDB81FF6C0}"/>
+                <a16:creationId xmlns:a16="http://schemas.microsoft.com/office/drawing/2014/main" id="{3A3E33FE-5538-4A34-B437-D1EF8A68B211}"/>
               </a:ext>
             </a:extLst>
           </p:cNvPr>
@@ -4602,7 +4602,7 @@
           <p:cNvPr id="11" name="">
             <a:extLst xmlns:a="http://schemas.openxmlformats.org/drawingml/2006/main">
               <a:ext uri="{FF2B5EF4-FFF2-40B4-BE49-F238E27FC236}">
-                <a16:creationId xmlns:a16="http://schemas.microsoft.com/office/drawing/2014/main" id="{966F62ED-8E8D-495F-9CC8-EAD5CEEF61BC}"/>
+                <a16:creationId xmlns:a16="http://schemas.microsoft.com/office/drawing/2014/main" id="{2FE679DB-9697-4311-AC36-A03A8E488634}"/>
               </a:ext>
             </a:extLst>
           </p:cNvPr>
@@ -4637,7 +4637,7 @@
           <p:cNvPr id="12" name="">
             <a:extLst xmlns:a="http://schemas.openxmlformats.org/drawingml/2006/main">
               <a:ext uri="{FF2B5EF4-FFF2-40B4-BE49-F238E27FC236}">
-                <a16:creationId xmlns:a16="http://schemas.microsoft.com/office/drawing/2014/main" id="{42A5DD72-F707-4802-9D4C-4F96772B235B}"/>
+                <a16:creationId xmlns:a16="http://schemas.microsoft.com/office/drawing/2014/main" id="{10F0946A-1F13-45E8-8012-86961CEA4A5A}"/>
               </a:ext>
             </a:extLst>
           </p:cNvPr>
@@ -4687,7 +4687,7 @@
           <p:cNvPr id="13" name="">
             <a:extLst xmlns:a="http://schemas.openxmlformats.org/drawingml/2006/main">
               <a:ext uri="{FF2B5EF4-FFF2-40B4-BE49-F238E27FC236}">
-                <a16:creationId xmlns:a16="http://schemas.microsoft.com/office/drawing/2014/main" id="{58FFCC91-DE35-44A5-A5C0-EA6A0142B388}"/>
+                <a16:creationId xmlns:a16="http://schemas.microsoft.com/office/drawing/2014/main" id="{2308AE5F-7C52-4401-8DA5-85AE5E16D136}"/>
               </a:ext>
             </a:extLst>
           </p:cNvPr>
@@ -4735,7 +4735,7 @@
     </p:spTree>
     <p:extLst>
       <p:ext uri="{BB962C8B-B14F-4D97-AF65-F5344CB8AC3E}">
-        <p14:creationId xmlns:p14="http://schemas.microsoft.com/office/powerpoint/2010/main" val="985763343"/>
+        <p14:creationId xmlns:p14="http://schemas.microsoft.com/office/powerpoint/2010/main" val="2058574810"/>
       </p:ext>
     </p:extLst>
   </p:cSld>
@@ -4766,7 +4766,7 @@
           <p:cNvPr id="1" name="">
             <a:extLst xmlns:a="http://schemas.openxmlformats.org/drawingml/2006/main">
               <a:ext uri="{FF2B5EF4-FFF2-40B4-BE49-F238E27FC236}">
-                <a16:creationId xmlns:a16="http://schemas.microsoft.com/office/drawing/2014/main" id="{843BE1FF-36FF-46AC-A0B6-61C98A257501}"/>
+                <a16:creationId xmlns:a16="http://schemas.microsoft.com/office/drawing/2014/main" id="{50B5CB4B-2E07-40FE-B549-467D315E2C94}"/>
               </a:ext>
             </a:extLst>
           </p:cNvPr>
@@ -4816,7 +4816,7 @@
           <p:cNvPr id="2" name="">
             <a:extLst xmlns:a="http://schemas.openxmlformats.org/drawingml/2006/main">
               <a:ext uri="{FF2B5EF4-FFF2-40B4-BE49-F238E27FC236}">
-                <a16:creationId xmlns:a16="http://schemas.microsoft.com/office/drawing/2014/main" id="{3971D77B-4529-4547-A766-31C9D569ABDC}"/>
+                <a16:creationId xmlns:a16="http://schemas.microsoft.com/office/drawing/2014/main" id="{96B5C4F5-41F9-4AFD-A608-5C58D19D3DCD}"/>
               </a:ext>
             </a:extLst>
           </p:cNvPr>
@@ -4866,7 +4866,7 @@
           <p:cNvPr id="3" name="">
             <a:extLst xmlns:a="http://schemas.openxmlformats.org/drawingml/2006/main">
               <a:ext uri="{FF2B5EF4-FFF2-40B4-BE49-F238E27FC236}">
-                <a16:creationId xmlns:a16="http://schemas.microsoft.com/office/drawing/2014/main" id="{B4D1C4EF-CF9E-464D-9AD5-E7D63EBB0847}"/>
+                <a16:creationId xmlns:a16="http://schemas.microsoft.com/office/drawing/2014/main" id="{11D87E1E-D5D6-457C-9136-74F3B06C92F7}"/>
               </a:ext>
             </a:extLst>
           </p:cNvPr>
@@ -4899,7 +4899,7 @@
           <p:cNvPr id="4" name="">
             <a:extLst xmlns:a="http://schemas.openxmlformats.org/drawingml/2006/main">
               <a:ext uri="{FF2B5EF4-FFF2-40B4-BE49-F238E27FC236}">
-                <a16:creationId xmlns:a16="http://schemas.microsoft.com/office/drawing/2014/main" id="{DE9DB7B8-1DF5-4F1D-8014-73654CD19567}"/>
+                <a16:creationId xmlns:a16="http://schemas.microsoft.com/office/drawing/2014/main" id="{01B7E728-0EAE-49D6-9C89-1FDC8D7B3430}"/>
               </a:ext>
             </a:extLst>
           </p:cNvPr>
@@ -4953,7 +4953,7 @@
           <p:nvPr/>
         </p:nvPicPr>
         <p:blipFill>
-          <a:blip xmlns:r="http://schemas.openxmlformats.org/officeDocument/2006/relationships" xmlns:a="http://schemas.openxmlformats.org/drawingml/2006/main" r:embed="Rf0549d57e709457e"/>
+          <a:blip xmlns:r="http://schemas.openxmlformats.org/officeDocument/2006/relationships" xmlns:a="http://schemas.openxmlformats.org/drawingml/2006/main" r:embed="R44940296fdcb49ed"/>
           <a:srcRect xmlns:a="http://schemas.openxmlformats.org/drawingml/2006/main" l="0" t="334" r="0" b="334"/>
           <a:stretch xmlns:a="http://schemas.openxmlformats.org/drawingml/2006/main">
             <a:fillRect l="0" t="0" r="0" b="0"/>
@@ -4980,7 +4980,7 @@
           <p:nvPr/>
         </p:nvPicPr>
         <p:blipFill>
-          <a:blip xmlns:r="http://schemas.openxmlformats.org/officeDocument/2006/relationships" xmlns:a="http://schemas.openxmlformats.org/drawingml/2006/main" r:embed="R57462b9d653840f9"/>
+          <a:blip xmlns:r="http://schemas.openxmlformats.org/officeDocument/2006/relationships" xmlns:a="http://schemas.openxmlformats.org/drawingml/2006/main" r:embed="R211613976f23407e"/>
           <a:srcRect xmlns:a="http://schemas.openxmlformats.org/drawingml/2006/main" l="0" t="334" r="0" b="334"/>
           <a:stretch xmlns:a="http://schemas.openxmlformats.org/drawingml/2006/main">
             <a:fillRect l="0" t="0" r="0" b="0"/>
@@ -5003,7 +5003,7 @@
           <p:cNvPr id="7" name="">
             <a:extLst xmlns:a="http://schemas.openxmlformats.org/drawingml/2006/main">
               <a:ext uri="{FF2B5EF4-FFF2-40B4-BE49-F238E27FC236}">
-                <a16:creationId xmlns:a16="http://schemas.microsoft.com/office/drawing/2014/main" id="{D560B596-7733-46BD-B271-C082F7EAC316}"/>
+                <a16:creationId xmlns:a16="http://schemas.microsoft.com/office/drawing/2014/main" id="{55954710-1B92-4A49-B226-A09D9CE98E4C}"/>
               </a:ext>
             </a:extLst>
           </p:cNvPr>
@@ -5051,7 +5051,7 @@
     </p:spTree>
     <p:extLst>
       <p:ext uri="{BB962C8B-B14F-4D97-AF65-F5344CB8AC3E}">
-        <p14:creationId xmlns:p14="http://schemas.microsoft.com/office/powerpoint/2010/main" val="352078910"/>
+        <p14:creationId xmlns:p14="http://schemas.microsoft.com/office/powerpoint/2010/main" val="1523527808"/>
       </p:ext>
     </p:extLst>
   </p:cSld>
@@ -5082,7 +5082,7 @@
           <p:cNvPr id="1" name="">
             <a:extLst xmlns:a="http://schemas.openxmlformats.org/drawingml/2006/main">
               <a:ext uri="{FF2B5EF4-FFF2-40B4-BE49-F238E27FC236}">
-                <a16:creationId xmlns:a16="http://schemas.microsoft.com/office/drawing/2014/main" id="{4857AA94-35E6-4809-BE30-873AFD5CA36D}"/>
+                <a16:creationId xmlns:a16="http://schemas.microsoft.com/office/drawing/2014/main" id="{1ED694EE-66F0-4D7D-9FA7-5D0091B17979}"/>
               </a:ext>
             </a:extLst>
           </p:cNvPr>
@@ -5132,7 +5132,7 @@
           <p:cNvPr id="2" name="">
             <a:extLst xmlns:a="http://schemas.openxmlformats.org/drawingml/2006/main">
               <a:ext uri="{FF2B5EF4-FFF2-40B4-BE49-F238E27FC236}">
-                <a16:creationId xmlns:a16="http://schemas.microsoft.com/office/drawing/2014/main" id="{39AA0CD4-28F2-4ABC-A35B-E02240199F7C}"/>
+                <a16:creationId xmlns:a16="http://schemas.microsoft.com/office/drawing/2014/main" id="{DB2FEA36-5C37-4217-935B-0DD733B15C9F}"/>
               </a:ext>
             </a:extLst>
           </p:cNvPr>
@@ -5182,7 +5182,7 @@
           <p:cNvPr id="3" name="">
             <a:extLst xmlns:a="http://schemas.openxmlformats.org/drawingml/2006/main">
               <a:ext uri="{FF2B5EF4-FFF2-40B4-BE49-F238E27FC236}">
-                <a16:creationId xmlns:a16="http://schemas.microsoft.com/office/drawing/2014/main" id="{B8AA2A87-934F-4267-828E-47A822C3B34B}"/>
+                <a16:creationId xmlns:a16="http://schemas.microsoft.com/office/drawing/2014/main" id="{40704C8C-36B0-4D7D-AF6B-5315E48CE38B}"/>
               </a:ext>
             </a:extLst>
           </p:cNvPr>
@@ -5215,7 +5215,7 @@
           <p:cNvPr id="4" name="">
             <a:extLst xmlns:a="http://schemas.openxmlformats.org/drawingml/2006/main">
               <a:ext uri="{FF2B5EF4-FFF2-40B4-BE49-F238E27FC236}">
-                <a16:creationId xmlns:a16="http://schemas.microsoft.com/office/drawing/2014/main" id="{675B665E-E9FE-45DF-8D8E-3CA2F050CF0A}"/>
+                <a16:creationId xmlns:a16="http://schemas.microsoft.com/office/drawing/2014/main" id="{B8436EDD-9FBA-4E7C-B554-E74558D254E1}"/>
               </a:ext>
             </a:extLst>
           </p:cNvPr>
@@ -5265,7 +5265,7 @@
           <p:cNvPr id="5" name="">
             <a:extLst xmlns:a="http://schemas.openxmlformats.org/drawingml/2006/main">
               <a:ext uri="{FF2B5EF4-FFF2-40B4-BE49-F238E27FC236}">
-                <a16:creationId xmlns:a16="http://schemas.microsoft.com/office/drawing/2014/main" id="{5838B8A2-8F26-4FE6-B4D3-4BB5A691FA86}"/>
+                <a16:creationId xmlns:a16="http://schemas.microsoft.com/office/drawing/2014/main" id="{DC1CA2E4-39E9-4F18-BECA-11C316F15303}"/>
               </a:ext>
             </a:extLst>
           </p:cNvPr>
@@ -5298,7 +5298,7 @@
           <p:cNvPr id="6" name="">
             <a:extLst xmlns:a="http://schemas.openxmlformats.org/drawingml/2006/main">
               <a:ext uri="{FF2B5EF4-FFF2-40B4-BE49-F238E27FC236}">
-                <a16:creationId xmlns:a16="http://schemas.microsoft.com/office/drawing/2014/main" id="{8C6C779D-E7ED-4A16-A8B6-503ED2F9EFA5}"/>
+                <a16:creationId xmlns:a16="http://schemas.microsoft.com/office/drawing/2014/main" id="{4AAE157C-125B-4D0E-B3BC-EFEC9B441894}"/>
               </a:ext>
             </a:extLst>
           </p:cNvPr>
@@ -5348,7 +5348,7 @@
           <p:cNvPr id="7" name="">
             <a:extLst xmlns:a="http://schemas.openxmlformats.org/drawingml/2006/main">
               <a:ext uri="{FF2B5EF4-FFF2-40B4-BE49-F238E27FC236}">
-                <a16:creationId xmlns:a16="http://schemas.microsoft.com/office/drawing/2014/main" id="{A5D47C41-CC6F-47BB-9430-616B36A7C986}"/>
+                <a16:creationId xmlns:a16="http://schemas.microsoft.com/office/drawing/2014/main" id="{0DAD13CC-0CEF-409F-ADE6-2E179C774F5F}"/>
               </a:ext>
             </a:extLst>
           </p:cNvPr>
@@ -5381,7 +5381,7 @@
           <p:cNvPr id="8" name="">
             <a:extLst xmlns:a="http://schemas.openxmlformats.org/drawingml/2006/main">
               <a:ext uri="{FF2B5EF4-FFF2-40B4-BE49-F238E27FC236}">
-                <a16:creationId xmlns:a16="http://schemas.microsoft.com/office/drawing/2014/main" id="{9FDF3B1B-872B-4C8B-885E-3C97F900BC59}"/>
+                <a16:creationId xmlns:a16="http://schemas.microsoft.com/office/drawing/2014/main" id="{F0D117B5-6321-4CFC-8436-A4D18C2DF76C}"/>
               </a:ext>
             </a:extLst>
           </p:cNvPr>
@@ -5431,7 +5431,7 @@
           <p:cNvPr id="9" name="">
             <a:extLst xmlns:a="http://schemas.openxmlformats.org/drawingml/2006/main">
               <a:ext uri="{FF2B5EF4-FFF2-40B4-BE49-F238E27FC236}">
-                <a16:creationId xmlns:a16="http://schemas.microsoft.com/office/drawing/2014/main" id="{F7489752-4E72-40A1-9AD2-BB2D3F2849DD}"/>
+                <a16:creationId xmlns:a16="http://schemas.microsoft.com/office/drawing/2014/main" id="{90E03D26-334F-4BF0-8C6F-96ED7CB92E01}"/>
               </a:ext>
             </a:extLst>
           </p:cNvPr>
@@ -5464,7 +5464,7 @@
           <p:cNvPr id="10" name="">
             <a:extLst xmlns:a="http://schemas.openxmlformats.org/drawingml/2006/main">
               <a:ext uri="{FF2B5EF4-FFF2-40B4-BE49-F238E27FC236}">
-                <a16:creationId xmlns:a16="http://schemas.microsoft.com/office/drawing/2014/main" id="{464F3E97-D8AC-4A7D-A95A-5CC8A6CB7F5A}"/>
+                <a16:creationId xmlns:a16="http://schemas.microsoft.com/office/drawing/2014/main" id="{56350B15-651F-4F8F-B182-24823AD579C9}"/>
               </a:ext>
             </a:extLst>
           </p:cNvPr>
@@ -5514,7 +5514,7 @@
           <p:cNvPr id="11" name="">
             <a:extLst xmlns:a="http://schemas.openxmlformats.org/drawingml/2006/main">
               <a:ext uri="{FF2B5EF4-FFF2-40B4-BE49-F238E27FC236}">
-                <a16:creationId xmlns:a16="http://schemas.microsoft.com/office/drawing/2014/main" id="{665A2F29-2F31-4116-9BB5-671140DA52E5}"/>
+                <a16:creationId xmlns:a16="http://schemas.microsoft.com/office/drawing/2014/main" id="{61800A2C-CA5D-429C-A41E-A31F16925BA6}"/>
               </a:ext>
             </a:extLst>
           </p:cNvPr>
@@ -5547,7 +5547,7 @@
           <p:cNvPr id="12" name="">
             <a:extLst xmlns:a="http://schemas.openxmlformats.org/drawingml/2006/main">
               <a:ext uri="{FF2B5EF4-FFF2-40B4-BE49-F238E27FC236}">
-                <a16:creationId xmlns:a16="http://schemas.microsoft.com/office/drawing/2014/main" id="{4BDDE8F2-40E7-4921-A9B4-FF06D7EF63BA}"/>
+                <a16:creationId xmlns:a16="http://schemas.microsoft.com/office/drawing/2014/main" id="{6EDB1524-41DB-48A0-889C-8D2DFECF9875}"/>
               </a:ext>
             </a:extLst>
           </p:cNvPr>
@@ -5597,7 +5597,7 @@
           <p:cNvPr id="13" name="">
             <a:extLst xmlns:a="http://schemas.openxmlformats.org/drawingml/2006/main">
               <a:ext uri="{FF2B5EF4-FFF2-40B4-BE49-F238E27FC236}">
-                <a16:creationId xmlns:a16="http://schemas.microsoft.com/office/drawing/2014/main" id="{665ACEA6-E1C7-4BD4-BB9A-BB8640495A75}"/>
+                <a16:creationId xmlns:a16="http://schemas.microsoft.com/office/drawing/2014/main" id="{30A4C493-526A-487D-B6A5-B09050E8D855}"/>
               </a:ext>
             </a:extLst>
           </p:cNvPr>
@@ -5632,7 +5632,7 @@
           <p:cNvPr id="14" name="">
             <a:extLst xmlns:a="http://schemas.openxmlformats.org/drawingml/2006/main">
               <a:ext uri="{FF2B5EF4-FFF2-40B4-BE49-F238E27FC236}">
-                <a16:creationId xmlns:a16="http://schemas.microsoft.com/office/drawing/2014/main" id="{DFCD1AC3-275B-4198-A265-C79CF97A0CAD}"/>
+                <a16:creationId xmlns:a16="http://schemas.microsoft.com/office/drawing/2014/main" id="{E4CBD594-2C34-4D9C-9D37-E2775EA32AFF}"/>
               </a:ext>
             </a:extLst>
           </p:cNvPr>
@@ -5680,7 +5680,7 @@
     </p:spTree>
     <p:extLst>
       <p:ext uri="{BB962C8B-B14F-4D97-AF65-F5344CB8AC3E}">
-        <p14:creationId xmlns:p14="http://schemas.microsoft.com/office/powerpoint/2010/main" val="74501716"/>
+        <p14:creationId xmlns:p14="http://schemas.microsoft.com/office/powerpoint/2010/main" val="1130644933"/>
       </p:ext>
     </p:extLst>
   </p:cSld>

</xml_diff>

<commit_message>
Simplify public demo walkthrough
</commit_message>
<xml_diff>
--- a/deliverables/SHORIR_AI_Project_Presentation.pptx
+++ b/deliverables/SHORIR_AI_Project_Presentation.pptx
@@ -2,20 +2,20 @@
 <file path=ppt/presentation.xml><?xml version="1.0" encoding="utf-8"?>
 <p:presentation xmlns:p="http://schemas.openxmlformats.org/presentationml/2006/main">
   <p:sldMasterIdLst>
-    <p:sldMasterId xmlns:r="http://schemas.openxmlformats.org/officeDocument/2006/relationships" id="2147483648" r:id="Rb74b0248f3574eab"/>
+    <p:sldMasterId xmlns:r="http://schemas.openxmlformats.org/officeDocument/2006/relationships" id="2147483648" r:id="R4140506ff0e34a1f"/>
   </p:sldMasterIdLst>
   <p:notesMasterIdLst>
-    <p:notesMasterId xmlns:r="http://schemas.openxmlformats.org/officeDocument/2006/relationships" r:id="Re55e452fd64946a7"/>
+    <p:notesMasterId xmlns:r="http://schemas.openxmlformats.org/officeDocument/2006/relationships" r:id="R65b948e3a2a74c4d"/>
   </p:notesMasterIdLst>
   <p:sldIdLst>
-    <p:sldId xmlns:r="http://schemas.openxmlformats.org/officeDocument/2006/relationships" id="256" r:id="Rb428755165b44efe"/>
-    <p:sldId xmlns:r="http://schemas.openxmlformats.org/officeDocument/2006/relationships" id="257" r:id="R83351197edc54ea0"/>
-    <p:sldId xmlns:r="http://schemas.openxmlformats.org/officeDocument/2006/relationships" id="258" r:id="R6568befb028b4fbf"/>
-    <p:sldId xmlns:r="http://schemas.openxmlformats.org/officeDocument/2006/relationships" id="259" r:id="Ree10a9a8b77b422e"/>
-    <p:sldId xmlns:r="http://schemas.openxmlformats.org/officeDocument/2006/relationships" id="260" r:id="R8dcf4e6077ec4a90"/>
-    <p:sldId xmlns:r="http://schemas.openxmlformats.org/officeDocument/2006/relationships" id="261" r:id="R3093826d7bb348e1"/>
-    <p:sldId xmlns:r="http://schemas.openxmlformats.org/officeDocument/2006/relationships" id="262" r:id="Rf5410dfa863e4144"/>
-    <p:sldId xmlns:r="http://schemas.openxmlformats.org/officeDocument/2006/relationships" id="263" r:id="Rae43e6eddc124887"/>
+    <p:sldId xmlns:r="http://schemas.openxmlformats.org/officeDocument/2006/relationships" id="256" r:id="R80144df60a0a4a57"/>
+    <p:sldId xmlns:r="http://schemas.openxmlformats.org/officeDocument/2006/relationships" id="257" r:id="R849f2bff6c7b4ee9"/>
+    <p:sldId xmlns:r="http://schemas.openxmlformats.org/officeDocument/2006/relationships" id="258" r:id="R334c9f40c1cc4348"/>
+    <p:sldId xmlns:r="http://schemas.openxmlformats.org/officeDocument/2006/relationships" id="259" r:id="R249fe59e5000402d"/>
+    <p:sldId xmlns:r="http://schemas.openxmlformats.org/officeDocument/2006/relationships" id="260" r:id="R6d9c6f271b014999"/>
+    <p:sldId xmlns:r="http://schemas.openxmlformats.org/officeDocument/2006/relationships" id="261" r:id="R28c55688216c4000"/>
+    <p:sldId xmlns:r="http://schemas.openxmlformats.org/officeDocument/2006/relationships" id="262" r:id="R68e62f34ad8c46a2"/>
+    <p:sldId xmlns:r="http://schemas.openxmlformats.org/officeDocument/2006/relationships" id="263" r:id="Rb47240e9c26643a8"/>
   </p:sldIdLst>
   <p:sldSz cx="12192000" cy="6858000"/>
   <p:notesSz cx="6858000" cy="9144000"/>
@@ -1070,7 +1070,7 @@
   </p:cSld>
   <p:clrMap bg1="lt1" tx1="dk1" bg2="lt2" tx2="dk2" accent1="accent1" accent2="accent2" accent3="accent3" accent4="accent4" accent5="accent5" accent6="accent6" hlink="hlink" folHlink="folHlink"/>
   <p:sldLayoutIdLst>
-    <p:sldLayoutId xmlns:r="http://schemas.openxmlformats.org/officeDocument/2006/relationships" id="2147483649" r:id="R112f4e4277054b45"/>
+    <p:sldLayoutId xmlns:r="http://schemas.openxmlformats.org/officeDocument/2006/relationships" id="2147483649" r:id="R693c0b0bedf84899"/>
   </p:sldLayoutIdLst>
   <p:txStyles>
     <p:titleStyle>
@@ -1621,7 +1621,7 @@
           <p:cNvPr id="1" name="">
             <a:extLst xmlns:a="http://schemas.openxmlformats.org/drawingml/2006/main">
               <a:ext uri="{FF2B5EF4-FFF2-40B4-BE49-F238E27FC236}">
-                <a16:creationId xmlns:a16="http://schemas.microsoft.com/office/drawing/2014/main" id="{A920FBB1-4110-4DBC-B9D7-6CB1AFB69E2D}"/>
+                <a16:creationId xmlns:a16="http://schemas.microsoft.com/office/drawing/2014/main" id="{3D118DFD-B70C-436D-9069-85EA3879797D}"/>
               </a:ext>
             </a:extLst>
           </p:cNvPr>
@@ -1671,7 +1671,7 @@
           <p:cNvPr id="2" name="">
             <a:extLst xmlns:a="http://schemas.openxmlformats.org/drawingml/2006/main">
               <a:ext uri="{FF2B5EF4-FFF2-40B4-BE49-F238E27FC236}">
-                <a16:creationId xmlns:a16="http://schemas.microsoft.com/office/drawing/2014/main" id="{CA8B3492-C971-48CE-8F6B-DD50B25916B4}"/>
+                <a16:creationId xmlns:a16="http://schemas.microsoft.com/office/drawing/2014/main" id="{383EAE7E-AB3B-41B7-B4FC-3E17ED3C60C7}"/>
               </a:ext>
             </a:extLst>
           </p:cNvPr>
@@ -1721,7 +1721,7 @@
           <p:cNvPr id="3" name="">
             <a:extLst xmlns:a="http://schemas.openxmlformats.org/drawingml/2006/main">
               <a:ext uri="{FF2B5EF4-FFF2-40B4-BE49-F238E27FC236}">
-                <a16:creationId xmlns:a16="http://schemas.microsoft.com/office/drawing/2014/main" id="{64D823EE-B8A5-4A46-853F-33AF35BD980C}"/>
+                <a16:creationId xmlns:a16="http://schemas.microsoft.com/office/drawing/2014/main" id="{D56D2DF0-6531-439B-A842-A3604703F337}"/>
               </a:ext>
             </a:extLst>
           </p:cNvPr>
@@ -1771,7 +1771,7 @@
           <p:cNvPr id="4" name="">
             <a:extLst xmlns:a="http://schemas.openxmlformats.org/drawingml/2006/main">
               <a:ext uri="{FF2B5EF4-FFF2-40B4-BE49-F238E27FC236}">
-                <a16:creationId xmlns:a16="http://schemas.microsoft.com/office/drawing/2014/main" id="{A4BC8567-4CF2-490B-B421-78A4FF997059}"/>
+                <a16:creationId xmlns:a16="http://schemas.microsoft.com/office/drawing/2014/main" id="{70B0B559-5FEF-4BCD-9676-1BB9B244AEB5}"/>
               </a:ext>
             </a:extLst>
           </p:cNvPr>
@@ -1810,7 +1810,7 @@
           <p:nvPr/>
         </p:nvPicPr>
         <p:blipFill>
-          <a:blip xmlns:r="http://schemas.openxmlformats.org/officeDocument/2006/relationships" xmlns:a="http://schemas.openxmlformats.org/drawingml/2006/main" r:embed="R6094f7bb1fe3488f"/>
+          <a:blip xmlns:r="http://schemas.openxmlformats.org/officeDocument/2006/relationships" xmlns:a="http://schemas.openxmlformats.org/drawingml/2006/main" r:embed="R57017dac3e074e53"/>
           <a:srcRect xmlns:a="http://schemas.openxmlformats.org/drawingml/2006/main" l="12678" t="0" r="12678" b="0"/>
           <a:stretch xmlns:a="http://schemas.openxmlformats.org/drawingml/2006/main">
             <a:fillRect l="0" t="0" r="0" b="0"/>
@@ -1833,7 +1833,7 @@
           <p:cNvPr id="6" name="">
             <a:extLst xmlns:a="http://schemas.openxmlformats.org/drawingml/2006/main">
               <a:ext uri="{FF2B5EF4-FFF2-40B4-BE49-F238E27FC236}">
-                <a16:creationId xmlns:a16="http://schemas.microsoft.com/office/drawing/2014/main" id="{8DCCCD3B-7EAF-46CB-B663-40E26A7AB6FB}"/>
+                <a16:creationId xmlns:a16="http://schemas.microsoft.com/office/drawing/2014/main" id="{E416547B-CD51-497B-9E91-6154FD8A741F}"/>
               </a:ext>
             </a:extLst>
           </p:cNvPr>
@@ -1881,7 +1881,7 @@
     </p:spTree>
     <p:extLst>
       <p:ext uri="{BB962C8B-B14F-4D97-AF65-F5344CB8AC3E}">
-        <p14:creationId xmlns:p14="http://schemas.microsoft.com/office/powerpoint/2010/main" val="1178557630"/>
+        <p14:creationId xmlns:p14="http://schemas.microsoft.com/office/powerpoint/2010/main" val="560745568"/>
       </p:ext>
     </p:extLst>
   </p:cSld>
@@ -1912,7 +1912,7 @@
           <p:cNvPr id="1" name="">
             <a:extLst xmlns:a="http://schemas.openxmlformats.org/drawingml/2006/main">
               <a:ext uri="{FF2B5EF4-FFF2-40B4-BE49-F238E27FC236}">
-                <a16:creationId xmlns:a16="http://schemas.microsoft.com/office/drawing/2014/main" id="{8233AAF4-3181-40ED-9E8A-90A954440D97}"/>
+                <a16:creationId xmlns:a16="http://schemas.microsoft.com/office/drawing/2014/main" id="{4BB5B64B-8857-43A3-B303-33AEC4803011}"/>
               </a:ext>
             </a:extLst>
           </p:cNvPr>
@@ -1962,7 +1962,7 @@
           <p:cNvPr id="2" name="">
             <a:extLst xmlns:a="http://schemas.openxmlformats.org/drawingml/2006/main">
               <a:ext uri="{FF2B5EF4-FFF2-40B4-BE49-F238E27FC236}">
-                <a16:creationId xmlns:a16="http://schemas.microsoft.com/office/drawing/2014/main" id="{8A71D98E-DB64-47CD-96B4-C6A9944A03EF}"/>
+                <a16:creationId xmlns:a16="http://schemas.microsoft.com/office/drawing/2014/main" id="{67B42BA1-314B-4846-8151-019121B5B00F}"/>
               </a:ext>
             </a:extLst>
           </p:cNvPr>
@@ -2012,7 +2012,7 @@
           <p:cNvPr id="3" name="">
             <a:extLst xmlns:a="http://schemas.openxmlformats.org/drawingml/2006/main">
               <a:ext uri="{FF2B5EF4-FFF2-40B4-BE49-F238E27FC236}">
-                <a16:creationId xmlns:a16="http://schemas.microsoft.com/office/drawing/2014/main" id="{6E6441F1-6D53-49CF-AD03-56D90BE2B4E4}"/>
+                <a16:creationId xmlns:a16="http://schemas.microsoft.com/office/drawing/2014/main" id="{0A0702D4-55C7-4CBB-BB8B-E67DF021A8B9}"/>
               </a:ext>
             </a:extLst>
           </p:cNvPr>
@@ -2045,7 +2045,7 @@
           <p:cNvPr id="4" name="">
             <a:extLst xmlns:a="http://schemas.openxmlformats.org/drawingml/2006/main">
               <a:ext uri="{FF2B5EF4-FFF2-40B4-BE49-F238E27FC236}">
-                <a16:creationId xmlns:a16="http://schemas.microsoft.com/office/drawing/2014/main" id="{76173097-9ABC-4213-8BC1-EBB2819F6884}"/>
+                <a16:creationId xmlns:a16="http://schemas.microsoft.com/office/drawing/2014/main" id="{126CC376-44E2-49CC-93ED-8030476F7E77}"/>
               </a:ext>
             </a:extLst>
           </p:cNvPr>
@@ -2095,7 +2095,7 @@
           <p:cNvPr id="5" name="">
             <a:extLst xmlns:a="http://schemas.openxmlformats.org/drawingml/2006/main">
               <a:ext uri="{FF2B5EF4-FFF2-40B4-BE49-F238E27FC236}">
-                <a16:creationId xmlns:a16="http://schemas.microsoft.com/office/drawing/2014/main" id="{E53CF2A9-C295-41FB-A740-76DDF73E84FE}"/>
+                <a16:creationId xmlns:a16="http://schemas.microsoft.com/office/drawing/2014/main" id="{5B5DAFBD-0297-4557-BDE4-B2F28997D920}"/>
               </a:ext>
             </a:extLst>
           </p:cNvPr>
@@ -2128,7 +2128,7 @@
           <p:cNvPr id="6" name="">
             <a:extLst xmlns:a="http://schemas.openxmlformats.org/drawingml/2006/main">
               <a:ext uri="{FF2B5EF4-FFF2-40B4-BE49-F238E27FC236}">
-                <a16:creationId xmlns:a16="http://schemas.microsoft.com/office/drawing/2014/main" id="{006C7D95-9F1E-40F4-BC85-B26E460AA3FF}"/>
+                <a16:creationId xmlns:a16="http://schemas.microsoft.com/office/drawing/2014/main" id="{B9EBB176-386C-46A2-883D-699A5F9FF4C8}"/>
               </a:ext>
             </a:extLst>
           </p:cNvPr>
@@ -2178,7 +2178,7 @@
           <p:cNvPr id="7" name="">
             <a:extLst xmlns:a="http://schemas.openxmlformats.org/drawingml/2006/main">
               <a:ext uri="{FF2B5EF4-FFF2-40B4-BE49-F238E27FC236}">
-                <a16:creationId xmlns:a16="http://schemas.microsoft.com/office/drawing/2014/main" id="{45815AD4-9EF2-46FA-B029-C690ECE61DEC}"/>
+                <a16:creationId xmlns:a16="http://schemas.microsoft.com/office/drawing/2014/main" id="{5B1A6A11-8495-4032-9820-A9C436DEAC48}"/>
               </a:ext>
             </a:extLst>
           </p:cNvPr>
@@ -2211,7 +2211,7 @@
           <p:cNvPr id="8" name="">
             <a:extLst xmlns:a="http://schemas.openxmlformats.org/drawingml/2006/main">
               <a:ext uri="{FF2B5EF4-FFF2-40B4-BE49-F238E27FC236}">
-                <a16:creationId xmlns:a16="http://schemas.microsoft.com/office/drawing/2014/main" id="{7AB0E1EE-DB39-4AD2-BDC8-622A760F9B9A}"/>
+                <a16:creationId xmlns:a16="http://schemas.microsoft.com/office/drawing/2014/main" id="{9E8D41DF-007E-4E4F-98D9-D9DBAADDAA81}"/>
               </a:ext>
             </a:extLst>
           </p:cNvPr>
@@ -2261,7 +2261,7 @@
           <p:cNvPr id="9" name="">
             <a:extLst xmlns:a="http://schemas.openxmlformats.org/drawingml/2006/main">
               <a:ext uri="{FF2B5EF4-FFF2-40B4-BE49-F238E27FC236}">
-                <a16:creationId xmlns:a16="http://schemas.microsoft.com/office/drawing/2014/main" id="{E0C97EC9-7E77-487D-8E12-A4045FBBA12D}"/>
+                <a16:creationId xmlns:a16="http://schemas.microsoft.com/office/drawing/2014/main" id="{C6198442-29C6-4A8E-83BD-61EC5C262081}"/>
               </a:ext>
             </a:extLst>
           </p:cNvPr>
@@ -2294,7 +2294,7 @@
           <p:cNvPr id="10" name="">
             <a:extLst xmlns:a="http://schemas.openxmlformats.org/drawingml/2006/main">
               <a:ext uri="{FF2B5EF4-FFF2-40B4-BE49-F238E27FC236}">
-                <a16:creationId xmlns:a16="http://schemas.microsoft.com/office/drawing/2014/main" id="{A82CAA8C-8108-4001-81D3-FFE03E46040E}"/>
+                <a16:creationId xmlns:a16="http://schemas.microsoft.com/office/drawing/2014/main" id="{D55ED78A-F8FF-42CE-B2F1-EABBA137608E}"/>
               </a:ext>
             </a:extLst>
           </p:cNvPr>
@@ -2344,7 +2344,7 @@
           <p:cNvPr id="11" name="">
             <a:extLst xmlns:a="http://schemas.openxmlformats.org/drawingml/2006/main">
               <a:ext uri="{FF2B5EF4-FFF2-40B4-BE49-F238E27FC236}">
-                <a16:creationId xmlns:a16="http://schemas.microsoft.com/office/drawing/2014/main" id="{9C2EE1CE-606E-4260-BCE4-0E4CEB58AB76}"/>
+                <a16:creationId xmlns:a16="http://schemas.microsoft.com/office/drawing/2014/main" id="{39AF00FF-9324-47C9-81AD-D26BCDFAA7B3}"/>
               </a:ext>
             </a:extLst>
           </p:cNvPr>
@@ -2379,7 +2379,7 @@
           <p:cNvPr id="12" name="">
             <a:extLst xmlns:a="http://schemas.openxmlformats.org/drawingml/2006/main">
               <a:ext uri="{FF2B5EF4-FFF2-40B4-BE49-F238E27FC236}">
-                <a16:creationId xmlns:a16="http://schemas.microsoft.com/office/drawing/2014/main" id="{310F218B-8611-456A-82CD-00ED783902CA}"/>
+                <a16:creationId xmlns:a16="http://schemas.microsoft.com/office/drawing/2014/main" id="{F23458E9-5EB1-4CE9-8051-2D69C9669846}"/>
               </a:ext>
             </a:extLst>
           </p:cNvPr>
@@ -2429,7 +2429,7 @@
           <p:cNvPr id="13" name="">
             <a:extLst xmlns:a="http://schemas.openxmlformats.org/drawingml/2006/main">
               <a:ext uri="{FF2B5EF4-FFF2-40B4-BE49-F238E27FC236}">
-                <a16:creationId xmlns:a16="http://schemas.microsoft.com/office/drawing/2014/main" id="{27DF5B6D-7164-4EBC-A6F1-F89538049EF1}"/>
+                <a16:creationId xmlns:a16="http://schemas.microsoft.com/office/drawing/2014/main" id="{8B2B8CB3-C8AA-4F70-A589-29AB4F48EF88}"/>
               </a:ext>
             </a:extLst>
           </p:cNvPr>
@@ -2477,7 +2477,7 @@
     </p:spTree>
     <p:extLst>
       <p:ext uri="{BB962C8B-B14F-4D97-AF65-F5344CB8AC3E}">
-        <p14:creationId xmlns:p14="http://schemas.microsoft.com/office/powerpoint/2010/main" val="120727610"/>
+        <p14:creationId xmlns:p14="http://schemas.microsoft.com/office/powerpoint/2010/main" val="1447024364"/>
       </p:ext>
     </p:extLst>
   </p:cSld>
@@ -2508,7 +2508,7 @@
           <p:cNvPr id="1" name="">
             <a:extLst xmlns:a="http://schemas.openxmlformats.org/drawingml/2006/main">
               <a:ext uri="{FF2B5EF4-FFF2-40B4-BE49-F238E27FC236}">
-                <a16:creationId xmlns:a16="http://schemas.microsoft.com/office/drawing/2014/main" id="{A73DE0D5-E5E5-47DB-9F83-49318E096AFB}"/>
+                <a16:creationId xmlns:a16="http://schemas.microsoft.com/office/drawing/2014/main" id="{3CEC2ED8-29A3-403B-A38B-15EB28FF3786}"/>
               </a:ext>
             </a:extLst>
           </p:cNvPr>
@@ -2558,7 +2558,7 @@
           <p:cNvPr id="2" name="">
             <a:extLst xmlns:a="http://schemas.openxmlformats.org/drawingml/2006/main">
               <a:ext uri="{FF2B5EF4-FFF2-40B4-BE49-F238E27FC236}">
-                <a16:creationId xmlns:a16="http://schemas.microsoft.com/office/drawing/2014/main" id="{54E5B465-C91F-40B3-961C-0AFBD713A8F9}"/>
+                <a16:creationId xmlns:a16="http://schemas.microsoft.com/office/drawing/2014/main" id="{1997893D-A3E2-44DE-BD84-53B4ACDE1615}"/>
               </a:ext>
             </a:extLst>
           </p:cNvPr>
@@ -2608,7 +2608,7 @@
           <p:cNvPr id="3" name="">
             <a:extLst xmlns:a="http://schemas.openxmlformats.org/drawingml/2006/main">
               <a:ext uri="{FF2B5EF4-FFF2-40B4-BE49-F238E27FC236}">
-                <a16:creationId xmlns:a16="http://schemas.microsoft.com/office/drawing/2014/main" id="{419A6E26-169E-4EE0-9E21-13D30998609A}"/>
+                <a16:creationId xmlns:a16="http://schemas.microsoft.com/office/drawing/2014/main" id="{C79D81C9-1FE6-4485-9619-A62A2FE867D0}"/>
               </a:ext>
             </a:extLst>
           </p:cNvPr>
@@ -2641,7 +2641,7 @@
           <p:cNvPr id="4" name="">
             <a:extLst xmlns:a="http://schemas.openxmlformats.org/drawingml/2006/main">
               <a:ext uri="{FF2B5EF4-FFF2-40B4-BE49-F238E27FC236}">
-                <a16:creationId xmlns:a16="http://schemas.microsoft.com/office/drawing/2014/main" id="{13C86033-0B45-4BCB-955B-11AA6AC89151}"/>
+                <a16:creationId xmlns:a16="http://schemas.microsoft.com/office/drawing/2014/main" id="{921F7EB7-867B-4B4E-9B6A-FB4563143555}"/>
               </a:ext>
             </a:extLst>
           </p:cNvPr>
@@ -2691,7 +2691,7 @@
           <p:cNvPr id="5" name="">
             <a:extLst xmlns:a="http://schemas.openxmlformats.org/drawingml/2006/main">
               <a:ext uri="{FF2B5EF4-FFF2-40B4-BE49-F238E27FC236}">
-                <a16:creationId xmlns:a16="http://schemas.microsoft.com/office/drawing/2014/main" id="{E6EA200A-61EA-4F38-8C96-D6C861F9FF2C}"/>
+                <a16:creationId xmlns:a16="http://schemas.microsoft.com/office/drawing/2014/main" id="{53051EB5-BD16-4D1F-B3EC-59C2320761BB}"/>
               </a:ext>
             </a:extLst>
           </p:cNvPr>
@@ -2726,7 +2726,7 @@
           <p:cNvPr id="6" name="">
             <a:extLst xmlns:a="http://schemas.openxmlformats.org/drawingml/2006/main">
               <a:ext uri="{FF2B5EF4-FFF2-40B4-BE49-F238E27FC236}">
-                <a16:creationId xmlns:a16="http://schemas.microsoft.com/office/drawing/2014/main" id="{DE37EC8B-FDC7-4E34-AD9B-2A37C35758B5}"/>
+                <a16:creationId xmlns:a16="http://schemas.microsoft.com/office/drawing/2014/main" id="{227EE3B6-0970-43A1-86AA-6A0262038429}"/>
               </a:ext>
             </a:extLst>
           </p:cNvPr>
@@ -2776,7 +2776,7 @@
           <p:cNvPr id="7" name="">
             <a:extLst xmlns:a="http://schemas.openxmlformats.org/drawingml/2006/main">
               <a:ext uri="{FF2B5EF4-FFF2-40B4-BE49-F238E27FC236}">
-                <a16:creationId xmlns:a16="http://schemas.microsoft.com/office/drawing/2014/main" id="{E08A1975-0419-4157-B96E-C456336E1B43}"/>
+                <a16:creationId xmlns:a16="http://schemas.microsoft.com/office/drawing/2014/main" id="{32A59D1F-54EB-4367-B886-30A9FAFF5C3F}"/>
               </a:ext>
             </a:extLst>
           </p:cNvPr>
@@ -2826,7 +2826,7 @@
           <p:cNvPr id="8" name="">
             <a:extLst xmlns:a="http://schemas.openxmlformats.org/drawingml/2006/main">
               <a:ext uri="{FF2B5EF4-FFF2-40B4-BE49-F238E27FC236}">
-                <a16:creationId xmlns:a16="http://schemas.microsoft.com/office/drawing/2014/main" id="{57B123C1-5568-4925-93A6-A8EA67B26372}"/>
+                <a16:creationId xmlns:a16="http://schemas.microsoft.com/office/drawing/2014/main" id="{D04C0D02-EF6E-4610-B543-6187027D9EFB}"/>
               </a:ext>
             </a:extLst>
           </p:cNvPr>
@@ -2861,7 +2861,7 @@
           <p:cNvPr id="9" name="">
             <a:extLst xmlns:a="http://schemas.openxmlformats.org/drawingml/2006/main">
               <a:ext uri="{FF2B5EF4-FFF2-40B4-BE49-F238E27FC236}">
-                <a16:creationId xmlns:a16="http://schemas.microsoft.com/office/drawing/2014/main" id="{97AE738F-C87D-448B-8F88-5C5AB097D6D0}"/>
+                <a16:creationId xmlns:a16="http://schemas.microsoft.com/office/drawing/2014/main" id="{17FC9CE1-698D-474E-A68C-7853F45892D7}"/>
               </a:ext>
             </a:extLst>
           </p:cNvPr>
@@ -2911,7 +2911,7 @@
           <p:cNvPr id="10" name="">
             <a:extLst xmlns:a="http://schemas.openxmlformats.org/drawingml/2006/main">
               <a:ext uri="{FF2B5EF4-FFF2-40B4-BE49-F238E27FC236}">
-                <a16:creationId xmlns:a16="http://schemas.microsoft.com/office/drawing/2014/main" id="{5F2FB0A4-99D0-4CAE-8021-1B312DE6AAA8}"/>
+                <a16:creationId xmlns:a16="http://schemas.microsoft.com/office/drawing/2014/main" id="{8F792B1D-3E7C-48A6-B75E-7C1DD3F90B54}"/>
               </a:ext>
             </a:extLst>
           </p:cNvPr>
@@ -2961,7 +2961,7 @@
           <p:cNvPr id="11" name="">
             <a:extLst xmlns:a="http://schemas.openxmlformats.org/drawingml/2006/main">
               <a:ext uri="{FF2B5EF4-FFF2-40B4-BE49-F238E27FC236}">
-                <a16:creationId xmlns:a16="http://schemas.microsoft.com/office/drawing/2014/main" id="{506110A8-BB78-4BD5-B593-21AEF77FC1B3}"/>
+                <a16:creationId xmlns:a16="http://schemas.microsoft.com/office/drawing/2014/main" id="{36541A72-9CF4-4CD5-8ECE-144F8D968DC6}"/>
               </a:ext>
             </a:extLst>
           </p:cNvPr>
@@ -2996,7 +2996,7 @@
           <p:cNvPr id="12" name="">
             <a:extLst xmlns:a="http://schemas.openxmlformats.org/drawingml/2006/main">
               <a:ext uri="{FF2B5EF4-FFF2-40B4-BE49-F238E27FC236}">
-                <a16:creationId xmlns:a16="http://schemas.microsoft.com/office/drawing/2014/main" id="{29C8FACA-5702-4347-BF69-E007682F474B}"/>
+                <a16:creationId xmlns:a16="http://schemas.microsoft.com/office/drawing/2014/main" id="{C06831EE-8959-4541-8B76-AB40FE96F1F2}"/>
               </a:ext>
             </a:extLst>
           </p:cNvPr>
@@ -3046,7 +3046,7 @@
           <p:cNvPr id="13" name="">
             <a:extLst xmlns:a="http://schemas.openxmlformats.org/drawingml/2006/main">
               <a:ext uri="{FF2B5EF4-FFF2-40B4-BE49-F238E27FC236}">
-                <a16:creationId xmlns:a16="http://schemas.microsoft.com/office/drawing/2014/main" id="{13B4280F-135E-4E65-8DE3-39BFE7F0BCDF}"/>
+                <a16:creationId xmlns:a16="http://schemas.microsoft.com/office/drawing/2014/main" id="{C6E47D05-3642-4766-8E7C-3067F935CCB3}"/>
               </a:ext>
             </a:extLst>
           </p:cNvPr>
@@ -3096,7 +3096,7 @@
           <p:cNvPr id="14" name="">
             <a:extLst xmlns:a="http://schemas.openxmlformats.org/drawingml/2006/main">
               <a:ext uri="{FF2B5EF4-FFF2-40B4-BE49-F238E27FC236}">
-                <a16:creationId xmlns:a16="http://schemas.microsoft.com/office/drawing/2014/main" id="{FE944767-27FE-4CBD-A23A-40888D5C6A23}"/>
+                <a16:creationId xmlns:a16="http://schemas.microsoft.com/office/drawing/2014/main" id="{176C456F-A15B-474E-898F-2359A3DCBD60}"/>
               </a:ext>
             </a:extLst>
           </p:cNvPr>
@@ -3131,7 +3131,7 @@
           <p:cNvPr id="15" name="">
             <a:extLst xmlns:a="http://schemas.openxmlformats.org/drawingml/2006/main">
               <a:ext uri="{FF2B5EF4-FFF2-40B4-BE49-F238E27FC236}">
-                <a16:creationId xmlns:a16="http://schemas.microsoft.com/office/drawing/2014/main" id="{117934AC-9D1D-4399-9892-98B4C75ECBE1}"/>
+                <a16:creationId xmlns:a16="http://schemas.microsoft.com/office/drawing/2014/main" id="{A04C93E8-A035-44FA-BBDF-9AC68A6A3392}"/>
               </a:ext>
             </a:extLst>
           </p:cNvPr>
@@ -3181,7 +3181,7 @@
           <p:cNvPr id="16" name="">
             <a:extLst xmlns:a="http://schemas.openxmlformats.org/drawingml/2006/main">
               <a:ext uri="{FF2B5EF4-FFF2-40B4-BE49-F238E27FC236}">
-                <a16:creationId xmlns:a16="http://schemas.microsoft.com/office/drawing/2014/main" id="{B8D5645F-F210-439E-BDF5-44237E6AD2D7}"/>
+                <a16:creationId xmlns:a16="http://schemas.microsoft.com/office/drawing/2014/main" id="{FDB99926-C5FD-44A9-8C37-71B574AB4D28}"/>
               </a:ext>
             </a:extLst>
           </p:cNvPr>
@@ -3231,7 +3231,7 @@
           <p:cNvPr id="17" name="">
             <a:extLst xmlns:a="http://schemas.openxmlformats.org/drawingml/2006/main">
               <a:ext uri="{FF2B5EF4-FFF2-40B4-BE49-F238E27FC236}">
-                <a16:creationId xmlns:a16="http://schemas.microsoft.com/office/drawing/2014/main" id="{D0BE854D-80C3-4D4E-AA80-82979142C3C9}"/>
+                <a16:creationId xmlns:a16="http://schemas.microsoft.com/office/drawing/2014/main" id="{ED97E8EB-EC8F-4895-BCE3-CF2DB0D08943}"/>
               </a:ext>
             </a:extLst>
           </p:cNvPr>
@@ -3279,7 +3279,7 @@
     </p:spTree>
     <p:extLst>
       <p:ext uri="{BB962C8B-B14F-4D97-AF65-F5344CB8AC3E}">
-        <p14:creationId xmlns:p14="http://schemas.microsoft.com/office/powerpoint/2010/main" val="1867490651"/>
+        <p14:creationId xmlns:p14="http://schemas.microsoft.com/office/powerpoint/2010/main" val="498547157"/>
       </p:ext>
     </p:extLst>
   </p:cSld>
@@ -3310,7 +3310,7 @@
           <p:cNvPr id="1" name="">
             <a:extLst xmlns:a="http://schemas.openxmlformats.org/drawingml/2006/main">
               <a:ext uri="{FF2B5EF4-FFF2-40B4-BE49-F238E27FC236}">
-                <a16:creationId xmlns:a16="http://schemas.microsoft.com/office/drawing/2014/main" id="{6718F1A0-2858-45AE-943A-A648D05B8398}"/>
+                <a16:creationId xmlns:a16="http://schemas.microsoft.com/office/drawing/2014/main" id="{89CB3E27-95D7-4395-B261-EB57BAEB574D}"/>
               </a:ext>
             </a:extLst>
           </p:cNvPr>
@@ -3360,7 +3360,7 @@
           <p:cNvPr id="2" name="">
             <a:extLst xmlns:a="http://schemas.openxmlformats.org/drawingml/2006/main">
               <a:ext uri="{FF2B5EF4-FFF2-40B4-BE49-F238E27FC236}">
-                <a16:creationId xmlns:a16="http://schemas.microsoft.com/office/drawing/2014/main" id="{4D0350EF-01DD-423D-AC23-D6DFAC6EB27C}"/>
+                <a16:creationId xmlns:a16="http://schemas.microsoft.com/office/drawing/2014/main" id="{D6129843-CB3E-48FE-8A3B-FA5DDFF669AC}"/>
               </a:ext>
             </a:extLst>
           </p:cNvPr>
@@ -3410,7 +3410,7 @@
           <p:cNvPr id="3" name="">
             <a:extLst xmlns:a="http://schemas.openxmlformats.org/drawingml/2006/main">
               <a:ext uri="{FF2B5EF4-FFF2-40B4-BE49-F238E27FC236}">
-                <a16:creationId xmlns:a16="http://schemas.microsoft.com/office/drawing/2014/main" id="{FF1D80AF-DC6F-4397-9E15-94F132034C8A}"/>
+                <a16:creationId xmlns:a16="http://schemas.microsoft.com/office/drawing/2014/main" id="{60E424B1-DFDC-4274-84F9-4DD32BB2F207}"/>
               </a:ext>
             </a:extLst>
           </p:cNvPr>
@@ -3443,7 +3443,7 @@
           <p:cNvPr id="4" name="">
             <a:extLst xmlns:a="http://schemas.openxmlformats.org/drawingml/2006/main">
               <a:ext uri="{FF2B5EF4-FFF2-40B4-BE49-F238E27FC236}">
-                <a16:creationId xmlns:a16="http://schemas.microsoft.com/office/drawing/2014/main" id="{20613FDB-7D7E-4065-9AF7-5F94EAF08FAA}"/>
+                <a16:creationId xmlns:a16="http://schemas.microsoft.com/office/drawing/2014/main" id="{DD0A9F94-8DEA-4FA7-9AA3-3E74E51B0049}"/>
               </a:ext>
             </a:extLst>
           </p:cNvPr>
@@ -3493,7 +3493,7 @@
           <p:cNvPr id="5" name="">
             <a:extLst xmlns:a="http://schemas.openxmlformats.org/drawingml/2006/main">
               <a:ext uri="{FF2B5EF4-FFF2-40B4-BE49-F238E27FC236}">
-                <a16:creationId xmlns:a16="http://schemas.microsoft.com/office/drawing/2014/main" id="{EFF7E1FA-319A-4C09-BE5B-A5B7D47AFAB3}"/>
+                <a16:creationId xmlns:a16="http://schemas.microsoft.com/office/drawing/2014/main" id="{A0B4652A-20DD-4DF7-82AD-4CFDE742F6C2}"/>
               </a:ext>
             </a:extLst>
           </p:cNvPr>
@@ -3547,7 +3547,7 @@
           <p:nvPr/>
         </p:nvPicPr>
         <p:blipFill>
-          <a:blip xmlns:r="http://schemas.openxmlformats.org/officeDocument/2006/relationships" xmlns:a="http://schemas.openxmlformats.org/drawingml/2006/main" r:embed="Recd881f288af4915"/>
+          <a:blip xmlns:r="http://schemas.openxmlformats.org/officeDocument/2006/relationships" xmlns:a="http://schemas.openxmlformats.org/drawingml/2006/main" r:embed="Rb2b48505036a4c97"/>
           <a:srcRect xmlns:a="http://schemas.openxmlformats.org/drawingml/2006/main" l="0" t="13" r="0" b="13"/>
           <a:stretch xmlns:a="http://schemas.openxmlformats.org/drawingml/2006/main">
             <a:fillRect l="0" t="0" r="0" b="0"/>
@@ -3568,7 +3568,7 @@
     </p:spTree>
     <p:extLst>
       <p:ext uri="{BB962C8B-B14F-4D97-AF65-F5344CB8AC3E}">
-        <p14:creationId xmlns:p14="http://schemas.microsoft.com/office/powerpoint/2010/main" val="2001637949"/>
+        <p14:creationId xmlns:p14="http://schemas.microsoft.com/office/powerpoint/2010/main" val="954420198"/>
       </p:ext>
     </p:extLst>
   </p:cSld>
@@ -3599,7 +3599,7 @@
           <p:cNvPr id="1" name="">
             <a:extLst xmlns:a="http://schemas.openxmlformats.org/drawingml/2006/main">
               <a:ext uri="{FF2B5EF4-FFF2-40B4-BE49-F238E27FC236}">
-                <a16:creationId xmlns:a16="http://schemas.microsoft.com/office/drawing/2014/main" id="{EDD9E26D-D731-43A5-8874-B5EED1951B7C}"/>
+                <a16:creationId xmlns:a16="http://schemas.microsoft.com/office/drawing/2014/main" id="{8FB86826-1E42-494F-B9E2-28CC68B0526A}"/>
               </a:ext>
             </a:extLst>
           </p:cNvPr>
@@ -3649,7 +3649,7 @@
           <p:cNvPr id="2" name="">
             <a:extLst xmlns:a="http://schemas.openxmlformats.org/drawingml/2006/main">
               <a:ext uri="{FF2B5EF4-FFF2-40B4-BE49-F238E27FC236}">
-                <a16:creationId xmlns:a16="http://schemas.microsoft.com/office/drawing/2014/main" id="{0088F616-48EB-4835-90CF-C16D48A10365}"/>
+                <a16:creationId xmlns:a16="http://schemas.microsoft.com/office/drawing/2014/main" id="{0055C384-7431-4DD4-8DF2-250E4BA69B47}"/>
               </a:ext>
             </a:extLst>
           </p:cNvPr>
@@ -3699,7 +3699,7 @@
           <p:cNvPr id="3" name="">
             <a:extLst xmlns:a="http://schemas.openxmlformats.org/drawingml/2006/main">
               <a:ext uri="{FF2B5EF4-FFF2-40B4-BE49-F238E27FC236}">
-                <a16:creationId xmlns:a16="http://schemas.microsoft.com/office/drawing/2014/main" id="{E7ECED8B-A73F-4CED-B5F0-31229D8E4D45}"/>
+                <a16:creationId xmlns:a16="http://schemas.microsoft.com/office/drawing/2014/main" id="{C1406C06-01E8-49AF-A07C-5C8235019F67}"/>
               </a:ext>
             </a:extLst>
           </p:cNvPr>
@@ -3732,7 +3732,7 @@
           <p:cNvPr id="4" name="">
             <a:extLst xmlns:a="http://schemas.openxmlformats.org/drawingml/2006/main">
               <a:ext uri="{FF2B5EF4-FFF2-40B4-BE49-F238E27FC236}">
-                <a16:creationId xmlns:a16="http://schemas.microsoft.com/office/drawing/2014/main" id="{5769ADB6-02CA-44D7-89EC-6EBC48DE37E0}"/>
+                <a16:creationId xmlns:a16="http://schemas.microsoft.com/office/drawing/2014/main" id="{7A25638E-25A7-49D2-9EF2-4CCB4BBDCC85}"/>
               </a:ext>
             </a:extLst>
           </p:cNvPr>
@@ -3786,7 +3786,7 @@
           <p:nvPr/>
         </p:nvPicPr>
         <p:blipFill>
-          <a:blip xmlns:r="http://schemas.openxmlformats.org/officeDocument/2006/relationships" xmlns:a="http://schemas.openxmlformats.org/drawingml/2006/main" r:embed="R021d13ddc67344fd"/>
+          <a:blip xmlns:r="http://schemas.openxmlformats.org/officeDocument/2006/relationships" xmlns:a="http://schemas.openxmlformats.org/drawingml/2006/main" r:embed="Re2f00156fba64429"/>
           <a:srcRect xmlns:a="http://schemas.openxmlformats.org/drawingml/2006/main" l="0" t="145" r="0" b="145"/>
           <a:stretch xmlns:a="http://schemas.openxmlformats.org/drawingml/2006/main">
             <a:fillRect l="0" t="0" r="0" b="0"/>
@@ -3809,7 +3809,7 @@
           <p:cNvPr id="6" name="">
             <a:extLst xmlns:a="http://schemas.openxmlformats.org/drawingml/2006/main">
               <a:ext uri="{FF2B5EF4-FFF2-40B4-BE49-F238E27FC236}">
-                <a16:creationId xmlns:a16="http://schemas.microsoft.com/office/drawing/2014/main" id="{BFBE4531-48C5-4612-B7E4-7390AB032930}"/>
+                <a16:creationId xmlns:a16="http://schemas.microsoft.com/office/drawing/2014/main" id="{792E34EE-5FBE-4115-B4B3-0261B66D820A}"/>
               </a:ext>
             </a:extLst>
           </p:cNvPr>
@@ -3842,7 +3842,7 @@
           <p:cNvPr id="7" name="">
             <a:extLst xmlns:a="http://schemas.openxmlformats.org/drawingml/2006/main">
               <a:ext uri="{FF2B5EF4-FFF2-40B4-BE49-F238E27FC236}">
-                <a16:creationId xmlns:a16="http://schemas.microsoft.com/office/drawing/2014/main" id="{F2E09893-8C43-4670-B9A7-038C21DA0765}"/>
+                <a16:creationId xmlns:a16="http://schemas.microsoft.com/office/drawing/2014/main" id="{DD3CE6F8-DA29-402C-930E-43782CB550C0}"/>
               </a:ext>
             </a:extLst>
           </p:cNvPr>
@@ -3892,7 +3892,7 @@
           <p:cNvPr id="8" name="">
             <a:extLst xmlns:a="http://schemas.openxmlformats.org/drawingml/2006/main">
               <a:ext uri="{FF2B5EF4-FFF2-40B4-BE49-F238E27FC236}">
-                <a16:creationId xmlns:a16="http://schemas.microsoft.com/office/drawing/2014/main" id="{C78DDB2F-5815-40E9-968E-4AB018B681A9}"/>
+                <a16:creationId xmlns:a16="http://schemas.microsoft.com/office/drawing/2014/main" id="{E417533A-5456-404E-9C96-3326E8AE85EA}"/>
               </a:ext>
             </a:extLst>
           </p:cNvPr>
@@ -3925,7 +3925,7 @@
           <p:cNvPr id="9" name="">
             <a:extLst xmlns:a="http://schemas.openxmlformats.org/drawingml/2006/main">
               <a:ext uri="{FF2B5EF4-FFF2-40B4-BE49-F238E27FC236}">
-                <a16:creationId xmlns:a16="http://schemas.microsoft.com/office/drawing/2014/main" id="{6848438E-8D15-4EBE-866D-05A8403FD961}"/>
+                <a16:creationId xmlns:a16="http://schemas.microsoft.com/office/drawing/2014/main" id="{337E0B3B-73EB-439C-9356-F352EAEB8539}"/>
               </a:ext>
             </a:extLst>
           </p:cNvPr>
@@ -3975,7 +3975,7 @@
           <p:cNvPr id="10" name="">
             <a:extLst xmlns:a="http://schemas.openxmlformats.org/drawingml/2006/main">
               <a:ext uri="{FF2B5EF4-FFF2-40B4-BE49-F238E27FC236}">
-                <a16:creationId xmlns:a16="http://schemas.microsoft.com/office/drawing/2014/main" id="{808E46AF-07EB-4B3B-B58B-7A12B20974F2}"/>
+                <a16:creationId xmlns:a16="http://schemas.microsoft.com/office/drawing/2014/main" id="{894ADEE7-6CA3-4931-B29D-9780FC990AC0}"/>
               </a:ext>
             </a:extLst>
           </p:cNvPr>
@@ -4008,7 +4008,7 @@
           <p:cNvPr id="11" name="">
             <a:extLst xmlns:a="http://schemas.openxmlformats.org/drawingml/2006/main">
               <a:ext uri="{FF2B5EF4-FFF2-40B4-BE49-F238E27FC236}">
-                <a16:creationId xmlns:a16="http://schemas.microsoft.com/office/drawing/2014/main" id="{D82944D3-34DC-428D-9ED2-F0CD9BEB1611}"/>
+                <a16:creationId xmlns:a16="http://schemas.microsoft.com/office/drawing/2014/main" id="{9BF6454D-4A39-4C18-AB79-72AAC91E7250}"/>
               </a:ext>
             </a:extLst>
           </p:cNvPr>
@@ -4058,7 +4058,7 @@
           <p:cNvPr id="12" name="">
             <a:extLst xmlns:a="http://schemas.openxmlformats.org/drawingml/2006/main">
               <a:ext uri="{FF2B5EF4-FFF2-40B4-BE49-F238E27FC236}">
-                <a16:creationId xmlns:a16="http://schemas.microsoft.com/office/drawing/2014/main" id="{F9D3C84E-FBBF-46C0-916B-68536D574CBA}"/>
+                <a16:creationId xmlns:a16="http://schemas.microsoft.com/office/drawing/2014/main" id="{E9F44F02-E33D-4E7A-9228-37296D409A5C}"/>
               </a:ext>
             </a:extLst>
           </p:cNvPr>
@@ -4091,7 +4091,7 @@
           <p:cNvPr id="13" name="">
             <a:extLst xmlns:a="http://schemas.openxmlformats.org/drawingml/2006/main">
               <a:ext uri="{FF2B5EF4-FFF2-40B4-BE49-F238E27FC236}">
-                <a16:creationId xmlns:a16="http://schemas.microsoft.com/office/drawing/2014/main" id="{E0A30465-2CA9-425F-B8AB-D67EA4DF010B}"/>
+                <a16:creationId xmlns:a16="http://schemas.microsoft.com/office/drawing/2014/main" id="{2F376ECF-C78A-40DF-B066-4ED1C0310DEB}"/>
               </a:ext>
             </a:extLst>
           </p:cNvPr>
@@ -4139,7 +4139,7 @@
     </p:spTree>
     <p:extLst>
       <p:ext uri="{BB962C8B-B14F-4D97-AF65-F5344CB8AC3E}">
-        <p14:creationId xmlns:p14="http://schemas.microsoft.com/office/powerpoint/2010/main" val="1612475631"/>
+        <p14:creationId xmlns:p14="http://schemas.microsoft.com/office/powerpoint/2010/main" val="1322628566"/>
       </p:ext>
     </p:extLst>
   </p:cSld>
@@ -4170,7 +4170,7 @@
           <p:cNvPr id="1" name="">
             <a:extLst xmlns:a="http://schemas.openxmlformats.org/drawingml/2006/main">
               <a:ext uri="{FF2B5EF4-FFF2-40B4-BE49-F238E27FC236}">
-                <a16:creationId xmlns:a16="http://schemas.microsoft.com/office/drawing/2014/main" id="{3D0F0E20-C02F-44E3-97B4-119B9BB5BA6E}"/>
+                <a16:creationId xmlns:a16="http://schemas.microsoft.com/office/drawing/2014/main" id="{31967BD6-D3F2-412B-8174-16A010918A94}"/>
               </a:ext>
             </a:extLst>
           </p:cNvPr>
@@ -4220,7 +4220,7 @@
           <p:cNvPr id="2" name="">
             <a:extLst xmlns:a="http://schemas.openxmlformats.org/drawingml/2006/main">
               <a:ext uri="{FF2B5EF4-FFF2-40B4-BE49-F238E27FC236}">
-                <a16:creationId xmlns:a16="http://schemas.microsoft.com/office/drawing/2014/main" id="{457163C1-78D8-4036-80A1-006E9C6653D1}"/>
+                <a16:creationId xmlns:a16="http://schemas.microsoft.com/office/drawing/2014/main" id="{3E5A1957-2E73-493F-8D4D-B4F2AB5F00EA}"/>
               </a:ext>
             </a:extLst>
           </p:cNvPr>
@@ -4270,7 +4270,7 @@
           <p:cNvPr id="3" name="">
             <a:extLst xmlns:a="http://schemas.openxmlformats.org/drawingml/2006/main">
               <a:ext uri="{FF2B5EF4-FFF2-40B4-BE49-F238E27FC236}">
-                <a16:creationId xmlns:a16="http://schemas.microsoft.com/office/drawing/2014/main" id="{149F3124-B6AB-424F-B500-F9B17FC49F54}"/>
+                <a16:creationId xmlns:a16="http://schemas.microsoft.com/office/drawing/2014/main" id="{8DFFC1EF-B39D-4960-9479-DE18C17917E9}"/>
               </a:ext>
             </a:extLst>
           </p:cNvPr>
@@ -4303,7 +4303,7 @@
           <p:cNvPr id="4" name="">
             <a:extLst xmlns:a="http://schemas.openxmlformats.org/drawingml/2006/main">
               <a:ext uri="{FF2B5EF4-FFF2-40B4-BE49-F238E27FC236}">
-                <a16:creationId xmlns:a16="http://schemas.microsoft.com/office/drawing/2014/main" id="{FA9577A1-3612-4B71-846F-DFBD38566AC4}"/>
+                <a16:creationId xmlns:a16="http://schemas.microsoft.com/office/drawing/2014/main" id="{6D19211E-4501-4759-84CC-9B158B9C6645}"/>
               </a:ext>
             </a:extLst>
           </p:cNvPr>
@@ -4353,7 +4353,7 @@
           <p:cNvPr id="5" name="">
             <a:extLst xmlns:a="http://schemas.openxmlformats.org/drawingml/2006/main">
               <a:ext uri="{FF2B5EF4-FFF2-40B4-BE49-F238E27FC236}">
-                <a16:creationId xmlns:a16="http://schemas.microsoft.com/office/drawing/2014/main" id="{9FE999E8-ABA9-497D-9EFF-6338A9BF3FE4}"/>
+                <a16:creationId xmlns:a16="http://schemas.microsoft.com/office/drawing/2014/main" id="{92961898-8B09-4E4B-902B-E6F1FAC54C67}"/>
               </a:ext>
             </a:extLst>
           </p:cNvPr>
@@ -4386,7 +4386,7 @@
           <p:cNvPr id="6" name="">
             <a:extLst xmlns:a="http://schemas.openxmlformats.org/drawingml/2006/main">
               <a:ext uri="{FF2B5EF4-FFF2-40B4-BE49-F238E27FC236}">
-                <a16:creationId xmlns:a16="http://schemas.microsoft.com/office/drawing/2014/main" id="{1D5A5085-BD87-4EFE-9317-1EE21E7D7396}"/>
+                <a16:creationId xmlns:a16="http://schemas.microsoft.com/office/drawing/2014/main" id="{8776B069-F24D-495F-A8D3-388FE272D071}"/>
               </a:ext>
             </a:extLst>
           </p:cNvPr>
@@ -4436,7 +4436,7 @@
           <p:cNvPr id="7" name="">
             <a:extLst xmlns:a="http://schemas.openxmlformats.org/drawingml/2006/main">
               <a:ext uri="{FF2B5EF4-FFF2-40B4-BE49-F238E27FC236}">
-                <a16:creationId xmlns:a16="http://schemas.microsoft.com/office/drawing/2014/main" id="{F173982A-3A4E-44B4-B353-10541801446F}"/>
+                <a16:creationId xmlns:a16="http://schemas.microsoft.com/office/drawing/2014/main" id="{4C895190-017A-4534-8179-A6D35BDBB278}"/>
               </a:ext>
             </a:extLst>
           </p:cNvPr>
@@ -4469,7 +4469,7 @@
           <p:cNvPr id="8" name="">
             <a:extLst xmlns:a="http://schemas.openxmlformats.org/drawingml/2006/main">
               <a:ext uri="{FF2B5EF4-FFF2-40B4-BE49-F238E27FC236}">
-                <a16:creationId xmlns:a16="http://schemas.microsoft.com/office/drawing/2014/main" id="{2C784E0D-218B-4174-B6E7-812C51C53019}"/>
+                <a16:creationId xmlns:a16="http://schemas.microsoft.com/office/drawing/2014/main" id="{4591E321-03DA-4D6D-AC68-0CD18E0FEACB}"/>
               </a:ext>
             </a:extLst>
           </p:cNvPr>
@@ -4519,7 +4519,7 @@
           <p:cNvPr id="9" name="">
             <a:extLst xmlns:a="http://schemas.openxmlformats.org/drawingml/2006/main">
               <a:ext uri="{FF2B5EF4-FFF2-40B4-BE49-F238E27FC236}">
-                <a16:creationId xmlns:a16="http://schemas.microsoft.com/office/drawing/2014/main" id="{96408754-D6A7-4A82-A6B6-02BCE2B6E862}"/>
+                <a16:creationId xmlns:a16="http://schemas.microsoft.com/office/drawing/2014/main" id="{86E917E8-4521-4CC9-A926-3A082511B6BE}"/>
               </a:ext>
             </a:extLst>
           </p:cNvPr>
@@ -4552,7 +4552,7 @@
           <p:cNvPr id="10" name="">
             <a:extLst xmlns:a="http://schemas.openxmlformats.org/drawingml/2006/main">
               <a:ext uri="{FF2B5EF4-FFF2-40B4-BE49-F238E27FC236}">
-                <a16:creationId xmlns:a16="http://schemas.microsoft.com/office/drawing/2014/main" id="{3A3E33FE-5538-4A34-B437-D1EF8A68B211}"/>
+                <a16:creationId xmlns:a16="http://schemas.microsoft.com/office/drawing/2014/main" id="{5AAF8383-B7A5-46AE-83AB-0FCA74625003}"/>
               </a:ext>
             </a:extLst>
           </p:cNvPr>
@@ -4602,7 +4602,7 @@
           <p:cNvPr id="11" name="">
             <a:extLst xmlns:a="http://schemas.openxmlformats.org/drawingml/2006/main">
               <a:ext uri="{FF2B5EF4-FFF2-40B4-BE49-F238E27FC236}">
-                <a16:creationId xmlns:a16="http://schemas.microsoft.com/office/drawing/2014/main" id="{2FE679DB-9697-4311-AC36-A03A8E488634}"/>
+                <a16:creationId xmlns:a16="http://schemas.microsoft.com/office/drawing/2014/main" id="{4188E8CB-2ACF-4B03-BD50-3E7CEA0F1A12}"/>
               </a:ext>
             </a:extLst>
           </p:cNvPr>
@@ -4637,7 +4637,7 @@
           <p:cNvPr id="12" name="">
             <a:extLst xmlns:a="http://schemas.openxmlformats.org/drawingml/2006/main">
               <a:ext uri="{FF2B5EF4-FFF2-40B4-BE49-F238E27FC236}">
-                <a16:creationId xmlns:a16="http://schemas.microsoft.com/office/drawing/2014/main" id="{10F0946A-1F13-45E8-8012-86961CEA4A5A}"/>
+                <a16:creationId xmlns:a16="http://schemas.microsoft.com/office/drawing/2014/main" id="{7603206C-6D72-4BE8-9C31-7F8592584389}"/>
               </a:ext>
             </a:extLst>
           </p:cNvPr>
@@ -4687,7 +4687,7 @@
           <p:cNvPr id="13" name="">
             <a:extLst xmlns:a="http://schemas.openxmlformats.org/drawingml/2006/main">
               <a:ext uri="{FF2B5EF4-FFF2-40B4-BE49-F238E27FC236}">
-                <a16:creationId xmlns:a16="http://schemas.microsoft.com/office/drawing/2014/main" id="{2308AE5F-7C52-4401-8DA5-85AE5E16D136}"/>
+                <a16:creationId xmlns:a16="http://schemas.microsoft.com/office/drawing/2014/main" id="{AEA0E37A-1B9C-4DD0-8155-53DBE003D318}"/>
               </a:ext>
             </a:extLst>
           </p:cNvPr>
@@ -4735,7 +4735,7 @@
     </p:spTree>
     <p:extLst>
       <p:ext uri="{BB962C8B-B14F-4D97-AF65-F5344CB8AC3E}">
-        <p14:creationId xmlns:p14="http://schemas.microsoft.com/office/powerpoint/2010/main" val="2058574810"/>
+        <p14:creationId xmlns:p14="http://schemas.microsoft.com/office/powerpoint/2010/main" val="958794141"/>
       </p:ext>
     </p:extLst>
   </p:cSld>
@@ -4766,7 +4766,7 @@
           <p:cNvPr id="1" name="">
             <a:extLst xmlns:a="http://schemas.openxmlformats.org/drawingml/2006/main">
               <a:ext uri="{FF2B5EF4-FFF2-40B4-BE49-F238E27FC236}">
-                <a16:creationId xmlns:a16="http://schemas.microsoft.com/office/drawing/2014/main" id="{50B5CB4B-2E07-40FE-B549-467D315E2C94}"/>
+                <a16:creationId xmlns:a16="http://schemas.microsoft.com/office/drawing/2014/main" id="{CBAC845D-F0FF-4F7A-A0F9-714262D0942F}"/>
               </a:ext>
             </a:extLst>
           </p:cNvPr>
@@ -4816,7 +4816,7 @@
           <p:cNvPr id="2" name="">
             <a:extLst xmlns:a="http://schemas.openxmlformats.org/drawingml/2006/main">
               <a:ext uri="{FF2B5EF4-FFF2-40B4-BE49-F238E27FC236}">
-                <a16:creationId xmlns:a16="http://schemas.microsoft.com/office/drawing/2014/main" id="{96B5C4F5-41F9-4AFD-A608-5C58D19D3DCD}"/>
+                <a16:creationId xmlns:a16="http://schemas.microsoft.com/office/drawing/2014/main" id="{2B906D61-E159-47CF-84A2-D6F73BE54B05}"/>
               </a:ext>
             </a:extLst>
           </p:cNvPr>
@@ -4866,7 +4866,7 @@
           <p:cNvPr id="3" name="">
             <a:extLst xmlns:a="http://schemas.openxmlformats.org/drawingml/2006/main">
               <a:ext uri="{FF2B5EF4-FFF2-40B4-BE49-F238E27FC236}">
-                <a16:creationId xmlns:a16="http://schemas.microsoft.com/office/drawing/2014/main" id="{11D87E1E-D5D6-457C-9136-74F3B06C92F7}"/>
+                <a16:creationId xmlns:a16="http://schemas.microsoft.com/office/drawing/2014/main" id="{FF0F6F0C-9FE7-4E3B-A418-0E49D48B1FDE}"/>
               </a:ext>
             </a:extLst>
           </p:cNvPr>
@@ -4899,7 +4899,7 @@
           <p:cNvPr id="4" name="">
             <a:extLst xmlns:a="http://schemas.openxmlformats.org/drawingml/2006/main">
               <a:ext uri="{FF2B5EF4-FFF2-40B4-BE49-F238E27FC236}">
-                <a16:creationId xmlns:a16="http://schemas.microsoft.com/office/drawing/2014/main" id="{01B7E728-0EAE-49D6-9C89-1FDC8D7B3430}"/>
+                <a16:creationId xmlns:a16="http://schemas.microsoft.com/office/drawing/2014/main" id="{29F514FA-2CE8-42C5-A697-8C4AB681340A}"/>
               </a:ext>
             </a:extLst>
           </p:cNvPr>
@@ -4953,7 +4953,7 @@
           <p:nvPr/>
         </p:nvPicPr>
         <p:blipFill>
-          <a:blip xmlns:r="http://schemas.openxmlformats.org/officeDocument/2006/relationships" xmlns:a="http://schemas.openxmlformats.org/drawingml/2006/main" r:embed="R44940296fdcb49ed"/>
+          <a:blip xmlns:r="http://schemas.openxmlformats.org/officeDocument/2006/relationships" xmlns:a="http://schemas.openxmlformats.org/drawingml/2006/main" r:embed="R12b62ad3ffc7482e"/>
           <a:srcRect xmlns:a="http://schemas.openxmlformats.org/drawingml/2006/main" l="0" t="334" r="0" b="334"/>
           <a:stretch xmlns:a="http://schemas.openxmlformats.org/drawingml/2006/main">
             <a:fillRect l="0" t="0" r="0" b="0"/>
@@ -4980,7 +4980,7 @@
           <p:nvPr/>
         </p:nvPicPr>
         <p:blipFill>
-          <a:blip xmlns:r="http://schemas.openxmlformats.org/officeDocument/2006/relationships" xmlns:a="http://schemas.openxmlformats.org/drawingml/2006/main" r:embed="R211613976f23407e"/>
+          <a:blip xmlns:r="http://schemas.openxmlformats.org/officeDocument/2006/relationships" xmlns:a="http://schemas.openxmlformats.org/drawingml/2006/main" r:embed="R5f895669f6644fda"/>
           <a:srcRect xmlns:a="http://schemas.openxmlformats.org/drawingml/2006/main" l="0" t="334" r="0" b="334"/>
           <a:stretch xmlns:a="http://schemas.openxmlformats.org/drawingml/2006/main">
             <a:fillRect l="0" t="0" r="0" b="0"/>
@@ -5003,7 +5003,7 @@
           <p:cNvPr id="7" name="">
             <a:extLst xmlns:a="http://schemas.openxmlformats.org/drawingml/2006/main">
               <a:ext uri="{FF2B5EF4-FFF2-40B4-BE49-F238E27FC236}">
-                <a16:creationId xmlns:a16="http://schemas.microsoft.com/office/drawing/2014/main" id="{55954710-1B92-4A49-B226-A09D9CE98E4C}"/>
+                <a16:creationId xmlns:a16="http://schemas.microsoft.com/office/drawing/2014/main" id="{31FB17B6-E0C9-45ED-9FEC-97D089A0F71B}"/>
               </a:ext>
             </a:extLst>
           </p:cNvPr>
@@ -5051,7 +5051,7 @@
     </p:spTree>
     <p:extLst>
       <p:ext uri="{BB962C8B-B14F-4D97-AF65-F5344CB8AC3E}">
-        <p14:creationId xmlns:p14="http://schemas.microsoft.com/office/powerpoint/2010/main" val="1523527808"/>
+        <p14:creationId xmlns:p14="http://schemas.microsoft.com/office/powerpoint/2010/main" val="399741120"/>
       </p:ext>
     </p:extLst>
   </p:cSld>
@@ -5082,7 +5082,7 @@
           <p:cNvPr id="1" name="">
             <a:extLst xmlns:a="http://schemas.openxmlformats.org/drawingml/2006/main">
               <a:ext uri="{FF2B5EF4-FFF2-40B4-BE49-F238E27FC236}">
-                <a16:creationId xmlns:a16="http://schemas.microsoft.com/office/drawing/2014/main" id="{1ED694EE-66F0-4D7D-9FA7-5D0091B17979}"/>
+                <a16:creationId xmlns:a16="http://schemas.microsoft.com/office/drawing/2014/main" id="{B268F278-08B6-4264-8EC9-D3A6C6BFC830}"/>
               </a:ext>
             </a:extLst>
           </p:cNvPr>
@@ -5132,7 +5132,7 @@
           <p:cNvPr id="2" name="">
             <a:extLst xmlns:a="http://schemas.openxmlformats.org/drawingml/2006/main">
               <a:ext uri="{FF2B5EF4-FFF2-40B4-BE49-F238E27FC236}">
-                <a16:creationId xmlns:a16="http://schemas.microsoft.com/office/drawing/2014/main" id="{DB2FEA36-5C37-4217-935B-0DD733B15C9F}"/>
+                <a16:creationId xmlns:a16="http://schemas.microsoft.com/office/drawing/2014/main" id="{E2467210-DBF9-49B8-80A6-972053594E1F}"/>
               </a:ext>
             </a:extLst>
           </p:cNvPr>
@@ -5182,7 +5182,7 @@
           <p:cNvPr id="3" name="">
             <a:extLst xmlns:a="http://schemas.openxmlformats.org/drawingml/2006/main">
               <a:ext uri="{FF2B5EF4-FFF2-40B4-BE49-F238E27FC236}">
-                <a16:creationId xmlns:a16="http://schemas.microsoft.com/office/drawing/2014/main" id="{40704C8C-36B0-4D7D-AF6B-5315E48CE38B}"/>
+                <a16:creationId xmlns:a16="http://schemas.microsoft.com/office/drawing/2014/main" id="{63683A47-40D1-4517-9F52-96BC30E16D23}"/>
               </a:ext>
             </a:extLst>
           </p:cNvPr>
@@ -5215,7 +5215,7 @@
           <p:cNvPr id="4" name="">
             <a:extLst xmlns:a="http://schemas.openxmlformats.org/drawingml/2006/main">
               <a:ext uri="{FF2B5EF4-FFF2-40B4-BE49-F238E27FC236}">
-                <a16:creationId xmlns:a16="http://schemas.microsoft.com/office/drawing/2014/main" id="{B8436EDD-9FBA-4E7C-B554-E74558D254E1}"/>
+                <a16:creationId xmlns:a16="http://schemas.microsoft.com/office/drawing/2014/main" id="{1A685BB4-CAC5-4C2D-AF6B-794B3F0F65F9}"/>
               </a:ext>
             </a:extLst>
           </p:cNvPr>
@@ -5265,7 +5265,7 @@
           <p:cNvPr id="5" name="">
             <a:extLst xmlns:a="http://schemas.openxmlformats.org/drawingml/2006/main">
               <a:ext uri="{FF2B5EF4-FFF2-40B4-BE49-F238E27FC236}">
-                <a16:creationId xmlns:a16="http://schemas.microsoft.com/office/drawing/2014/main" id="{DC1CA2E4-39E9-4F18-BECA-11C316F15303}"/>
+                <a16:creationId xmlns:a16="http://schemas.microsoft.com/office/drawing/2014/main" id="{D9FC2C9A-629D-434C-9610-8F1FC59A7435}"/>
               </a:ext>
             </a:extLst>
           </p:cNvPr>
@@ -5298,7 +5298,7 @@
           <p:cNvPr id="6" name="">
             <a:extLst xmlns:a="http://schemas.openxmlformats.org/drawingml/2006/main">
               <a:ext uri="{FF2B5EF4-FFF2-40B4-BE49-F238E27FC236}">
-                <a16:creationId xmlns:a16="http://schemas.microsoft.com/office/drawing/2014/main" id="{4AAE157C-125B-4D0E-B3BC-EFEC9B441894}"/>
+                <a16:creationId xmlns:a16="http://schemas.microsoft.com/office/drawing/2014/main" id="{12FEC1F8-C959-47FA-9A27-65584FD8A2EE}"/>
               </a:ext>
             </a:extLst>
           </p:cNvPr>
@@ -5348,7 +5348,7 @@
           <p:cNvPr id="7" name="">
             <a:extLst xmlns:a="http://schemas.openxmlformats.org/drawingml/2006/main">
               <a:ext uri="{FF2B5EF4-FFF2-40B4-BE49-F238E27FC236}">
-                <a16:creationId xmlns:a16="http://schemas.microsoft.com/office/drawing/2014/main" id="{0DAD13CC-0CEF-409F-ADE6-2E179C774F5F}"/>
+                <a16:creationId xmlns:a16="http://schemas.microsoft.com/office/drawing/2014/main" id="{D5B7744C-13AB-40C8-81E8-18C82A27389A}"/>
               </a:ext>
             </a:extLst>
           </p:cNvPr>
@@ -5381,7 +5381,7 @@
           <p:cNvPr id="8" name="">
             <a:extLst xmlns:a="http://schemas.openxmlformats.org/drawingml/2006/main">
               <a:ext uri="{FF2B5EF4-FFF2-40B4-BE49-F238E27FC236}">
-                <a16:creationId xmlns:a16="http://schemas.microsoft.com/office/drawing/2014/main" id="{F0D117B5-6321-4CFC-8436-A4D18C2DF76C}"/>
+                <a16:creationId xmlns:a16="http://schemas.microsoft.com/office/drawing/2014/main" id="{0D16AA10-17DC-49D9-AFF4-BD15C4FCFB0F}"/>
               </a:ext>
             </a:extLst>
           </p:cNvPr>
@@ -5431,7 +5431,7 @@
           <p:cNvPr id="9" name="">
             <a:extLst xmlns:a="http://schemas.openxmlformats.org/drawingml/2006/main">
               <a:ext uri="{FF2B5EF4-FFF2-40B4-BE49-F238E27FC236}">
-                <a16:creationId xmlns:a16="http://schemas.microsoft.com/office/drawing/2014/main" id="{90E03D26-334F-4BF0-8C6F-96ED7CB92E01}"/>
+                <a16:creationId xmlns:a16="http://schemas.microsoft.com/office/drawing/2014/main" id="{36CD3ED8-43AA-4B50-AD58-F8B3B88B6E22}"/>
               </a:ext>
             </a:extLst>
           </p:cNvPr>
@@ -5464,7 +5464,7 @@
           <p:cNvPr id="10" name="">
             <a:extLst xmlns:a="http://schemas.openxmlformats.org/drawingml/2006/main">
               <a:ext uri="{FF2B5EF4-FFF2-40B4-BE49-F238E27FC236}">
-                <a16:creationId xmlns:a16="http://schemas.microsoft.com/office/drawing/2014/main" id="{56350B15-651F-4F8F-B182-24823AD579C9}"/>
+                <a16:creationId xmlns:a16="http://schemas.microsoft.com/office/drawing/2014/main" id="{15F35675-B7B2-412E-A7BF-3FBF10D6B87B}"/>
               </a:ext>
             </a:extLst>
           </p:cNvPr>
@@ -5514,7 +5514,7 @@
           <p:cNvPr id="11" name="">
             <a:extLst xmlns:a="http://schemas.openxmlformats.org/drawingml/2006/main">
               <a:ext uri="{FF2B5EF4-FFF2-40B4-BE49-F238E27FC236}">
-                <a16:creationId xmlns:a16="http://schemas.microsoft.com/office/drawing/2014/main" id="{61800A2C-CA5D-429C-A41E-A31F16925BA6}"/>
+                <a16:creationId xmlns:a16="http://schemas.microsoft.com/office/drawing/2014/main" id="{124AFB85-3522-4243-9292-D0DAFD855EED}"/>
               </a:ext>
             </a:extLst>
           </p:cNvPr>
@@ -5547,7 +5547,7 @@
           <p:cNvPr id="12" name="">
             <a:extLst xmlns:a="http://schemas.openxmlformats.org/drawingml/2006/main">
               <a:ext uri="{FF2B5EF4-FFF2-40B4-BE49-F238E27FC236}">
-                <a16:creationId xmlns:a16="http://schemas.microsoft.com/office/drawing/2014/main" id="{6EDB1524-41DB-48A0-889C-8D2DFECF9875}"/>
+                <a16:creationId xmlns:a16="http://schemas.microsoft.com/office/drawing/2014/main" id="{C51A0393-88CA-46AA-A613-877A170BAD9C}"/>
               </a:ext>
             </a:extLst>
           </p:cNvPr>
@@ -5597,7 +5597,7 @@
           <p:cNvPr id="13" name="">
             <a:extLst xmlns:a="http://schemas.openxmlformats.org/drawingml/2006/main">
               <a:ext uri="{FF2B5EF4-FFF2-40B4-BE49-F238E27FC236}">
-                <a16:creationId xmlns:a16="http://schemas.microsoft.com/office/drawing/2014/main" id="{30A4C493-526A-487D-B6A5-B09050E8D855}"/>
+                <a16:creationId xmlns:a16="http://schemas.microsoft.com/office/drawing/2014/main" id="{5FCB8EA7-087D-4527-B347-5DE82025525E}"/>
               </a:ext>
             </a:extLst>
           </p:cNvPr>
@@ -5632,7 +5632,7 @@
           <p:cNvPr id="14" name="">
             <a:extLst xmlns:a="http://schemas.openxmlformats.org/drawingml/2006/main">
               <a:ext uri="{FF2B5EF4-FFF2-40B4-BE49-F238E27FC236}">
-                <a16:creationId xmlns:a16="http://schemas.microsoft.com/office/drawing/2014/main" id="{E4CBD594-2C34-4D9C-9D37-E2775EA32AFF}"/>
+                <a16:creationId xmlns:a16="http://schemas.microsoft.com/office/drawing/2014/main" id="{F89DD69F-6870-4DD3-8DE0-1DD8EBA32BD2}"/>
               </a:ext>
             </a:extLst>
           </p:cNvPr>
@@ -5680,7 +5680,7 @@
     </p:spTree>
     <p:extLst>
       <p:ext uri="{BB962C8B-B14F-4D97-AF65-F5344CB8AC3E}">
-        <p14:creationId xmlns:p14="http://schemas.microsoft.com/office/powerpoint/2010/main" val="1130644933"/>
+        <p14:creationId xmlns:p14="http://schemas.microsoft.com/office/powerpoint/2010/main" val="1962250163"/>
       </p:ext>
     </p:extLst>
   </p:cSld>

</xml_diff>

<commit_message>
Redesign demo as interactive guided tour
</commit_message>
<xml_diff>
--- a/deliverables/SHORIR_AI_Project_Presentation.pptx
+++ b/deliverables/SHORIR_AI_Project_Presentation.pptx
@@ -2,20 +2,20 @@
 <file path=ppt/presentation.xml><?xml version="1.0" encoding="utf-8"?>
 <p:presentation xmlns:p="http://schemas.openxmlformats.org/presentationml/2006/main">
   <p:sldMasterIdLst>
-    <p:sldMasterId xmlns:r="http://schemas.openxmlformats.org/officeDocument/2006/relationships" id="2147483648" r:id="R4140506ff0e34a1f"/>
+    <p:sldMasterId xmlns:r="http://schemas.openxmlformats.org/officeDocument/2006/relationships" id="2147483648" r:id="R06a44d3452e54995"/>
   </p:sldMasterIdLst>
   <p:notesMasterIdLst>
-    <p:notesMasterId xmlns:r="http://schemas.openxmlformats.org/officeDocument/2006/relationships" r:id="R65b948e3a2a74c4d"/>
+    <p:notesMasterId xmlns:r="http://schemas.openxmlformats.org/officeDocument/2006/relationships" r:id="Rac7b705bc0fe40b0"/>
   </p:notesMasterIdLst>
   <p:sldIdLst>
-    <p:sldId xmlns:r="http://schemas.openxmlformats.org/officeDocument/2006/relationships" id="256" r:id="R80144df60a0a4a57"/>
-    <p:sldId xmlns:r="http://schemas.openxmlformats.org/officeDocument/2006/relationships" id="257" r:id="R849f2bff6c7b4ee9"/>
-    <p:sldId xmlns:r="http://schemas.openxmlformats.org/officeDocument/2006/relationships" id="258" r:id="R334c9f40c1cc4348"/>
-    <p:sldId xmlns:r="http://schemas.openxmlformats.org/officeDocument/2006/relationships" id="259" r:id="R249fe59e5000402d"/>
-    <p:sldId xmlns:r="http://schemas.openxmlformats.org/officeDocument/2006/relationships" id="260" r:id="R6d9c6f271b014999"/>
-    <p:sldId xmlns:r="http://schemas.openxmlformats.org/officeDocument/2006/relationships" id="261" r:id="R28c55688216c4000"/>
-    <p:sldId xmlns:r="http://schemas.openxmlformats.org/officeDocument/2006/relationships" id="262" r:id="R68e62f34ad8c46a2"/>
-    <p:sldId xmlns:r="http://schemas.openxmlformats.org/officeDocument/2006/relationships" id="263" r:id="Rb47240e9c26643a8"/>
+    <p:sldId xmlns:r="http://schemas.openxmlformats.org/officeDocument/2006/relationships" id="256" r:id="R48484a3eb36a496a"/>
+    <p:sldId xmlns:r="http://schemas.openxmlformats.org/officeDocument/2006/relationships" id="257" r:id="Rc7c696212e94406c"/>
+    <p:sldId xmlns:r="http://schemas.openxmlformats.org/officeDocument/2006/relationships" id="258" r:id="R0291c5e5788d4e5a"/>
+    <p:sldId xmlns:r="http://schemas.openxmlformats.org/officeDocument/2006/relationships" id="259" r:id="R855933dc3c0a4b70"/>
+    <p:sldId xmlns:r="http://schemas.openxmlformats.org/officeDocument/2006/relationships" id="260" r:id="R00b7f3f944ac4bfb"/>
+    <p:sldId xmlns:r="http://schemas.openxmlformats.org/officeDocument/2006/relationships" id="261" r:id="R6d0bda3c58894f96"/>
+    <p:sldId xmlns:r="http://schemas.openxmlformats.org/officeDocument/2006/relationships" id="262" r:id="Rbd0ed8e2225f4c38"/>
+    <p:sldId xmlns:r="http://schemas.openxmlformats.org/officeDocument/2006/relationships" id="263" r:id="Rcf1ee6fff958435f"/>
   </p:sldIdLst>
   <p:sldSz cx="12192000" cy="6858000"/>
   <p:notesSz cx="6858000" cy="9144000"/>
@@ -1070,7 +1070,7 @@
   </p:cSld>
   <p:clrMap bg1="lt1" tx1="dk1" bg2="lt2" tx2="dk2" accent1="accent1" accent2="accent2" accent3="accent3" accent4="accent4" accent5="accent5" accent6="accent6" hlink="hlink" folHlink="folHlink"/>
   <p:sldLayoutIdLst>
-    <p:sldLayoutId xmlns:r="http://schemas.openxmlformats.org/officeDocument/2006/relationships" id="2147483649" r:id="R693c0b0bedf84899"/>
+    <p:sldLayoutId xmlns:r="http://schemas.openxmlformats.org/officeDocument/2006/relationships" id="2147483649" r:id="Rc918627e2bc742d7"/>
   </p:sldLayoutIdLst>
   <p:txStyles>
     <p:titleStyle>
@@ -1621,7 +1621,7 @@
           <p:cNvPr id="1" name="">
             <a:extLst xmlns:a="http://schemas.openxmlformats.org/drawingml/2006/main">
               <a:ext uri="{FF2B5EF4-FFF2-40B4-BE49-F238E27FC236}">
-                <a16:creationId xmlns:a16="http://schemas.microsoft.com/office/drawing/2014/main" id="{3D118DFD-B70C-436D-9069-85EA3879797D}"/>
+                <a16:creationId xmlns:a16="http://schemas.microsoft.com/office/drawing/2014/main" id="{95E01367-A256-41C1-A81E-24AA8DC267FB}"/>
               </a:ext>
             </a:extLst>
           </p:cNvPr>
@@ -1671,7 +1671,7 @@
           <p:cNvPr id="2" name="">
             <a:extLst xmlns:a="http://schemas.openxmlformats.org/drawingml/2006/main">
               <a:ext uri="{FF2B5EF4-FFF2-40B4-BE49-F238E27FC236}">
-                <a16:creationId xmlns:a16="http://schemas.microsoft.com/office/drawing/2014/main" id="{383EAE7E-AB3B-41B7-B4FC-3E17ED3C60C7}"/>
+                <a16:creationId xmlns:a16="http://schemas.microsoft.com/office/drawing/2014/main" id="{4300ED2E-53F8-4081-A3ED-8BE066142AFF}"/>
               </a:ext>
             </a:extLst>
           </p:cNvPr>
@@ -1721,7 +1721,7 @@
           <p:cNvPr id="3" name="">
             <a:extLst xmlns:a="http://schemas.openxmlformats.org/drawingml/2006/main">
               <a:ext uri="{FF2B5EF4-FFF2-40B4-BE49-F238E27FC236}">
-                <a16:creationId xmlns:a16="http://schemas.microsoft.com/office/drawing/2014/main" id="{D56D2DF0-6531-439B-A842-A3604703F337}"/>
+                <a16:creationId xmlns:a16="http://schemas.microsoft.com/office/drawing/2014/main" id="{9D7B107C-ADF1-46B6-8670-74B5FA0C9796}"/>
               </a:ext>
             </a:extLst>
           </p:cNvPr>
@@ -1771,7 +1771,7 @@
           <p:cNvPr id="4" name="">
             <a:extLst xmlns:a="http://schemas.openxmlformats.org/drawingml/2006/main">
               <a:ext uri="{FF2B5EF4-FFF2-40B4-BE49-F238E27FC236}">
-                <a16:creationId xmlns:a16="http://schemas.microsoft.com/office/drawing/2014/main" id="{70B0B559-5FEF-4BCD-9676-1BB9B244AEB5}"/>
+                <a16:creationId xmlns:a16="http://schemas.microsoft.com/office/drawing/2014/main" id="{0D6BB137-A13C-46B5-BD65-9639822CF2CF}"/>
               </a:ext>
             </a:extLst>
           </p:cNvPr>
@@ -1810,7 +1810,7 @@
           <p:nvPr/>
         </p:nvPicPr>
         <p:blipFill>
-          <a:blip xmlns:r="http://schemas.openxmlformats.org/officeDocument/2006/relationships" xmlns:a="http://schemas.openxmlformats.org/drawingml/2006/main" r:embed="R57017dac3e074e53"/>
+          <a:blip xmlns:r="http://schemas.openxmlformats.org/officeDocument/2006/relationships" xmlns:a="http://schemas.openxmlformats.org/drawingml/2006/main" r:embed="Re1925ff221324acf"/>
           <a:srcRect xmlns:a="http://schemas.openxmlformats.org/drawingml/2006/main" l="12678" t="0" r="12678" b="0"/>
           <a:stretch xmlns:a="http://schemas.openxmlformats.org/drawingml/2006/main">
             <a:fillRect l="0" t="0" r="0" b="0"/>
@@ -1833,7 +1833,7 @@
           <p:cNvPr id="6" name="">
             <a:extLst xmlns:a="http://schemas.openxmlformats.org/drawingml/2006/main">
               <a:ext uri="{FF2B5EF4-FFF2-40B4-BE49-F238E27FC236}">
-                <a16:creationId xmlns:a16="http://schemas.microsoft.com/office/drawing/2014/main" id="{E416547B-CD51-497B-9E91-6154FD8A741F}"/>
+                <a16:creationId xmlns:a16="http://schemas.microsoft.com/office/drawing/2014/main" id="{B69AC76E-0D33-4A86-ADF4-0F8C1141B8A1}"/>
               </a:ext>
             </a:extLst>
           </p:cNvPr>
@@ -1881,7 +1881,7 @@
     </p:spTree>
     <p:extLst>
       <p:ext uri="{BB962C8B-B14F-4D97-AF65-F5344CB8AC3E}">
-        <p14:creationId xmlns:p14="http://schemas.microsoft.com/office/powerpoint/2010/main" val="560745568"/>
+        <p14:creationId xmlns:p14="http://schemas.microsoft.com/office/powerpoint/2010/main" val="906194732"/>
       </p:ext>
     </p:extLst>
   </p:cSld>
@@ -1912,7 +1912,7 @@
           <p:cNvPr id="1" name="">
             <a:extLst xmlns:a="http://schemas.openxmlformats.org/drawingml/2006/main">
               <a:ext uri="{FF2B5EF4-FFF2-40B4-BE49-F238E27FC236}">
-                <a16:creationId xmlns:a16="http://schemas.microsoft.com/office/drawing/2014/main" id="{4BB5B64B-8857-43A3-B303-33AEC4803011}"/>
+                <a16:creationId xmlns:a16="http://schemas.microsoft.com/office/drawing/2014/main" id="{450B1EC4-F44C-4751-A26D-6C4A50CFCC83}"/>
               </a:ext>
             </a:extLst>
           </p:cNvPr>
@@ -1962,7 +1962,7 @@
           <p:cNvPr id="2" name="">
             <a:extLst xmlns:a="http://schemas.openxmlformats.org/drawingml/2006/main">
               <a:ext uri="{FF2B5EF4-FFF2-40B4-BE49-F238E27FC236}">
-                <a16:creationId xmlns:a16="http://schemas.microsoft.com/office/drawing/2014/main" id="{67B42BA1-314B-4846-8151-019121B5B00F}"/>
+                <a16:creationId xmlns:a16="http://schemas.microsoft.com/office/drawing/2014/main" id="{EB4D3C8B-2699-415E-B50B-6415F795B457}"/>
               </a:ext>
             </a:extLst>
           </p:cNvPr>
@@ -2012,7 +2012,7 @@
           <p:cNvPr id="3" name="">
             <a:extLst xmlns:a="http://schemas.openxmlformats.org/drawingml/2006/main">
               <a:ext uri="{FF2B5EF4-FFF2-40B4-BE49-F238E27FC236}">
-                <a16:creationId xmlns:a16="http://schemas.microsoft.com/office/drawing/2014/main" id="{0A0702D4-55C7-4CBB-BB8B-E67DF021A8B9}"/>
+                <a16:creationId xmlns:a16="http://schemas.microsoft.com/office/drawing/2014/main" id="{9BCD1B04-9DCF-4BC5-97CE-BCC3317F45CB}"/>
               </a:ext>
             </a:extLst>
           </p:cNvPr>
@@ -2045,7 +2045,7 @@
           <p:cNvPr id="4" name="">
             <a:extLst xmlns:a="http://schemas.openxmlformats.org/drawingml/2006/main">
               <a:ext uri="{FF2B5EF4-FFF2-40B4-BE49-F238E27FC236}">
-                <a16:creationId xmlns:a16="http://schemas.microsoft.com/office/drawing/2014/main" id="{126CC376-44E2-49CC-93ED-8030476F7E77}"/>
+                <a16:creationId xmlns:a16="http://schemas.microsoft.com/office/drawing/2014/main" id="{A8630F4B-7AC7-4351-9A2A-C0521D38E67C}"/>
               </a:ext>
             </a:extLst>
           </p:cNvPr>
@@ -2095,7 +2095,7 @@
           <p:cNvPr id="5" name="">
             <a:extLst xmlns:a="http://schemas.openxmlformats.org/drawingml/2006/main">
               <a:ext uri="{FF2B5EF4-FFF2-40B4-BE49-F238E27FC236}">
-                <a16:creationId xmlns:a16="http://schemas.microsoft.com/office/drawing/2014/main" id="{5B5DAFBD-0297-4557-BDE4-B2F28997D920}"/>
+                <a16:creationId xmlns:a16="http://schemas.microsoft.com/office/drawing/2014/main" id="{F5168F10-7BEA-4426-A062-2C738A080382}"/>
               </a:ext>
             </a:extLst>
           </p:cNvPr>
@@ -2128,7 +2128,7 @@
           <p:cNvPr id="6" name="">
             <a:extLst xmlns:a="http://schemas.openxmlformats.org/drawingml/2006/main">
               <a:ext uri="{FF2B5EF4-FFF2-40B4-BE49-F238E27FC236}">
-                <a16:creationId xmlns:a16="http://schemas.microsoft.com/office/drawing/2014/main" id="{B9EBB176-386C-46A2-883D-699A5F9FF4C8}"/>
+                <a16:creationId xmlns:a16="http://schemas.microsoft.com/office/drawing/2014/main" id="{FCB706C7-FC8F-452F-A5EC-E7346AFE1090}"/>
               </a:ext>
             </a:extLst>
           </p:cNvPr>
@@ -2178,7 +2178,7 @@
           <p:cNvPr id="7" name="">
             <a:extLst xmlns:a="http://schemas.openxmlformats.org/drawingml/2006/main">
               <a:ext uri="{FF2B5EF4-FFF2-40B4-BE49-F238E27FC236}">
-                <a16:creationId xmlns:a16="http://schemas.microsoft.com/office/drawing/2014/main" id="{5B1A6A11-8495-4032-9820-A9C436DEAC48}"/>
+                <a16:creationId xmlns:a16="http://schemas.microsoft.com/office/drawing/2014/main" id="{A4D3C061-0D86-4D38-BD44-03C68DCCF186}"/>
               </a:ext>
             </a:extLst>
           </p:cNvPr>
@@ -2211,7 +2211,7 @@
           <p:cNvPr id="8" name="">
             <a:extLst xmlns:a="http://schemas.openxmlformats.org/drawingml/2006/main">
               <a:ext uri="{FF2B5EF4-FFF2-40B4-BE49-F238E27FC236}">
-                <a16:creationId xmlns:a16="http://schemas.microsoft.com/office/drawing/2014/main" id="{9E8D41DF-007E-4E4F-98D9-D9DBAADDAA81}"/>
+                <a16:creationId xmlns:a16="http://schemas.microsoft.com/office/drawing/2014/main" id="{AB300499-2CD7-4E29-86D5-89DC45C45A57}"/>
               </a:ext>
             </a:extLst>
           </p:cNvPr>
@@ -2261,7 +2261,7 @@
           <p:cNvPr id="9" name="">
             <a:extLst xmlns:a="http://schemas.openxmlformats.org/drawingml/2006/main">
               <a:ext uri="{FF2B5EF4-FFF2-40B4-BE49-F238E27FC236}">
-                <a16:creationId xmlns:a16="http://schemas.microsoft.com/office/drawing/2014/main" id="{C6198442-29C6-4A8E-83BD-61EC5C262081}"/>
+                <a16:creationId xmlns:a16="http://schemas.microsoft.com/office/drawing/2014/main" id="{DF0F8DDD-C518-44DA-AE9D-AEAB1BE0303A}"/>
               </a:ext>
             </a:extLst>
           </p:cNvPr>
@@ -2294,7 +2294,7 @@
           <p:cNvPr id="10" name="">
             <a:extLst xmlns:a="http://schemas.openxmlformats.org/drawingml/2006/main">
               <a:ext uri="{FF2B5EF4-FFF2-40B4-BE49-F238E27FC236}">
-                <a16:creationId xmlns:a16="http://schemas.microsoft.com/office/drawing/2014/main" id="{D55ED78A-F8FF-42CE-B2F1-EABBA137608E}"/>
+                <a16:creationId xmlns:a16="http://schemas.microsoft.com/office/drawing/2014/main" id="{6EADE638-DD39-406D-9D48-D1355AA899B9}"/>
               </a:ext>
             </a:extLst>
           </p:cNvPr>
@@ -2344,7 +2344,7 @@
           <p:cNvPr id="11" name="">
             <a:extLst xmlns:a="http://schemas.openxmlformats.org/drawingml/2006/main">
               <a:ext uri="{FF2B5EF4-FFF2-40B4-BE49-F238E27FC236}">
-                <a16:creationId xmlns:a16="http://schemas.microsoft.com/office/drawing/2014/main" id="{39AF00FF-9324-47C9-81AD-D26BCDFAA7B3}"/>
+                <a16:creationId xmlns:a16="http://schemas.microsoft.com/office/drawing/2014/main" id="{DCDFFF14-7928-42A3-A8E8-0DAFD871B4B5}"/>
               </a:ext>
             </a:extLst>
           </p:cNvPr>
@@ -2379,7 +2379,7 @@
           <p:cNvPr id="12" name="">
             <a:extLst xmlns:a="http://schemas.openxmlformats.org/drawingml/2006/main">
               <a:ext uri="{FF2B5EF4-FFF2-40B4-BE49-F238E27FC236}">
-                <a16:creationId xmlns:a16="http://schemas.microsoft.com/office/drawing/2014/main" id="{F23458E9-5EB1-4CE9-8051-2D69C9669846}"/>
+                <a16:creationId xmlns:a16="http://schemas.microsoft.com/office/drawing/2014/main" id="{B2CE6259-7AB1-4DCA-BC86-612A48EF428F}"/>
               </a:ext>
             </a:extLst>
           </p:cNvPr>
@@ -2429,7 +2429,7 @@
           <p:cNvPr id="13" name="">
             <a:extLst xmlns:a="http://schemas.openxmlformats.org/drawingml/2006/main">
               <a:ext uri="{FF2B5EF4-FFF2-40B4-BE49-F238E27FC236}">
-                <a16:creationId xmlns:a16="http://schemas.microsoft.com/office/drawing/2014/main" id="{8B2B8CB3-C8AA-4F70-A589-29AB4F48EF88}"/>
+                <a16:creationId xmlns:a16="http://schemas.microsoft.com/office/drawing/2014/main" id="{F9F40EE2-14D4-4481-96AE-FD71DE0B224A}"/>
               </a:ext>
             </a:extLst>
           </p:cNvPr>
@@ -2477,7 +2477,7 @@
     </p:spTree>
     <p:extLst>
       <p:ext uri="{BB962C8B-B14F-4D97-AF65-F5344CB8AC3E}">
-        <p14:creationId xmlns:p14="http://schemas.microsoft.com/office/powerpoint/2010/main" val="1447024364"/>
+        <p14:creationId xmlns:p14="http://schemas.microsoft.com/office/powerpoint/2010/main" val="1622649426"/>
       </p:ext>
     </p:extLst>
   </p:cSld>
@@ -2508,7 +2508,7 @@
           <p:cNvPr id="1" name="">
             <a:extLst xmlns:a="http://schemas.openxmlformats.org/drawingml/2006/main">
               <a:ext uri="{FF2B5EF4-FFF2-40B4-BE49-F238E27FC236}">
-                <a16:creationId xmlns:a16="http://schemas.microsoft.com/office/drawing/2014/main" id="{3CEC2ED8-29A3-403B-A38B-15EB28FF3786}"/>
+                <a16:creationId xmlns:a16="http://schemas.microsoft.com/office/drawing/2014/main" id="{E588C220-7BF3-45B4-AF89-3BE5D5EBC400}"/>
               </a:ext>
             </a:extLst>
           </p:cNvPr>
@@ -2558,7 +2558,7 @@
           <p:cNvPr id="2" name="">
             <a:extLst xmlns:a="http://schemas.openxmlformats.org/drawingml/2006/main">
               <a:ext uri="{FF2B5EF4-FFF2-40B4-BE49-F238E27FC236}">
-                <a16:creationId xmlns:a16="http://schemas.microsoft.com/office/drawing/2014/main" id="{1997893D-A3E2-44DE-BD84-53B4ACDE1615}"/>
+                <a16:creationId xmlns:a16="http://schemas.microsoft.com/office/drawing/2014/main" id="{F2C4F286-4DDE-4E8A-9A36-90C8A39A2D13}"/>
               </a:ext>
             </a:extLst>
           </p:cNvPr>
@@ -2608,7 +2608,7 @@
           <p:cNvPr id="3" name="">
             <a:extLst xmlns:a="http://schemas.openxmlformats.org/drawingml/2006/main">
               <a:ext uri="{FF2B5EF4-FFF2-40B4-BE49-F238E27FC236}">
-                <a16:creationId xmlns:a16="http://schemas.microsoft.com/office/drawing/2014/main" id="{C79D81C9-1FE6-4485-9619-A62A2FE867D0}"/>
+                <a16:creationId xmlns:a16="http://schemas.microsoft.com/office/drawing/2014/main" id="{7DB269BD-4B05-43CF-85D8-A1C209C992F1}"/>
               </a:ext>
             </a:extLst>
           </p:cNvPr>
@@ -2641,7 +2641,7 @@
           <p:cNvPr id="4" name="">
             <a:extLst xmlns:a="http://schemas.openxmlformats.org/drawingml/2006/main">
               <a:ext uri="{FF2B5EF4-FFF2-40B4-BE49-F238E27FC236}">
-                <a16:creationId xmlns:a16="http://schemas.microsoft.com/office/drawing/2014/main" id="{921F7EB7-867B-4B4E-9B6A-FB4563143555}"/>
+                <a16:creationId xmlns:a16="http://schemas.microsoft.com/office/drawing/2014/main" id="{CB25D34F-1986-4E92-AC49-519C62195B86}"/>
               </a:ext>
             </a:extLst>
           </p:cNvPr>
@@ -2691,7 +2691,7 @@
           <p:cNvPr id="5" name="">
             <a:extLst xmlns:a="http://schemas.openxmlformats.org/drawingml/2006/main">
               <a:ext uri="{FF2B5EF4-FFF2-40B4-BE49-F238E27FC236}">
-                <a16:creationId xmlns:a16="http://schemas.microsoft.com/office/drawing/2014/main" id="{53051EB5-BD16-4D1F-B3EC-59C2320761BB}"/>
+                <a16:creationId xmlns:a16="http://schemas.microsoft.com/office/drawing/2014/main" id="{AADC26E0-C3E8-4562-810B-1B45E516668D}"/>
               </a:ext>
             </a:extLst>
           </p:cNvPr>
@@ -2726,7 +2726,7 @@
           <p:cNvPr id="6" name="">
             <a:extLst xmlns:a="http://schemas.openxmlformats.org/drawingml/2006/main">
               <a:ext uri="{FF2B5EF4-FFF2-40B4-BE49-F238E27FC236}">
-                <a16:creationId xmlns:a16="http://schemas.microsoft.com/office/drawing/2014/main" id="{227EE3B6-0970-43A1-86AA-6A0262038429}"/>
+                <a16:creationId xmlns:a16="http://schemas.microsoft.com/office/drawing/2014/main" id="{7AF09C30-7FBB-4457-9EB8-10C98C67337A}"/>
               </a:ext>
             </a:extLst>
           </p:cNvPr>
@@ -2776,7 +2776,7 @@
           <p:cNvPr id="7" name="">
             <a:extLst xmlns:a="http://schemas.openxmlformats.org/drawingml/2006/main">
               <a:ext uri="{FF2B5EF4-FFF2-40B4-BE49-F238E27FC236}">
-                <a16:creationId xmlns:a16="http://schemas.microsoft.com/office/drawing/2014/main" id="{32A59D1F-54EB-4367-B886-30A9FAFF5C3F}"/>
+                <a16:creationId xmlns:a16="http://schemas.microsoft.com/office/drawing/2014/main" id="{44B28240-C55D-4CFA-9885-B95C2FA5C0A4}"/>
               </a:ext>
             </a:extLst>
           </p:cNvPr>
@@ -2826,7 +2826,7 @@
           <p:cNvPr id="8" name="">
             <a:extLst xmlns:a="http://schemas.openxmlformats.org/drawingml/2006/main">
               <a:ext uri="{FF2B5EF4-FFF2-40B4-BE49-F238E27FC236}">
-                <a16:creationId xmlns:a16="http://schemas.microsoft.com/office/drawing/2014/main" id="{D04C0D02-EF6E-4610-B543-6187027D9EFB}"/>
+                <a16:creationId xmlns:a16="http://schemas.microsoft.com/office/drawing/2014/main" id="{01B7E37D-2B30-46A3-A455-E052AD665891}"/>
               </a:ext>
             </a:extLst>
           </p:cNvPr>
@@ -2861,7 +2861,7 @@
           <p:cNvPr id="9" name="">
             <a:extLst xmlns:a="http://schemas.openxmlformats.org/drawingml/2006/main">
               <a:ext uri="{FF2B5EF4-FFF2-40B4-BE49-F238E27FC236}">
-                <a16:creationId xmlns:a16="http://schemas.microsoft.com/office/drawing/2014/main" id="{17FC9CE1-698D-474E-A68C-7853F45892D7}"/>
+                <a16:creationId xmlns:a16="http://schemas.microsoft.com/office/drawing/2014/main" id="{B1BCF881-762C-4B7A-B458-55511B275A0F}"/>
               </a:ext>
             </a:extLst>
           </p:cNvPr>
@@ -2911,7 +2911,7 @@
           <p:cNvPr id="10" name="">
             <a:extLst xmlns:a="http://schemas.openxmlformats.org/drawingml/2006/main">
               <a:ext uri="{FF2B5EF4-FFF2-40B4-BE49-F238E27FC236}">
-                <a16:creationId xmlns:a16="http://schemas.microsoft.com/office/drawing/2014/main" id="{8F792B1D-3E7C-48A6-B75E-7C1DD3F90B54}"/>
+                <a16:creationId xmlns:a16="http://schemas.microsoft.com/office/drawing/2014/main" id="{F917D029-50A7-4C90-AA66-5089C6FFEAB9}"/>
               </a:ext>
             </a:extLst>
           </p:cNvPr>
@@ -2961,7 +2961,7 @@
           <p:cNvPr id="11" name="">
             <a:extLst xmlns:a="http://schemas.openxmlformats.org/drawingml/2006/main">
               <a:ext uri="{FF2B5EF4-FFF2-40B4-BE49-F238E27FC236}">
-                <a16:creationId xmlns:a16="http://schemas.microsoft.com/office/drawing/2014/main" id="{36541A72-9CF4-4CD5-8ECE-144F8D968DC6}"/>
+                <a16:creationId xmlns:a16="http://schemas.microsoft.com/office/drawing/2014/main" id="{5DE122BB-409B-4F93-937E-6A45A7E11C18}"/>
               </a:ext>
             </a:extLst>
           </p:cNvPr>
@@ -2996,7 +2996,7 @@
           <p:cNvPr id="12" name="">
             <a:extLst xmlns:a="http://schemas.openxmlformats.org/drawingml/2006/main">
               <a:ext uri="{FF2B5EF4-FFF2-40B4-BE49-F238E27FC236}">
-                <a16:creationId xmlns:a16="http://schemas.microsoft.com/office/drawing/2014/main" id="{C06831EE-8959-4541-8B76-AB40FE96F1F2}"/>
+                <a16:creationId xmlns:a16="http://schemas.microsoft.com/office/drawing/2014/main" id="{9677731B-266B-4C7E-BA14-D99A1CCA8E28}"/>
               </a:ext>
             </a:extLst>
           </p:cNvPr>
@@ -3046,7 +3046,7 @@
           <p:cNvPr id="13" name="">
             <a:extLst xmlns:a="http://schemas.openxmlformats.org/drawingml/2006/main">
               <a:ext uri="{FF2B5EF4-FFF2-40B4-BE49-F238E27FC236}">
-                <a16:creationId xmlns:a16="http://schemas.microsoft.com/office/drawing/2014/main" id="{C6E47D05-3642-4766-8E7C-3067F935CCB3}"/>
+                <a16:creationId xmlns:a16="http://schemas.microsoft.com/office/drawing/2014/main" id="{1F9E0165-906C-44AE-9259-3841EC7B5442}"/>
               </a:ext>
             </a:extLst>
           </p:cNvPr>
@@ -3096,7 +3096,7 @@
           <p:cNvPr id="14" name="">
             <a:extLst xmlns:a="http://schemas.openxmlformats.org/drawingml/2006/main">
               <a:ext uri="{FF2B5EF4-FFF2-40B4-BE49-F238E27FC236}">
-                <a16:creationId xmlns:a16="http://schemas.microsoft.com/office/drawing/2014/main" id="{176C456F-A15B-474E-898F-2359A3DCBD60}"/>
+                <a16:creationId xmlns:a16="http://schemas.microsoft.com/office/drawing/2014/main" id="{9C4BF41D-216E-467C-A846-B8D605D17264}"/>
               </a:ext>
             </a:extLst>
           </p:cNvPr>
@@ -3131,7 +3131,7 @@
           <p:cNvPr id="15" name="">
             <a:extLst xmlns:a="http://schemas.openxmlformats.org/drawingml/2006/main">
               <a:ext uri="{FF2B5EF4-FFF2-40B4-BE49-F238E27FC236}">
-                <a16:creationId xmlns:a16="http://schemas.microsoft.com/office/drawing/2014/main" id="{A04C93E8-A035-44FA-BBDF-9AC68A6A3392}"/>
+                <a16:creationId xmlns:a16="http://schemas.microsoft.com/office/drawing/2014/main" id="{66135D47-FC69-4B61-90FA-4F2AA8897298}"/>
               </a:ext>
             </a:extLst>
           </p:cNvPr>
@@ -3181,7 +3181,7 @@
           <p:cNvPr id="16" name="">
             <a:extLst xmlns:a="http://schemas.openxmlformats.org/drawingml/2006/main">
               <a:ext uri="{FF2B5EF4-FFF2-40B4-BE49-F238E27FC236}">
-                <a16:creationId xmlns:a16="http://schemas.microsoft.com/office/drawing/2014/main" id="{FDB99926-C5FD-44A9-8C37-71B574AB4D28}"/>
+                <a16:creationId xmlns:a16="http://schemas.microsoft.com/office/drawing/2014/main" id="{EB2D78BB-37AB-47D1-AC37-75DEDCB1B926}"/>
               </a:ext>
             </a:extLst>
           </p:cNvPr>
@@ -3231,7 +3231,7 @@
           <p:cNvPr id="17" name="">
             <a:extLst xmlns:a="http://schemas.openxmlformats.org/drawingml/2006/main">
               <a:ext uri="{FF2B5EF4-FFF2-40B4-BE49-F238E27FC236}">
-                <a16:creationId xmlns:a16="http://schemas.microsoft.com/office/drawing/2014/main" id="{ED97E8EB-EC8F-4895-BCE3-CF2DB0D08943}"/>
+                <a16:creationId xmlns:a16="http://schemas.microsoft.com/office/drawing/2014/main" id="{55BE6304-6F49-46E8-93BD-8E8E3B18ED03}"/>
               </a:ext>
             </a:extLst>
           </p:cNvPr>
@@ -3279,7 +3279,7 @@
     </p:spTree>
     <p:extLst>
       <p:ext uri="{BB962C8B-B14F-4D97-AF65-F5344CB8AC3E}">
-        <p14:creationId xmlns:p14="http://schemas.microsoft.com/office/powerpoint/2010/main" val="498547157"/>
+        <p14:creationId xmlns:p14="http://schemas.microsoft.com/office/powerpoint/2010/main" val="458363803"/>
       </p:ext>
     </p:extLst>
   </p:cSld>
@@ -3310,7 +3310,7 @@
           <p:cNvPr id="1" name="">
             <a:extLst xmlns:a="http://schemas.openxmlformats.org/drawingml/2006/main">
               <a:ext uri="{FF2B5EF4-FFF2-40B4-BE49-F238E27FC236}">
-                <a16:creationId xmlns:a16="http://schemas.microsoft.com/office/drawing/2014/main" id="{89CB3E27-95D7-4395-B261-EB57BAEB574D}"/>
+                <a16:creationId xmlns:a16="http://schemas.microsoft.com/office/drawing/2014/main" id="{1EAD47E6-1F2C-44DE-AEC0-8B0580D825F2}"/>
               </a:ext>
             </a:extLst>
           </p:cNvPr>
@@ -3360,7 +3360,7 @@
           <p:cNvPr id="2" name="">
             <a:extLst xmlns:a="http://schemas.openxmlformats.org/drawingml/2006/main">
               <a:ext uri="{FF2B5EF4-FFF2-40B4-BE49-F238E27FC236}">
-                <a16:creationId xmlns:a16="http://schemas.microsoft.com/office/drawing/2014/main" id="{D6129843-CB3E-48FE-8A3B-FA5DDFF669AC}"/>
+                <a16:creationId xmlns:a16="http://schemas.microsoft.com/office/drawing/2014/main" id="{2DE1EE9A-4DA0-4649-AE84-636DD89D45C4}"/>
               </a:ext>
             </a:extLst>
           </p:cNvPr>
@@ -3410,7 +3410,7 @@
           <p:cNvPr id="3" name="">
             <a:extLst xmlns:a="http://schemas.openxmlformats.org/drawingml/2006/main">
               <a:ext uri="{FF2B5EF4-FFF2-40B4-BE49-F238E27FC236}">
-                <a16:creationId xmlns:a16="http://schemas.microsoft.com/office/drawing/2014/main" id="{60E424B1-DFDC-4274-84F9-4DD32BB2F207}"/>
+                <a16:creationId xmlns:a16="http://schemas.microsoft.com/office/drawing/2014/main" id="{612E2416-8E3F-40A9-A02E-108CFD14A26A}"/>
               </a:ext>
             </a:extLst>
           </p:cNvPr>
@@ -3443,7 +3443,7 @@
           <p:cNvPr id="4" name="">
             <a:extLst xmlns:a="http://schemas.openxmlformats.org/drawingml/2006/main">
               <a:ext uri="{FF2B5EF4-FFF2-40B4-BE49-F238E27FC236}">
-                <a16:creationId xmlns:a16="http://schemas.microsoft.com/office/drawing/2014/main" id="{DD0A9F94-8DEA-4FA7-9AA3-3E74E51B0049}"/>
+                <a16:creationId xmlns:a16="http://schemas.microsoft.com/office/drawing/2014/main" id="{5E844C12-91F3-40A4-9771-C23EEA6A8476}"/>
               </a:ext>
             </a:extLst>
           </p:cNvPr>
@@ -3493,7 +3493,7 @@
           <p:cNvPr id="5" name="">
             <a:extLst xmlns:a="http://schemas.openxmlformats.org/drawingml/2006/main">
               <a:ext uri="{FF2B5EF4-FFF2-40B4-BE49-F238E27FC236}">
-                <a16:creationId xmlns:a16="http://schemas.microsoft.com/office/drawing/2014/main" id="{A0B4652A-20DD-4DF7-82AD-4CFDE742F6C2}"/>
+                <a16:creationId xmlns:a16="http://schemas.microsoft.com/office/drawing/2014/main" id="{46824491-C899-4546-806B-1954753AFC1C}"/>
               </a:ext>
             </a:extLst>
           </p:cNvPr>
@@ -3547,7 +3547,7 @@
           <p:nvPr/>
         </p:nvPicPr>
         <p:blipFill>
-          <a:blip xmlns:r="http://schemas.openxmlformats.org/officeDocument/2006/relationships" xmlns:a="http://schemas.openxmlformats.org/drawingml/2006/main" r:embed="Rb2b48505036a4c97"/>
+          <a:blip xmlns:r="http://schemas.openxmlformats.org/officeDocument/2006/relationships" xmlns:a="http://schemas.openxmlformats.org/drawingml/2006/main" r:embed="R3c5cec4f5a524cb2"/>
           <a:srcRect xmlns:a="http://schemas.openxmlformats.org/drawingml/2006/main" l="0" t="13" r="0" b="13"/>
           <a:stretch xmlns:a="http://schemas.openxmlformats.org/drawingml/2006/main">
             <a:fillRect l="0" t="0" r="0" b="0"/>
@@ -3568,7 +3568,7 @@
     </p:spTree>
     <p:extLst>
       <p:ext uri="{BB962C8B-B14F-4D97-AF65-F5344CB8AC3E}">
-        <p14:creationId xmlns:p14="http://schemas.microsoft.com/office/powerpoint/2010/main" val="954420198"/>
+        <p14:creationId xmlns:p14="http://schemas.microsoft.com/office/powerpoint/2010/main" val="1666208560"/>
       </p:ext>
     </p:extLst>
   </p:cSld>
@@ -3599,7 +3599,7 @@
           <p:cNvPr id="1" name="">
             <a:extLst xmlns:a="http://schemas.openxmlformats.org/drawingml/2006/main">
               <a:ext uri="{FF2B5EF4-FFF2-40B4-BE49-F238E27FC236}">
-                <a16:creationId xmlns:a16="http://schemas.microsoft.com/office/drawing/2014/main" id="{8FB86826-1E42-494F-B9E2-28CC68B0526A}"/>
+                <a16:creationId xmlns:a16="http://schemas.microsoft.com/office/drawing/2014/main" id="{5E5BFDC8-A1BC-4A0A-952F-A6C8C997E6BE}"/>
               </a:ext>
             </a:extLst>
           </p:cNvPr>
@@ -3649,7 +3649,7 @@
           <p:cNvPr id="2" name="">
             <a:extLst xmlns:a="http://schemas.openxmlformats.org/drawingml/2006/main">
               <a:ext uri="{FF2B5EF4-FFF2-40B4-BE49-F238E27FC236}">
-                <a16:creationId xmlns:a16="http://schemas.microsoft.com/office/drawing/2014/main" id="{0055C384-7431-4DD4-8DF2-250E4BA69B47}"/>
+                <a16:creationId xmlns:a16="http://schemas.microsoft.com/office/drawing/2014/main" id="{489D04C2-61B7-4011-BF24-52F3EA3DCF82}"/>
               </a:ext>
             </a:extLst>
           </p:cNvPr>
@@ -3699,7 +3699,7 @@
           <p:cNvPr id="3" name="">
             <a:extLst xmlns:a="http://schemas.openxmlformats.org/drawingml/2006/main">
               <a:ext uri="{FF2B5EF4-FFF2-40B4-BE49-F238E27FC236}">
-                <a16:creationId xmlns:a16="http://schemas.microsoft.com/office/drawing/2014/main" id="{C1406C06-01E8-49AF-A07C-5C8235019F67}"/>
+                <a16:creationId xmlns:a16="http://schemas.microsoft.com/office/drawing/2014/main" id="{EE6729FC-ECD5-4C14-B13F-16219F3FED07}"/>
               </a:ext>
             </a:extLst>
           </p:cNvPr>
@@ -3732,7 +3732,7 @@
           <p:cNvPr id="4" name="">
             <a:extLst xmlns:a="http://schemas.openxmlformats.org/drawingml/2006/main">
               <a:ext uri="{FF2B5EF4-FFF2-40B4-BE49-F238E27FC236}">
-                <a16:creationId xmlns:a16="http://schemas.microsoft.com/office/drawing/2014/main" id="{7A25638E-25A7-49D2-9EF2-4CCB4BBDCC85}"/>
+                <a16:creationId xmlns:a16="http://schemas.microsoft.com/office/drawing/2014/main" id="{364224CB-6AB9-4932-BF80-05121D52DF70}"/>
               </a:ext>
             </a:extLst>
           </p:cNvPr>
@@ -3744,7 +3744,7 @@
         <p:spPr>
           <a:xfrm xmlns:a="http://schemas.openxmlformats.org/drawingml/2006/main">
             <a:off x="552450" y="1066800"/>
-            <a:ext cx="5143500" cy="552450"/>
+            <a:ext cx="5143500" cy="895350"/>
           </a:xfrm>
           <a:prstGeom xmlns:a="http://schemas.openxmlformats.org/drawingml/2006/main" prst="rect">
             <a:avLst/>
@@ -3760,19 +3760,19 @@
           <a:lstStyle xmlns:a="http://schemas.openxmlformats.org/drawingml/2006/main"/>
           <a:p xmlns:a="http://schemas.openxmlformats.org/drawingml/2006/main">
             <a:pPr algn="l">
-              <a:defRPr sz="3300" b="1">
+              <a:defRPr sz="3150" b="1">
                 <a:solidFill>
                   <a:srgbClr val="101828"/>
                 </a:solidFill>
               </a:defRPr>
             </a:pPr>
             <a:r>
-              <a:rPr sz="3300" b="1">
+              <a:rPr sz="3150" b="1">
                 <a:solidFill>
                   <a:srgbClr val="101828"/>
                 </a:solidFill>
               </a:rPr>
-              <a:t>Show it in eight steps</a:t>
+              <a:t>Guide it like a product tour</a:t>
             </a:r>
           </a:p>
         </p:txBody>
@@ -3786,7 +3786,7 @@
           <p:nvPr/>
         </p:nvPicPr>
         <p:blipFill>
-          <a:blip xmlns:r="http://schemas.openxmlformats.org/officeDocument/2006/relationships" xmlns:a="http://schemas.openxmlformats.org/drawingml/2006/main" r:embed="Re2f00156fba64429"/>
+          <a:blip xmlns:r="http://schemas.openxmlformats.org/officeDocument/2006/relationships" xmlns:a="http://schemas.openxmlformats.org/drawingml/2006/main" r:embed="R4f0c26c3e6db4168"/>
           <a:srcRect xmlns:a="http://schemas.openxmlformats.org/drawingml/2006/main" l="0" t="145" r="0" b="145"/>
           <a:stretch xmlns:a="http://schemas.openxmlformats.org/drawingml/2006/main">
             <a:fillRect l="0" t="0" r="0" b="0"/>
@@ -3809,18 +3809,18 @@
           <p:cNvPr id="6" name="">
             <a:extLst xmlns:a="http://schemas.openxmlformats.org/drawingml/2006/main">
               <a:ext uri="{FF2B5EF4-FFF2-40B4-BE49-F238E27FC236}">
-                <a16:creationId xmlns:a16="http://schemas.microsoft.com/office/drawing/2014/main" id="{792E34EE-5FBE-4115-B4B3-0261B66D820A}"/>
-              </a:ext>
-            </a:extLst>
-          </p:cNvPr>
-          <p:cNvSpPr>
-            <a:spLocks xmlns:a="http://schemas.openxmlformats.org/drawingml/2006/main" noGrp="1"/>
-          </p:cNvSpPr>
-          <p:nvPr/>
-        </p:nvSpPr>
-        <p:spPr>
-          <a:xfrm xmlns:a="http://schemas.openxmlformats.org/drawingml/2006/main">
-            <a:off x="666750" y="2152650"/>
+                <a16:creationId xmlns:a16="http://schemas.microsoft.com/office/drawing/2014/main" id="{83CA5DB1-1294-4F24-8DAA-E130C08C855F}"/>
+              </a:ext>
+            </a:extLst>
+          </p:cNvPr>
+          <p:cNvSpPr>
+            <a:spLocks xmlns:a="http://schemas.openxmlformats.org/drawingml/2006/main" noGrp="1"/>
+          </p:cNvSpPr>
+          <p:nvPr/>
+        </p:nvSpPr>
+        <p:spPr>
+          <a:xfrm xmlns:a="http://schemas.openxmlformats.org/drawingml/2006/main">
+            <a:off x="666750" y="2343150"/>
             <a:ext cx="114300" cy="114300"/>
           </a:xfrm>
           <a:prstGeom xmlns:a="http://schemas.openxmlformats.org/drawingml/2006/main" prst="ellipse">
@@ -3842,18 +3842,18 @@
           <p:cNvPr id="7" name="">
             <a:extLst xmlns:a="http://schemas.openxmlformats.org/drawingml/2006/main">
               <a:ext uri="{FF2B5EF4-FFF2-40B4-BE49-F238E27FC236}">
-                <a16:creationId xmlns:a16="http://schemas.microsoft.com/office/drawing/2014/main" id="{DD3CE6F8-DA29-402C-930E-43782CB550C0}"/>
-              </a:ext>
-            </a:extLst>
-          </p:cNvPr>
-          <p:cNvSpPr>
-            <a:spLocks xmlns:a="http://schemas.openxmlformats.org/drawingml/2006/main" noGrp="1"/>
-          </p:cNvSpPr>
-          <p:nvPr/>
-        </p:nvSpPr>
-        <p:spPr>
-          <a:xfrm xmlns:a="http://schemas.openxmlformats.org/drawingml/2006/main">
-            <a:off x="914400" y="2076450"/>
+                <a16:creationId xmlns:a16="http://schemas.microsoft.com/office/drawing/2014/main" id="{53AFB8CB-7CB9-4ECF-84EF-1C217F006258}"/>
+              </a:ext>
+            </a:extLst>
+          </p:cNvPr>
+          <p:cNvSpPr>
+            <a:spLocks xmlns:a="http://schemas.openxmlformats.org/drawingml/2006/main" noGrp="1"/>
+          </p:cNvSpPr>
+          <p:nvPr/>
+        </p:nvSpPr>
+        <p:spPr>
+          <a:xfrm xmlns:a="http://schemas.openxmlformats.org/drawingml/2006/main">
+            <a:off x="914400" y="2266950"/>
             <a:ext cx="3810000" cy="457200"/>
           </a:xfrm>
           <a:prstGeom xmlns:a="http://schemas.openxmlformats.org/drawingml/2006/main" prst="rect">
@@ -3882,7 +3882,7 @@
                   <a:srgbClr val="101828"/>
                 </a:solidFill>
               </a:rPr>
-              <a:t>Start with onboarding and dashboard context.</a:t>
+              <a:t>Auto-play through real app frames with focal highlights.</a:t>
             </a:r>
           </a:p>
         </p:txBody>
@@ -3892,18 +3892,18 @@
           <p:cNvPr id="8" name="">
             <a:extLst xmlns:a="http://schemas.openxmlformats.org/drawingml/2006/main">
               <a:ext uri="{FF2B5EF4-FFF2-40B4-BE49-F238E27FC236}">
-                <a16:creationId xmlns:a16="http://schemas.microsoft.com/office/drawing/2014/main" id="{E417533A-5456-404E-9C96-3326E8AE85EA}"/>
-              </a:ext>
-            </a:extLst>
-          </p:cNvPr>
-          <p:cNvSpPr>
-            <a:spLocks xmlns:a="http://schemas.openxmlformats.org/drawingml/2006/main" noGrp="1"/>
-          </p:cNvSpPr>
-          <p:nvPr/>
-        </p:nvSpPr>
-        <p:spPr>
-          <a:xfrm xmlns:a="http://schemas.openxmlformats.org/drawingml/2006/main">
-            <a:off x="666750" y="2705100"/>
+                <a16:creationId xmlns:a16="http://schemas.microsoft.com/office/drawing/2014/main" id="{6A36B3F8-AD00-4B9E-9250-17B9A59EBBC1}"/>
+              </a:ext>
+            </a:extLst>
+          </p:cNvPr>
+          <p:cNvSpPr>
+            <a:spLocks xmlns:a="http://schemas.openxmlformats.org/drawingml/2006/main" noGrp="1"/>
+          </p:cNvSpPr>
+          <p:nvPr/>
+        </p:nvSpPr>
+        <p:spPr>
+          <a:xfrm xmlns:a="http://schemas.openxmlformats.org/drawingml/2006/main">
+            <a:off x="666750" y="2895600"/>
             <a:ext cx="114300" cy="114300"/>
           </a:xfrm>
           <a:prstGeom xmlns:a="http://schemas.openxmlformats.org/drawingml/2006/main" prst="ellipse">
@@ -3925,18 +3925,18 @@
           <p:cNvPr id="9" name="">
             <a:extLst xmlns:a="http://schemas.openxmlformats.org/drawingml/2006/main">
               <a:ext uri="{FF2B5EF4-FFF2-40B4-BE49-F238E27FC236}">
-                <a16:creationId xmlns:a16="http://schemas.microsoft.com/office/drawing/2014/main" id="{337E0B3B-73EB-439C-9356-F352EAEB8539}"/>
-              </a:ext>
-            </a:extLst>
-          </p:cNvPr>
-          <p:cNvSpPr>
-            <a:spLocks xmlns:a="http://schemas.openxmlformats.org/drawingml/2006/main" noGrp="1"/>
-          </p:cNvSpPr>
-          <p:nvPr/>
-        </p:nvSpPr>
-        <p:spPr>
-          <a:xfrm xmlns:a="http://schemas.openxmlformats.org/drawingml/2006/main">
-            <a:off x="914400" y="2628900"/>
+                <a16:creationId xmlns:a16="http://schemas.microsoft.com/office/drawing/2014/main" id="{DFA34389-60CA-413E-90E8-16C4B72ED385}"/>
+              </a:ext>
+            </a:extLst>
+          </p:cNvPr>
+          <p:cNvSpPr>
+            <a:spLocks xmlns:a="http://schemas.openxmlformats.org/drawingml/2006/main" noGrp="1"/>
+          </p:cNvSpPr>
+          <p:nvPr/>
+        </p:nvSpPr>
+        <p:spPr>
+          <a:xfrm xmlns:a="http://schemas.openxmlformats.org/drawingml/2006/main">
+            <a:off x="914400" y="2819400"/>
             <a:ext cx="3810000" cy="457200"/>
           </a:xfrm>
           <a:prstGeom xmlns:a="http://schemas.openxmlformats.org/drawingml/2006/main" prst="rect">
@@ -3965,7 +3965,7 @@
                   <a:srgbClr val="101828"/>
                 </a:solidFill>
               </a:rPr>
-              <a:t>Demonstrate strict pose coaching and hidden diagnostics.</a:t>
+              <a:t>Use cursor motion and captions to point out the story.</a:t>
             </a:r>
           </a:p>
         </p:txBody>
@@ -3975,18 +3975,18 @@
           <p:cNvPr id="10" name="">
             <a:extLst xmlns:a="http://schemas.openxmlformats.org/drawingml/2006/main">
               <a:ext uri="{FF2B5EF4-FFF2-40B4-BE49-F238E27FC236}">
-                <a16:creationId xmlns:a16="http://schemas.microsoft.com/office/drawing/2014/main" id="{894ADEE7-6CA3-4931-B29D-9780FC990AC0}"/>
-              </a:ext>
-            </a:extLst>
-          </p:cNvPr>
-          <p:cNvSpPr>
-            <a:spLocks xmlns:a="http://schemas.openxmlformats.org/drawingml/2006/main" noGrp="1"/>
-          </p:cNvSpPr>
-          <p:nvPr/>
-        </p:nvSpPr>
-        <p:spPr>
-          <a:xfrm xmlns:a="http://schemas.openxmlformats.org/drawingml/2006/main">
-            <a:off x="666750" y="3257550"/>
+                <a16:creationId xmlns:a16="http://schemas.microsoft.com/office/drawing/2014/main" id="{F35D76BD-52FB-4691-82EB-7FD338E0AC11}"/>
+              </a:ext>
+            </a:extLst>
+          </p:cNvPr>
+          <p:cNvSpPr>
+            <a:spLocks xmlns:a="http://schemas.openxmlformats.org/drawingml/2006/main" noGrp="1"/>
+          </p:cNvSpPr>
+          <p:nvPr/>
+        </p:nvSpPr>
+        <p:spPr>
+          <a:xfrm xmlns:a="http://schemas.openxmlformats.org/drawingml/2006/main">
+            <a:off x="666750" y="3448050"/>
             <a:ext cx="114300" cy="114300"/>
           </a:xfrm>
           <a:prstGeom xmlns:a="http://schemas.openxmlformats.org/drawingml/2006/main" prst="ellipse">
@@ -4008,18 +4008,18 @@
           <p:cNvPr id="11" name="">
             <a:extLst xmlns:a="http://schemas.openxmlformats.org/drawingml/2006/main">
               <a:ext uri="{FF2B5EF4-FFF2-40B4-BE49-F238E27FC236}">
-                <a16:creationId xmlns:a16="http://schemas.microsoft.com/office/drawing/2014/main" id="{9BF6454D-4A39-4C18-AB79-72AAC91E7250}"/>
-              </a:ext>
-            </a:extLst>
-          </p:cNvPr>
-          <p:cNvSpPr>
-            <a:spLocks xmlns:a="http://schemas.openxmlformats.org/drawingml/2006/main" noGrp="1"/>
-          </p:cNvSpPr>
-          <p:nvPr/>
-        </p:nvSpPr>
-        <p:spPr>
-          <a:xfrm xmlns:a="http://schemas.openxmlformats.org/drawingml/2006/main">
-            <a:off x="914400" y="3181350"/>
+                <a16:creationId xmlns:a16="http://schemas.microsoft.com/office/drawing/2014/main" id="{25EFB354-25F8-46BE-9846-EC851D450E6D}"/>
+              </a:ext>
+            </a:extLst>
+          </p:cNvPr>
+          <p:cNvSpPr>
+            <a:spLocks xmlns:a="http://schemas.openxmlformats.org/drawingml/2006/main" noGrp="1"/>
+          </p:cNvSpPr>
+          <p:nvPr/>
+        </p:nvSpPr>
+        <p:spPr>
+          <a:xfrm xmlns:a="http://schemas.openxmlformats.org/drawingml/2006/main">
+            <a:off x="914400" y="3371850"/>
             <a:ext cx="3810000" cy="457200"/>
           </a:xfrm>
           <a:prstGeom xmlns:a="http://schemas.openxmlformats.org/drawingml/2006/main" prst="rect">
@@ -4048,7 +4048,7 @@
                   <a:srgbClr val="101828"/>
                 </a:solidFill>
               </a:rPr>
-              <a:t>Move through exercise guidance, diet, calorie photo review, and progress.</a:t>
+              <a:t>Pause on Pose Coach for the strict-rep explanation.</a:t>
             </a:r>
           </a:p>
         </p:txBody>
@@ -4058,18 +4058,18 @@
           <p:cNvPr id="12" name="">
             <a:extLst xmlns:a="http://schemas.openxmlformats.org/drawingml/2006/main">
               <a:ext uri="{FF2B5EF4-FFF2-40B4-BE49-F238E27FC236}">
-                <a16:creationId xmlns:a16="http://schemas.microsoft.com/office/drawing/2014/main" id="{E9F44F02-E33D-4E7A-9228-37296D409A5C}"/>
-              </a:ext>
-            </a:extLst>
-          </p:cNvPr>
-          <p:cNvSpPr>
-            <a:spLocks xmlns:a="http://schemas.openxmlformats.org/drawingml/2006/main" noGrp="1"/>
-          </p:cNvSpPr>
-          <p:nvPr/>
-        </p:nvSpPr>
-        <p:spPr>
-          <a:xfrm xmlns:a="http://schemas.openxmlformats.org/drawingml/2006/main">
-            <a:off x="666750" y="3810000"/>
+                <a16:creationId xmlns:a16="http://schemas.microsoft.com/office/drawing/2014/main" id="{368DF633-11D1-4A4E-8CE9-E7A55A377A3E}"/>
+              </a:ext>
+            </a:extLst>
+          </p:cNvPr>
+          <p:cNvSpPr>
+            <a:spLocks xmlns:a="http://schemas.openxmlformats.org/drawingml/2006/main" noGrp="1"/>
+          </p:cNvSpPr>
+          <p:nvPr/>
+        </p:nvSpPr>
+        <p:spPr>
+          <a:xfrm xmlns:a="http://schemas.openxmlformats.org/drawingml/2006/main">
+            <a:off x="666750" y="4000500"/>
             <a:ext cx="114300" cy="114300"/>
           </a:xfrm>
           <a:prstGeom xmlns:a="http://schemas.openxmlformats.org/drawingml/2006/main" prst="ellipse">
@@ -4091,18 +4091,18 @@
           <p:cNvPr id="13" name="">
             <a:extLst xmlns:a="http://schemas.openxmlformats.org/drawingml/2006/main">
               <a:ext uri="{FF2B5EF4-FFF2-40B4-BE49-F238E27FC236}">
-                <a16:creationId xmlns:a16="http://schemas.microsoft.com/office/drawing/2014/main" id="{2F376ECF-C78A-40DF-B066-4ED1C0310DEB}"/>
-              </a:ext>
-            </a:extLst>
-          </p:cNvPr>
-          <p:cNvSpPr>
-            <a:spLocks xmlns:a="http://schemas.openxmlformats.org/drawingml/2006/main" noGrp="1"/>
-          </p:cNvSpPr>
-          <p:nvPr/>
-        </p:nvSpPr>
-        <p:spPr>
-          <a:xfrm xmlns:a="http://schemas.openxmlformats.org/drawingml/2006/main">
-            <a:off x="914400" y="3733800"/>
+                <a16:creationId xmlns:a16="http://schemas.microsoft.com/office/drawing/2014/main" id="{E9BD0979-3F35-4F2E-A958-6D0595E2303C}"/>
+              </a:ext>
+            </a:extLst>
+          </p:cNvPr>
+          <p:cNvSpPr>
+            <a:spLocks xmlns:a="http://schemas.openxmlformats.org/drawingml/2006/main" noGrp="1"/>
+          </p:cNvSpPr>
+          <p:nvPr/>
+        </p:nvSpPr>
+        <p:spPr>
+          <a:xfrm xmlns:a="http://schemas.openxmlformats.org/drawingml/2006/main">
+            <a:off x="914400" y="3924300"/>
             <a:ext cx="3810000" cy="457200"/>
           </a:xfrm>
           <a:prstGeom xmlns:a="http://schemas.openxmlformats.org/drawingml/2006/main" prst="rect">
@@ -4131,7 +4131,7 @@
                   <a:srgbClr val="101828"/>
                 </a:solidFill>
               </a:rPr>
-              <a:t>Close on the generated submission package.</a:t>
+              <a:t>Open a live route only when judges want deeper inspection.</a:t>
             </a:r>
           </a:p>
         </p:txBody>
@@ -4139,7 +4139,7 @@
     </p:spTree>
     <p:extLst>
       <p:ext uri="{BB962C8B-B14F-4D97-AF65-F5344CB8AC3E}">
-        <p14:creationId xmlns:p14="http://schemas.microsoft.com/office/powerpoint/2010/main" val="1322628566"/>
+        <p14:creationId xmlns:p14="http://schemas.microsoft.com/office/powerpoint/2010/main" val="772780203"/>
       </p:ext>
     </p:extLst>
   </p:cSld>
@@ -4170,7 +4170,7 @@
           <p:cNvPr id="1" name="">
             <a:extLst xmlns:a="http://schemas.openxmlformats.org/drawingml/2006/main">
               <a:ext uri="{FF2B5EF4-FFF2-40B4-BE49-F238E27FC236}">
-                <a16:creationId xmlns:a16="http://schemas.microsoft.com/office/drawing/2014/main" id="{31967BD6-D3F2-412B-8174-16A010918A94}"/>
+                <a16:creationId xmlns:a16="http://schemas.microsoft.com/office/drawing/2014/main" id="{2110CCD8-1214-496B-9EC4-EA99BE97D77D}"/>
               </a:ext>
             </a:extLst>
           </p:cNvPr>
@@ -4220,7 +4220,7 @@
           <p:cNvPr id="2" name="">
             <a:extLst xmlns:a="http://schemas.openxmlformats.org/drawingml/2006/main">
               <a:ext uri="{FF2B5EF4-FFF2-40B4-BE49-F238E27FC236}">
-                <a16:creationId xmlns:a16="http://schemas.microsoft.com/office/drawing/2014/main" id="{3E5A1957-2E73-493F-8D4D-B4F2AB5F00EA}"/>
+                <a16:creationId xmlns:a16="http://schemas.microsoft.com/office/drawing/2014/main" id="{0207081A-742D-4345-923E-AB3F17AD6882}"/>
               </a:ext>
             </a:extLst>
           </p:cNvPr>
@@ -4270,7 +4270,7 @@
           <p:cNvPr id="3" name="">
             <a:extLst xmlns:a="http://schemas.openxmlformats.org/drawingml/2006/main">
               <a:ext uri="{FF2B5EF4-FFF2-40B4-BE49-F238E27FC236}">
-                <a16:creationId xmlns:a16="http://schemas.microsoft.com/office/drawing/2014/main" id="{8DFFC1EF-B39D-4960-9479-DE18C17917E9}"/>
+                <a16:creationId xmlns:a16="http://schemas.microsoft.com/office/drawing/2014/main" id="{65E0663A-ABEA-40BA-B9AA-A5908F3261A9}"/>
               </a:ext>
             </a:extLst>
           </p:cNvPr>
@@ -4303,7 +4303,7 @@
           <p:cNvPr id="4" name="">
             <a:extLst xmlns:a="http://schemas.openxmlformats.org/drawingml/2006/main">
               <a:ext uri="{FF2B5EF4-FFF2-40B4-BE49-F238E27FC236}">
-                <a16:creationId xmlns:a16="http://schemas.microsoft.com/office/drawing/2014/main" id="{6D19211E-4501-4759-84CC-9B158B9C6645}"/>
+                <a16:creationId xmlns:a16="http://schemas.microsoft.com/office/drawing/2014/main" id="{24B867D3-6D5C-46AF-86DA-406E74C7C29A}"/>
               </a:ext>
             </a:extLst>
           </p:cNvPr>
@@ -4353,7 +4353,7 @@
           <p:cNvPr id="5" name="">
             <a:extLst xmlns:a="http://schemas.openxmlformats.org/drawingml/2006/main">
               <a:ext uri="{FF2B5EF4-FFF2-40B4-BE49-F238E27FC236}">
-                <a16:creationId xmlns:a16="http://schemas.microsoft.com/office/drawing/2014/main" id="{92961898-8B09-4E4B-902B-E6F1FAC54C67}"/>
+                <a16:creationId xmlns:a16="http://schemas.microsoft.com/office/drawing/2014/main" id="{17C78A78-A43F-4E8F-86D9-008F4288A301}"/>
               </a:ext>
             </a:extLst>
           </p:cNvPr>
@@ -4386,7 +4386,7 @@
           <p:cNvPr id="6" name="">
             <a:extLst xmlns:a="http://schemas.openxmlformats.org/drawingml/2006/main">
               <a:ext uri="{FF2B5EF4-FFF2-40B4-BE49-F238E27FC236}">
-                <a16:creationId xmlns:a16="http://schemas.microsoft.com/office/drawing/2014/main" id="{8776B069-F24D-495F-A8D3-388FE272D071}"/>
+                <a16:creationId xmlns:a16="http://schemas.microsoft.com/office/drawing/2014/main" id="{98FDCA4E-BA72-4346-A9D1-B9B13D3D3FE0}"/>
               </a:ext>
             </a:extLst>
           </p:cNvPr>
@@ -4436,7 +4436,7 @@
           <p:cNvPr id="7" name="">
             <a:extLst xmlns:a="http://schemas.openxmlformats.org/drawingml/2006/main">
               <a:ext uri="{FF2B5EF4-FFF2-40B4-BE49-F238E27FC236}">
-                <a16:creationId xmlns:a16="http://schemas.microsoft.com/office/drawing/2014/main" id="{4C895190-017A-4534-8179-A6D35BDBB278}"/>
+                <a16:creationId xmlns:a16="http://schemas.microsoft.com/office/drawing/2014/main" id="{14DA0594-1FD9-42A1-908D-8E67F4D7E707}"/>
               </a:ext>
             </a:extLst>
           </p:cNvPr>
@@ -4469,7 +4469,7 @@
           <p:cNvPr id="8" name="">
             <a:extLst xmlns:a="http://schemas.openxmlformats.org/drawingml/2006/main">
               <a:ext uri="{FF2B5EF4-FFF2-40B4-BE49-F238E27FC236}">
-                <a16:creationId xmlns:a16="http://schemas.microsoft.com/office/drawing/2014/main" id="{4591E321-03DA-4D6D-AC68-0CD18E0FEACB}"/>
+                <a16:creationId xmlns:a16="http://schemas.microsoft.com/office/drawing/2014/main" id="{92B647AB-4E22-4CCA-BAF4-ADD59059B5E6}"/>
               </a:ext>
             </a:extLst>
           </p:cNvPr>
@@ -4519,7 +4519,7 @@
           <p:cNvPr id="9" name="">
             <a:extLst xmlns:a="http://schemas.openxmlformats.org/drawingml/2006/main">
               <a:ext uri="{FF2B5EF4-FFF2-40B4-BE49-F238E27FC236}">
-                <a16:creationId xmlns:a16="http://schemas.microsoft.com/office/drawing/2014/main" id="{86E917E8-4521-4CC9-A926-3A082511B6BE}"/>
+                <a16:creationId xmlns:a16="http://schemas.microsoft.com/office/drawing/2014/main" id="{46924515-70CB-4D37-99A5-B63C9433698A}"/>
               </a:ext>
             </a:extLst>
           </p:cNvPr>
@@ -4552,7 +4552,7 @@
           <p:cNvPr id="10" name="">
             <a:extLst xmlns:a="http://schemas.openxmlformats.org/drawingml/2006/main">
               <a:ext uri="{FF2B5EF4-FFF2-40B4-BE49-F238E27FC236}">
-                <a16:creationId xmlns:a16="http://schemas.microsoft.com/office/drawing/2014/main" id="{5AAF8383-B7A5-46AE-83AB-0FCA74625003}"/>
+                <a16:creationId xmlns:a16="http://schemas.microsoft.com/office/drawing/2014/main" id="{1298261B-3F26-4514-BAFD-ACCF3EAD3FB5}"/>
               </a:ext>
             </a:extLst>
           </p:cNvPr>
@@ -4602,7 +4602,7 @@
           <p:cNvPr id="11" name="">
             <a:extLst xmlns:a="http://schemas.openxmlformats.org/drawingml/2006/main">
               <a:ext uri="{FF2B5EF4-FFF2-40B4-BE49-F238E27FC236}">
-                <a16:creationId xmlns:a16="http://schemas.microsoft.com/office/drawing/2014/main" id="{4188E8CB-2ACF-4B03-BD50-3E7CEA0F1A12}"/>
+                <a16:creationId xmlns:a16="http://schemas.microsoft.com/office/drawing/2014/main" id="{3E91A57C-E818-4285-BECF-1B344B394DEE}"/>
               </a:ext>
             </a:extLst>
           </p:cNvPr>
@@ -4637,7 +4637,7 @@
           <p:cNvPr id="12" name="">
             <a:extLst xmlns:a="http://schemas.openxmlformats.org/drawingml/2006/main">
               <a:ext uri="{FF2B5EF4-FFF2-40B4-BE49-F238E27FC236}">
-                <a16:creationId xmlns:a16="http://schemas.microsoft.com/office/drawing/2014/main" id="{7603206C-6D72-4BE8-9C31-7F8592584389}"/>
+                <a16:creationId xmlns:a16="http://schemas.microsoft.com/office/drawing/2014/main" id="{655859E5-F00F-4CFE-9C4F-1108BC65C400}"/>
               </a:ext>
             </a:extLst>
           </p:cNvPr>
@@ -4687,7 +4687,7 @@
           <p:cNvPr id="13" name="">
             <a:extLst xmlns:a="http://schemas.openxmlformats.org/drawingml/2006/main">
               <a:ext uri="{FF2B5EF4-FFF2-40B4-BE49-F238E27FC236}">
-                <a16:creationId xmlns:a16="http://schemas.microsoft.com/office/drawing/2014/main" id="{AEA0E37A-1B9C-4DD0-8155-53DBE003D318}"/>
+                <a16:creationId xmlns:a16="http://schemas.microsoft.com/office/drawing/2014/main" id="{5902E503-49B8-49FE-A862-FB220C61D655}"/>
               </a:ext>
             </a:extLst>
           </p:cNvPr>
@@ -4735,7 +4735,7 @@
     </p:spTree>
     <p:extLst>
       <p:ext uri="{BB962C8B-B14F-4D97-AF65-F5344CB8AC3E}">
-        <p14:creationId xmlns:p14="http://schemas.microsoft.com/office/powerpoint/2010/main" val="958794141"/>
+        <p14:creationId xmlns:p14="http://schemas.microsoft.com/office/powerpoint/2010/main" val="1880794745"/>
       </p:ext>
     </p:extLst>
   </p:cSld>
@@ -4766,7 +4766,7 @@
           <p:cNvPr id="1" name="">
             <a:extLst xmlns:a="http://schemas.openxmlformats.org/drawingml/2006/main">
               <a:ext uri="{FF2B5EF4-FFF2-40B4-BE49-F238E27FC236}">
-                <a16:creationId xmlns:a16="http://schemas.microsoft.com/office/drawing/2014/main" id="{CBAC845D-F0FF-4F7A-A0F9-714262D0942F}"/>
+                <a16:creationId xmlns:a16="http://schemas.microsoft.com/office/drawing/2014/main" id="{9254891B-0C38-4B53-9F9F-8E4CB2121B04}"/>
               </a:ext>
             </a:extLst>
           </p:cNvPr>
@@ -4816,7 +4816,7 @@
           <p:cNvPr id="2" name="">
             <a:extLst xmlns:a="http://schemas.openxmlformats.org/drawingml/2006/main">
               <a:ext uri="{FF2B5EF4-FFF2-40B4-BE49-F238E27FC236}">
-                <a16:creationId xmlns:a16="http://schemas.microsoft.com/office/drawing/2014/main" id="{2B906D61-E159-47CF-84A2-D6F73BE54B05}"/>
+                <a16:creationId xmlns:a16="http://schemas.microsoft.com/office/drawing/2014/main" id="{44A995C1-6B81-47A1-96CD-B0A19A5B52F7}"/>
               </a:ext>
             </a:extLst>
           </p:cNvPr>
@@ -4866,7 +4866,7 @@
           <p:cNvPr id="3" name="">
             <a:extLst xmlns:a="http://schemas.openxmlformats.org/drawingml/2006/main">
               <a:ext uri="{FF2B5EF4-FFF2-40B4-BE49-F238E27FC236}">
-                <a16:creationId xmlns:a16="http://schemas.microsoft.com/office/drawing/2014/main" id="{FF0F6F0C-9FE7-4E3B-A418-0E49D48B1FDE}"/>
+                <a16:creationId xmlns:a16="http://schemas.microsoft.com/office/drawing/2014/main" id="{A4737906-625A-49A9-91C8-68A66F2042CD}"/>
               </a:ext>
             </a:extLst>
           </p:cNvPr>
@@ -4899,7 +4899,7 @@
           <p:cNvPr id="4" name="">
             <a:extLst xmlns:a="http://schemas.openxmlformats.org/drawingml/2006/main">
               <a:ext uri="{FF2B5EF4-FFF2-40B4-BE49-F238E27FC236}">
-                <a16:creationId xmlns:a16="http://schemas.microsoft.com/office/drawing/2014/main" id="{29F514FA-2CE8-42C5-A697-8C4AB681340A}"/>
+                <a16:creationId xmlns:a16="http://schemas.microsoft.com/office/drawing/2014/main" id="{539D5621-D198-4570-8EEC-B8DB4A38C683}"/>
               </a:ext>
             </a:extLst>
           </p:cNvPr>
@@ -4953,7 +4953,7 @@
           <p:nvPr/>
         </p:nvPicPr>
         <p:blipFill>
-          <a:blip xmlns:r="http://schemas.openxmlformats.org/officeDocument/2006/relationships" xmlns:a="http://schemas.openxmlformats.org/drawingml/2006/main" r:embed="R12b62ad3ffc7482e"/>
+          <a:blip xmlns:r="http://schemas.openxmlformats.org/officeDocument/2006/relationships" xmlns:a="http://schemas.openxmlformats.org/drawingml/2006/main" r:embed="Ra4120dbf3fdb4534"/>
           <a:srcRect xmlns:a="http://schemas.openxmlformats.org/drawingml/2006/main" l="0" t="334" r="0" b="334"/>
           <a:stretch xmlns:a="http://schemas.openxmlformats.org/drawingml/2006/main">
             <a:fillRect l="0" t="0" r="0" b="0"/>
@@ -4980,7 +4980,7 @@
           <p:nvPr/>
         </p:nvPicPr>
         <p:blipFill>
-          <a:blip xmlns:r="http://schemas.openxmlformats.org/officeDocument/2006/relationships" xmlns:a="http://schemas.openxmlformats.org/drawingml/2006/main" r:embed="R5f895669f6644fda"/>
+          <a:blip xmlns:r="http://schemas.openxmlformats.org/officeDocument/2006/relationships" xmlns:a="http://schemas.openxmlformats.org/drawingml/2006/main" r:embed="R004a0b33c70d4b4e"/>
           <a:srcRect xmlns:a="http://schemas.openxmlformats.org/drawingml/2006/main" l="0" t="334" r="0" b="334"/>
           <a:stretch xmlns:a="http://schemas.openxmlformats.org/drawingml/2006/main">
             <a:fillRect l="0" t="0" r="0" b="0"/>
@@ -5003,7 +5003,7 @@
           <p:cNvPr id="7" name="">
             <a:extLst xmlns:a="http://schemas.openxmlformats.org/drawingml/2006/main">
               <a:ext uri="{FF2B5EF4-FFF2-40B4-BE49-F238E27FC236}">
-                <a16:creationId xmlns:a16="http://schemas.microsoft.com/office/drawing/2014/main" id="{31FB17B6-E0C9-45ED-9FEC-97D089A0F71B}"/>
+                <a16:creationId xmlns:a16="http://schemas.microsoft.com/office/drawing/2014/main" id="{70FFA2FB-C488-4F0A-9D34-3620A1ED7C1D}"/>
               </a:ext>
             </a:extLst>
           </p:cNvPr>
@@ -5051,7 +5051,7 @@
     </p:spTree>
     <p:extLst>
       <p:ext uri="{BB962C8B-B14F-4D97-AF65-F5344CB8AC3E}">
-        <p14:creationId xmlns:p14="http://schemas.microsoft.com/office/powerpoint/2010/main" val="399741120"/>
+        <p14:creationId xmlns:p14="http://schemas.microsoft.com/office/powerpoint/2010/main" val="1992094288"/>
       </p:ext>
     </p:extLst>
   </p:cSld>
@@ -5082,7 +5082,7 @@
           <p:cNvPr id="1" name="">
             <a:extLst xmlns:a="http://schemas.openxmlformats.org/drawingml/2006/main">
               <a:ext uri="{FF2B5EF4-FFF2-40B4-BE49-F238E27FC236}">
-                <a16:creationId xmlns:a16="http://schemas.microsoft.com/office/drawing/2014/main" id="{B268F278-08B6-4264-8EC9-D3A6C6BFC830}"/>
+                <a16:creationId xmlns:a16="http://schemas.microsoft.com/office/drawing/2014/main" id="{7F0926F4-46A3-41F4-B6A9-C52F8F1CCD4E}"/>
               </a:ext>
             </a:extLst>
           </p:cNvPr>
@@ -5132,7 +5132,7 @@
           <p:cNvPr id="2" name="">
             <a:extLst xmlns:a="http://schemas.openxmlformats.org/drawingml/2006/main">
               <a:ext uri="{FF2B5EF4-FFF2-40B4-BE49-F238E27FC236}">
-                <a16:creationId xmlns:a16="http://schemas.microsoft.com/office/drawing/2014/main" id="{E2467210-DBF9-49B8-80A6-972053594E1F}"/>
+                <a16:creationId xmlns:a16="http://schemas.microsoft.com/office/drawing/2014/main" id="{9DAA5AE3-410B-4DCF-BB49-0D2C096E9AE5}"/>
               </a:ext>
             </a:extLst>
           </p:cNvPr>
@@ -5182,7 +5182,7 @@
           <p:cNvPr id="3" name="">
             <a:extLst xmlns:a="http://schemas.openxmlformats.org/drawingml/2006/main">
               <a:ext uri="{FF2B5EF4-FFF2-40B4-BE49-F238E27FC236}">
-                <a16:creationId xmlns:a16="http://schemas.microsoft.com/office/drawing/2014/main" id="{63683A47-40D1-4517-9F52-96BC30E16D23}"/>
+                <a16:creationId xmlns:a16="http://schemas.microsoft.com/office/drawing/2014/main" id="{6085E347-C1FE-446B-A2F7-B01B1384046B}"/>
               </a:ext>
             </a:extLst>
           </p:cNvPr>
@@ -5215,7 +5215,7 @@
           <p:cNvPr id="4" name="">
             <a:extLst xmlns:a="http://schemas.openxmlformats.org/drawingml/2006/main">
               <a:ext uri="{FF2B5EF4-FFF2-40B4-BE49-F238E27FC236}">
-                <a16:creationId xmlns:a16="http://schemas.microsoft.com/office/drawing/2014/main" id="{1A685BB4-CAC5-4C2D-AF6B-794B3F0F65F9}"/>
+                <a16:creationId xmlns:a16="http://schemas.microsoft.com/office/drawing/2014/main" id="{C4D28E4A-C3C6-4393-8C95-1B9430FF7B82}"/>
               </a:ext>
             </a:extLst>
           </p:cNvPr>
@@ -5265,7 +5265,7 @@
           <p:cNvPr id="5" name="">
             <a:extLst xmlns:a="http://schemas.openxmlformats.org/drawingml/2006/main">
               <a:ext uri="{FF2B5EF4-FFF2-40B4-BE49-F238E27FC236}">
-                <a16:creationId xmlns:a16="http://schemas.microsoft.com/office/drawing/2014/main" id="{D9FC2C9A-629D-434C-9610-8F1FC59A7435}"/>
+                <a16:creationId xmlns:a16="http://schemas.microsoft.com/office/drawing/2014/main" id="{C7B9EF7F-B1FE-4C2D-8A39-91C75DC8C819}"/>
               </a:ext>
             </a:extLst>
           </p:cNvPr>
@@ -5298,7 +5298,7 @@
           <p:cNvPr id="6" name="">
             <a:extLst xmlns:a="http://schemas.openxmlformats.org/drawingml/2006/main">
               <a:ext uri="{FF2B5EF4-FFF2-40B4-BE49-F238E27FC236}">
-                <a16:creationId xmlns:a16="http://schemas.microsoft.com/office/drawing/2014/main" id="{12FEC1F8-C959-47FA-9A27-65584FD8A2EE}"/>
+                <a16:creationId xmlns:a16="http://schemas.microsoft.com/office/drawing/2014/main" id="{66A2338B-9F15-4C77-8BAF-4D34A9A88F97}"/>
               </a:ext>
             </a:extLst>
           </p:cNvPr>
@@ -5348,7 +5348,7 @@
           <p:cNvPr id="7" name="">
             <a:extLst xmlns:a="http://schemas.openxmlformats.org/drawingml/2006/main">
               <a:ext uri="{FF2B5EF4-FFF2-40B4-BE49-F238E27FC236}">
-                <a16:creationId xmlns:a16="http://schemas.microsoft.com/office/drawing/2014/main" id="{D5B7744C-13AB-40C8-81E8-18C82A27389A}"/>
+                <a16:creationId xmlns:a16="http://schemas.microsoft.com/office/drawing/2014/main" id="{F64FC067-FB94-4276-8550-D58BFF5E3F63}"/>
               </a:ext>
             </a:extLst>
           </p:cNvPr>
@@ -5381,7 +5381,7 @@
           <p:cNvPr id="8" name="">
             <a:extLst xmlns:a="http://schemas.openxmlformats.org/drawingml/2006/main">
               <a:ext uri="{FF2B5EF4-FFF2-40B4-BE49-F238E27FC236}">
-                <a16:creationId xmlns:a16="http://schemas.microsoft.com/office/drawing/2014/main" id="{0D16AA10-17DC-49D9-AFF4-BD15C4FCFB0F}"/>
+                <a16:creationId xmlns:a16="http://schemas.microsoft.com/office/drawing/2014/main" id="{0C06335B-9F4C-4A7E-89D0-81ED80A4025D}"/>
               </a:ext>
             </a:extLst>
           </p:cNvPr>
@@ -5431,7 +5431,7 @@
           <p:cNvPr id="9" name="">
             <a:extLst xmlns:a="http://schemas.openxmlformats.org/drawingml/2006/main">
               <a:ext uri="{FF2B5EF4-FFF2-40B4-BE49-F238E27FC236}">
-                <a16:creationId xmlns:a16="http://schemas.microsoft.com/office/drawing/2014/main" id="{36CD3ED8-43AA-4B50-AD58-F8B3B88B6E22}"/>
+                <a16:creationId xmlns:a16="http://schemas.microsoft.com/office/drawing/2014/main" id="{2578FC78-5EB9-4C13-8714-C886A3B4C65A}"/>
               </a:ext>
             </a:extLst>
           </p:cNvPr>
@@ -5464,7 +5464,7 @@
           <p:cNvPr id="10" name="">
             <a:extLst xmlns:a="http://schemas.openxmlformats.org/drawingml/2006/main">
               <a:ext uri="{FF2B5EF4-FFF2-40B4-BE49-F238E27FC236}">
-                <a16:creationId xmlns:a16="http://schemas.microsoft.com/office/drawing/2014/main" id="{15F35675-B7B2-412E-A7BF-3FBF10D6B87B}"/>
+                <a16:creationId xmlns:a16="http://schemas.microsoft.com/office/drawing/2014/main" id="{9BD9AD77-C0B5-4B41-87F0-B9C32C9A4318}"/>
               </a:ext>
             </a:extLst>
           </p:cNvPr>
@@ -5514,7 +5514,7 @@
           <p:cNvPr id="11" name="">
             <a:extLst xmlns:a="http://schemas.openxmlformats.org/drawingml/2006/main">
               <a:ext uri="{FF2B5EF4-FFF2-40B4-BE49-F238E27FC236}">
-                <a16:creationId xmlns:a16="http://schemas.microsoft.com/office/drawing/2014/main" id="{124AFB85-3522-4243-9292-D0DAFD855EED}"/>
+                <a16:creationId xmlns:a16="http://schemas.microsoft.com/office/drawing/2014/main" id="{EEB73B5F-9212-48B7-9A81-2C3F9C5176F1}"/>
               </a:ext>
             </a:extLst>
           </p:cNvPr>
@@ -5547,7 +5547,7 @@
           <p:cNvPr id="12" name="">
             <a:extLst xmlns:a="http://schemas.openxmlformats.org/drawingml/2006/main">
               <a:ext uri="{FF2B5EF4-FFF2-40B4-BE49-F238E27FC236}">
-                <a16:creationId xmlns:a16="http://schemas.microsoft.com/office/drawing/2014/main" id="{C51A0393-88CA-46AA-A613-877A170BAD9C}"/>
+                <a16:creationId xmlns:a16="http://schemas.microsoft.com/office/drawing/2014/main" id="{A0A9BA01-1989-4FF9-A96A-70380EDC7A44}"/>
               </a:ext>
             </a:extLst>
           </p:cNvPr>
@@ -5597,7 +5597,7 @@
           <p:cNvPr id="13" name="">
             <a:extLst xmlns:a="http://schemas.openxmlformats.org/drawingml/2006/main">
               <a:ext uri="{FF2B5EF4-FFF2-40B4-BE49-F238E27FC236}">
-                <a16:creationId xmlns:a16="http://schemas.microsoft.com/office/drawing/2014/main" id="{5FCB8EA7-087D-4527-B347-5DE82025525E}"/>
+                <a16:creationId xmlns:a16="http://schemas.microsoft.com/office/drawing/2014/main" id="{C1F6E6E5-00A0-4F47-89BD-5FC737F2CE6A}"/>
               </a:ext>
             </a:extLst>
           </p:cNvPr>
@@ -5632,7 +5632,7 @@
           <p:cNvPr id="14" name="">
             <a:extLst xmlns:a="http://schemas.openxmlformats.org/drawingml/2006/main">
               <a:ext uri="{FF2B5EF4-FFF2-40B4-BE49-F238E27FC236}">
-                <a16:creationId xmlns:a16="http://schemas.microsoft.com/office/drawing/2014/main" id="{F89DD69F-6870-4DD3-8DE0-1DD8EBA32BD2}"/>
+                <a16:creationId xmlns:a16="http://schemas.microsoft.com/office/drawing/2014/main" id="{2BA3307C-9FF5-4580-8972-8375013BC501}"/>
               </a:ext>
             </a:extLst>
           </p:cNvPr>
@@ -5680,7 +5680,7 @@
     </p:spTree>
     <p:extLst>
       <p:ext uri="{BB962C8B-B14F-4D97-AF65-F5344CB8AC3E}">
-        <p14:creationId xmlns:p14="http://schemas.microsoft.com/office/powerpoint/2010/main" val="1962250163"/>
+        <p14:creationId xmlns:p14="http://schemas.microsoft.com/office/powerpoint/2010/main" val="1405614250"/>
       </p:ext>
     </p:extLst>
   </p:cSld>

</xml_diff>

<commit_message>
Prepare El Bracino submission package
</commit_message>
<xml_diff>
--- a/deliverables/SHORIR_AI_Project_Presentation.pptx
+++ b/deliverables/SHORIR_AI_Project_Presentation.pptx
@@ -2,20 +2,20 @@
 <file path=ppt/presentation.xml><?xml version="1.0" encoding="utf-8"?>
 <p:presentation xmlns:p="http://schemas.openxmlformats.org/presentationml/2006/main">
   <p:sldMasterIdLst>
-    <p:sldMasterId xmlns:r="http://schemas.openxmlformats.org/officeDocument/2006/relationships" id="2147483648" r:id="R06a44d3452e54995"/>
+    <p:sldMasterId xmlns:r="http://schemas.openxmlformats.org/officeDocument/2006/relationships" id="2147483648" r:id="Rc4aa9c3ff75c4687"/>
   </p:sldMasterIdLst>
   <p:notesMasterIdLst>
-    <p:notesMasterId xmlns:r="http://schemas.openxmlformats.org/officeDocument/2006/relationships" r:id="Rac7b705bc0fe40b0"/>
+    <p:notesMasterId xmlns:r="http://schemas.openxmlformats.org/officeDocument/2006/relationships" r:id="R8e0ca98dc2ef41c7"/>
   </p:notesMasterIdLst>
   <p:sldIdLst>
-    <p:sldId xmlns:r="http://schemas.openxmlformats.org/officeDocument/2006/relationships" id="256" r:id="R48484a3eb36a496a"/>
-    <p:sldId xmlns:r="http://schemas.openxmlformats.org/officeDocument/2006/relationships" id="257" r:id="Rc7c696212e94406c"/>
-    <p:sldId xmlns:r="http://schemas.openxmlformats.org/officeDocument/2006/relationships" id="258" r:id="R0291c5e5788d4e5a"/>
-    <p:sldId xmlns:r="http://schemas.openxmlformats.org/officeDocument/2006/relationships" id="259" r:id="R855933dc3c0a4b70"/>
-    <p:sldId xmlns:r="http://schemas.openxmlformats.org/officeDocument/2006/relationships" id="260" r:id="R00b7f3f944ac4bfb"/>
-    <p:sldId xmlns:r="http://schemas.openxmlformats.org/officeDocument/2006/relationships" id="261" r:id="R6d0bda3c58894f96"/>
-    <p:sldId xmlns:r="http://schemas.openxmlformats.org/officeDocument/2006/relationships" id="262" r:id="Rbd0ed8e2225f4c38"/>
-    <p:sldId xmlns:r="http://schemas.openxmlformats.org/officeDocument/2006/relationships" id="263" r:id="Rcf1ee6fff958435f"/>
+    <p:sldId xmlns:r="http://schemas.openxmlformats.org/officeDocument/2006/relationships" id="256" r:id="R678ee97100b14eb5"/>
+    <p:sldId xmlns:r="http://schemas.openxmlformats.org/officeDocument/2006/relationships" id="257" r:id="Ra04ec3cfc9304988"/>
+    <p:sldId xmlns:r="http://schemas.openxmlformats.org/officeDocument/2006/relationships" id="258" r:id="Ra65e02168a9f474f"/>
+    <p:sldId xmlns:r="http://schemas.openxmlformats.org/officeDocument/2006/relationships" id="259" r:id="Rada5dfbc0cf742df"/>
+    <p:sldId xmlns:r="http://schemas.openxmlformats.org/officeDocument/2006/relationships" id="260" r:id="R53c1a697b41d4315"/>
+    <p:sldId xmlns:r="http://schemas.openxmlformats.org/officeDocument/2006/relationships" id="261" r:id="R7c66255262b04594"/>
+    <p:sldId xmlns:r="http://schemas.openxmlformats.org/officeDocument/2006/relationships" id="262" r:id="R6afba09fbe5a4711"/>
+    <p:sldId xmlns:r="http://schemas.openxmlformats.org/officeDocument/2006/relationships" id="263" r:id="R9075cb68ecf74eac"/>
   </p:sldIdLst>
   <p:sldSz cx="12192000" cy="6858000"/>
   <p:notesSz cx="6858000" cy="9144000"/>
@@ -1070,7 +1070,7 @@
   </p:cSld>
   <p:clrMap bg1="lt1" tx1="dk1" bg2="lt2" tx2="dk2" accent1="accent1" accent2="accent2" accent3="accent3" accent4="accent4" accent5="accent5" accent6="accent6" hlink="hlink" folHlink="folHlink"/>
   <p:sldLayoutIdLst>
-    <p:sldLayoutId xmlns:r="http://schemas.openxmlformats.org/officeDocument/2006/relationships" id="2147483649" r:id="Rc918627e2bc742d7"/>
+    <p:sldLayoutId xmlns:r="http://schemas.openxmlformats.org/officeDocument/2006/relationships" id="2147483649" r:id="Rd2c92399df6b4f1b"/>
   </p:sldLayoutIdLst>
   <p:txStyles>
     <p:titleStyle>
@@ -1621,7 +1621,7 @@
           <p:cNvPr id="1" name="">
             <a:extLst xmlns:a="http://schemas.openxmlformats.org/drawingml/2006/main">
               <a:ext uri="{FF2B5EF4-FFF2-40B4-BE49-F238E27FC236}">
-                <a16:creationId xmlns:a16="http://schemas.microsoft.com/office/drawing/2014/main" id="{95E01367-A256-41C1-A81E-24AA8DC267FB}"/>
+                <a16:creationId xmlns:a16="http://schemas.microsoft.com/office/drawing/2014/main" id="{875B690E-A07A-4989-AE81-A8EE5EE48153}"/>
               </a:ext>
             </a:extLst>
           </p:cNvPr>
@@ -1671,7 +1671,7 @@
           <p:cNvPr id="2" name="">
             <a:extLst xmlns:a="http://schemas.openxmlformats.org/drawingml/2006/main">
               <a:ext uri="{FF2B5EF4-FFF2-40B4-BE49-F238E27FC236}">
-                <a16:creationId xmlns:a16="http://schemas.microsoft.com/office/drawing/2014/main" id="{4300ED2E-53F8-4081-A3ED-8BE066142AFF}"/>
+                <a16:creationId xmlns:a16="http://schemas.microsoft.com/office/drawing/2014/main" id="{B84FEC1E-E3AB-4141-9FB8-90EC06DA4562}"/>
               </a:ext>
             </a:extLst>
           </p:cNvPr>
@@ -1721,7 +1721,7 @@
           <p:cNvPr id="3" name="">
             <a:extLst xmlns:a="http://schemas.openxmlformats.org/drawingml/2006/main">
               <a:ext uri="{FF2B5EF4-FFF2-40B4-BE49-F238E27FC236}">
-                <a16:creationId xmlns:a16="http://schemas.microsoft.com/office/drawing/2014/main" id="{9D7B107C-ADF1-46B6-8670-74B5FA0C9796}"/>
+                <a16:creationId xmlns:a16="http://schemas.microsoft.com/office/drawing/2014/main" id="{55E58663-06D3-48E6-ACE7-A5B00D733EAF}"/>
               </a:ext>
             </a:extLst>
           </p:cNvPr>
@@ -1771,7 +1771,7 @@
           <p:cNvPr id="4" name="">
             <a:extLst xmlns:a="http://schemas.openxmlformats.org/drawingml/2006/main">
               <a:ext uri="{FF2B5EF4-FFF2-40B4-BE49-F238E27FC236}">
-                <a16:creationId xmlns:a16="http://schemas.microsoft.com/office/drawing/2014/main" id="{0D6BB137-A13C-46B5-BD65-9639822CF2CF}"/>
+                <a16:creationId xmlns:a16="http://schemas.microsoft.com/office/drawing/2014/main" id="{4C11AE14-DA08-46D8-8795-D2197DFEB14A}"/>
               </a:ext>
             </a:extLst>
           </p:cNvPr>
@@ -1810,7 +1810,7 @@
           <p:nvPr/>
         </p:nvPicPr>
         <p:blipFill>
-          <a:blip xmlns:r="http://schemas.openxmlformats.org/officeDocument/2006/relationships" xmlns:a="http://schemas.openxmlformats.org/drawingml/2006/main" r:embed="Re1925ff221324acf"/>
+          <a:blip xmlns:r="http://schemas.openxmlformats.org/officeDocument/2006/relationships" xmlns:a="http://schemas.openxmlformats.org/drawingml/2006/main" r:embed="Rfd369d06408d4a46"/>
           <a:srcRect xmlns:a="http://schemas.openxmlformats.org/drawingml/2006/main" l="12678" t="0" r="12678" b="0"/>
           <a:stretch xmlns:a="http://schemas.openxmlformats.org/drawingml/2006/main">
             <a:fillRect l="0" t="0" r="0" b="0"/>
@@ -1833,7 +1833,7 @@
           <p:cNvPr id="6" name="">
             <a:extLst xmlns:a="http://schemas.openxmlformats.org/drawingml/2006/main">
               <a:ext uri="{FF2B5EF4-FFF2-40B4-BE49-F238E27FC236}">
-                <a16:creationId xmlns:a16="http://schemas.microsoft.com/office/drawing/2014/main" id="{B69AC76E-0D33-4A86-ADF4-0F8C1141B8A1}"/>
+                <a16:creationId xmlns:a16="http://schemas.microsoft.com/office/drawing/2014/main" id="{A83E4AE6-D2FB-4973-A2F7-D8C5C1EE5B49}"/>
               </a:ext>
             </a:extLst>
           </p:cNvPr>
@@ -1881,7 +1881,7 @@
     </p:spTree>
     <p:extLst>
       <p:ext uri="{BB962C8B-B14F-4D97-AF65-F5344CB8AC3E}">
-        <p14:creationId xmlns:p14="http://schemas.microsoft.com/office/powerpoint/2010/main" val="906194732"/>
+        <p14:creationId xmlns:p14="http://schemas.microsoft.com/office/powerpoint/2010/main" val="1794714101"/>
       </p:ext>
     </p:extLst>
   </p:cSld>
@@ -1912,7 +1912,7 @@
           <p:cNvPr id="1" name="">
             <a:extLst xmlns:a="http://schemas.openxmlformats.org/drawingml/2006/main">
               <a:ext uri="{FF2B5EF4-FFF2-40B4-BE49-F238E27FC236}">
-                <a16:creationId xmlns:a16="http://schemas.microsoft.com/office/drawing/2014/main" id="{450B1EC4-F44C-4751-A26D-6C4A50CFCC83}"/>
+                <a16:creationId xmlns:a16="http://schemas.microsoft.com/office/drawing/2014/main" id="{3FD3EAEB-28B3-4E80-9A11-4AB026691B6B}"/>
               </a:ext>
             </a:extLst>
           </p:cNvPr>
@@ -1962,7 +1962,7 @@
           <p:cNvPr id="2" name="">
             <a:extLst xmlns:a="http://schemas.openxmlformats.org/drawingml/2006/main">
               <a:ext uri="{FF2B5EF4-FFF2-40B4-BE49-F238E27FC236}">
-                <a16:creationId xmlns:a16="http://schemas.microsoft.com/office/drawing/2014/main" id="{EB4D3C8B-2699-415E-B50B-6415F795B457}"/>
+                <a16:creationId xmlns:a16="http://schemas.microsoft.com/office/drawing/2014/main" id="{76A881D6-EBC4-400F-944C-470BFA01CEAB}"/>
               </a:ext>
             </a:extLst>
           </p:cNvPr>
@@ -2012,7 +2012,7 @@
           <p:cNvPr id="3" name="">
             <a:extLst xmlns:a="http://schemas.openxmlformats.org/drawingml/2006/main">
               <a:ext uri="{FF2B5EF4-FFF2-40B4-BE49-F238E27FC236}">
-                <a16:creationId xmlns:a16="http://schemas.microsoft.com/office/drawing/2014/main" id="{9BCD1B04-9DCF-4BC5-97CE-BCC3317F45CB}"/>
+                <a16:creationId xmlns:a16="http://schemas.microsoft.com/office/drawing/2014/main" id="{B76D1CC7-0450-4AD5-AC36-A23AF7497F1A}"/>
               </a:ext>
             </a:extLst>
           </p:cNvPr>
@@ -2045,7 +2045,7 @@
           <p:cNvPr id="4" name="">
             <a:extLst xmlns:a="http://schemas.openxmlformats.org/drawingml/2006/main">
               <a:ext uri="{FF2B5EF4-FFF2-40B4-BE49-F238E27FC236}">
-                <a16:creationId xmlns:a16="http://schemas.microsoft.com/office/drawing/2014/main" id="{A8630F4B-7AC7-4351-9A2A-C0521D38E67C}"/>
+                <a16:creationId xmlns:a16="http://schemas.microsoft.com/office/drawing/2014/main" id="{CECFB97D-F03D-446B-964C-65E12B0FE9FC}"/>
               </a:ext>
             </a:extLst>
           </p:cNvPr>
@@ -2095,7 +2095,7 @@
           <p:cNvPr id="5" name="">
             <a:extLst xmlns:a="http://schemas.openxmlformats.org/drawingml/2006/main">
               <a:ext uri="{FF2B5EF4-FFF2-40B4-BE49-F238E27FC236}">
-                <a16:creationId xmlns:a16="http://schemas.microsoft.com/office/drawing/2014/main" id="{F5168F10-7BEA-4426-A062-2C738A080382}"/>
+                <a16:creationId xmlns:a16="http://schemas.microsoft.com/office/drawing/2014/main" id="{8BBB6481-BB43-4EFE-8DFB-13E1B305E13C}"/>
               </a:ext>
             </a:extLst>
           </p:cNvPr>
@@ -2128,7 +2128,7 @@
           <p:cNvPr id="6" name="">
             <a:extLst xmlns:a="http://schemas.openxmlformats.org/drawingml/2006/main">
               <a:ext uri="{FF2B5EF4-FFF2-40B4-BE49-F238E27FC236}">
-                <a16:creationId xmlns:a16="http://schemas.microsoft.com/office/drawing/2014/main" id="{FCB706C7-FC8F-452F-A5EC-E7346AFE1090}"/>
+                <a16:creationId xmlns:a16="http://schemas.microsoft.com/office/drawing/2014/main" id="{52B0B018-0BF4-4368-9CB9-32561BEFCB65}"/>
               </a:ext>
             </a:extLst>
           </p:cNvPr>
@@ -2178,7 +2178,7 @@
           <p:cNvPr id="7" name="">
             <a:extLst xmlns:a="http://schemas.openxmlformats.org/drawingml/2006/main">
               <a:ext uri="{FF2B5EF4-FFF2-40B4-BE49-F238E27FC236}">
-                <a16:creationId xmlns:a16="http://schemas.microsoft.com/office/drawing/2014/main" id="{A4D3C061-0D86-4D38-BD44-03C68DCCF186}"/>
+                <a16:creationId xmlns:a16="http://schemas.microsoft.com/office/drawing/2014/main" id="{57F65B0D-FF13-420F-8ACD-1651063079DE}"/>
               </a:ext>
             </a:extLst>
           </p:cNvPr>
@@ -2211,7 +2211,7 @@
           <p:cNvPr id="8" name="">
             <a:extLst xmlns:a="http://schemas.openxmlformats.org/drawingml/2006/main">
               <a:ext uri="{FF2B5EF4-FFF2-40B4-BE49-F238E27FC236}">
-                <a16:creationId xmlns:a16="http://schemas.microsoft.com/office/drawing/2014/main" id="{AB300499-2CD7-4E29-86D5-89DC45C45A57}"/>
+                <a16:creationId xmlns:a16="http://schemas.microsoft.com/office/drawing/2014/main" id="{F95C6729-6CA4-406D-AF86-3D40076FAC33}"/>
               </a:ext>
             </a:extLst>
           </p:cNvPr>
@@ -2261,7 +2261,7 @@
           <p:cNvPr id="9" name="">
             <a:extLst xmlns:a="http://schemas.openxmlformats.org/drawingml/2006/main">
               <a:ext uri="{FF2B5EF4-FFF2-40B4-BE49-F238E27FC236}">
-                <a16:creationId xmlns:a16="http://schemas.microsoft.com/office/drawing/2014/main" id="{DF0F8DDD-C518-44DA-AE9D-AEAB1BE0303A}"/>
+                <a16:creationId xmlns:a16="http://schemas.microsoft.com/office/drawing/2014/main" id="{8C26EB7F-4073-4C20-84F9-9F42C3A78330}"/>
               </a:ext>
             </a:extLst>
           </p:cNvPr>
@@ -2294,7 +2294,7 @@
           <p:cNvPr id="10" name="">
             <a:extLst xmlns:a="http://schemas.openxmlformats.org/drawingml/2006/main">
               <a:ext uri="{FF2B5EF4-FFF2-40B4-BE49-F238E27FC236}">
-                <a16:creationId xmlns:a16="http://schemas.microsoft.com/office/drawing/2014/main" id="{6EADE638-DD39-406D-9D48-D1355AA899B9}"/>
+                <a16:creationId xmlns:a16="http://schemas.microsoft.com/office/drawing/2014/main" id="{3868C3EB-4A09-47D0-95B0-5FB71B2DF38A}"/>
               </a:ext>
             </a:extLst>
           </p:cNvPr>
@@ -2344,7 +2344,7 @@
           <p:cNvPr id="11" name="">
             <a:extLst xmlns:a="http://schemas.openxmlformats.org/drawingml/2006/main">
               <a:ext uri="{FF2B5EF4-FFF2-40B4-BE49-F238E27FC236}">
-                <a16:creationId xmlns:a16="http://schemas.microsoft.com/office/drawing/2014/main" id="{DCDFFF14-7928-42A3-A8E8-0DAFD871B4B5}"/>
+                <a16:creationId xmlns:a16="http://schemas.microsoft.com/office/drawing/2014/main" id="{BBC1A41B-1E0E-4B07-A7C1-B4719E016106}"/>
               </a:ext>
             </a:extLst>
           </p:cNvPr>
@@ -2379,7 +2379,7 @@
           <p:cNvPr id="12" name="">
             <a:extLst xmlns:a="http://schemas.openxmlformats.org/drawingml/2006/main">
               <a:ext uri="{FF2B5EF4-FFF2-40B4-BE49-F238E27FC236}">
-                <a16:creationId xmlns:a16="http://schemas.microsoft.com/office/drawing/2014/main" id="{B2CE6259-7AB1-4DCA-BC86-612A48EF428F}"/>
+                <a16:creationId xmlns:a16="http://schemas.microsoft.com/office/drawing/2014/main" id="{02764C95-9676-48C7-BB3A-31B140A1F7ED}"/>
               </a:ext>
             </a:extLst>
           </p:cNvPr>
@@ -2429,7 +2429,7 @@
           <p:cNvPr id="13" name="">
             <a:extLst xmlns:a="http://schemas.openxmlformats.org/drawingml/2006/main">
               <a:ext uri="{FF2B5EF4-FFF2-40B4-BE49-F238E27FC236}">
-                <a16:creationId xmlns:a16="http://schemas.microsoft.com/office/drawing/2014/main" id="{F9F40EE2-14D4-4481-96AE-FD71DE0B224A}"/>
+                <a16:creationId xmlns:a16="http://schemas.microsoft.com/office/drawing/2014/main" id="{9068D020-C2EC-455A-8FAB-641D37C51A83}"/>
               </a:ext>
             </a:extLst>
           </p:cNvPr>
@@ -2477,7 +2477,7 @@
     </p:spTree>
     <p:extLst>
       <p:ext uri="{BB962C8B-B14F-4D97-AF65-F5344CB8AC3E}">
-        <p14:creationId xmlns:p14="http://schemas.microsoft.com/office/powerpoint/2010/main" val="1622649426"/>
+        <p14:creationId xmlns:p14="http://schemas.microsoft.com/office/powerpoint/2010/main" val="1842212829"/>
       </p:ext>
     </p:extLst>
   </p:cSld>
@@ -2508,7 +2508,7 @@
           <p:cNvPr id="1" name="">
             <a:extLst xmlns:a="http://schemas.openxmlformats.org/drawingml/2006/main">
               <a:ext uri="{FF2B5EF4-FFF2-40B4-BE49-F238E27FC236}">
-                <a16:creationId xmlns:a16="http://schemas.microsoft.com/office/drawing/2014/main" id="{E588C220-7BF3-45B4-AF89-3BE5D5EBC400}"/>
+                <a16:creationId xmlns:a16="http://schemas.microsoft.com/office/drawing/2014/main" id="{1C32BA12-EE54-4914-BB73-DF35687AA753}"/>
               </a:ext>
             </a:extLst>
           </p:cNvPr>
@@ -2558,7 +2558,7 @@
           <p:cNvPr id="2" name="">
             <a:extLst xmlns:a="http://schemas.openxmlformats.org/drawingml/2006/main">
               <a:ext uri="{FF2B5EF4-FFF2-40B4-BE49-F238E27FC236}">
-                <a16:creationId xmlns:a16="http://schemas.microsoft.com/office/drawing/2014/main" id="{F2C4F286-4DDE-4E8A-9A36-90C8A39A2D13}"/>
+                <a16:creationId xmlns:a16="http://schemas.microsoft.com/office/drawing/2014/main" id="{634BF3D7-C6A6-4B83-A69B-0CFB5E2AB3E6}"/>
               </a:ext>
             </a:extLst>
           </p:cNvPr>
@@ -2608,7 +2608,7 @@
           <p:cNvPr id="3" name="">
             <a:extLst xmlns:a="http://schemas.openxmlformats.org/drawingml/2006/main">
               <a:ext uri="{FF2B5EF4-FFF2-40B4-BE49-F238E27FC236}">
-                <a16:creationId xmlns:a16="http://schemas.microsoft.com/office/drawing/2014/main" id="{7DB269BD-4B05-43CF-85D8-A1C209C992F1}"/>
+                <a16:creationId xmlns:a16="http://schemas.microsoft.com/office/drawing/2014/main" id="{DA91C5E8-226E-4EFE-994A-BA84DA074391}"/>
               </a:ext>
             </a:extLst>
           </p:cNvPr>
@@ -2641,7 +2641,7 @@
           <p:cNvPr id="4" name="">
             <a:extLst xmlns:a="http://schemas.openxmlformats.org/drawingml/2006/main">
               <a:ext uri="{FF2B5EF4-FFF2-40B4-BE49-F238E27FC236}">
-                <a16:creationId xmlns:a16="http://schemas.microsoft.com/office/drawing/2014/main" id="{CB25D34F-1986-4E92-AC49-519C62195B86}"/>
+                <a16:creationId xmlns:a16="http://schemas.microsoft.com/office/drawing/2014/main" id="{A2C954B4-A490-4C0C-97F6-2EE501D57927}"/>
               </a:ext>
             </a:extLst>
           </p:cNvPr>
@@ -2691,7 +2691,7 @@
           <p:cNvPr id="5" name="">
             <a:extLst xmlns:a="http://schemas.openxmlformats.org/drawingml/2006/main">
               <a:ext uri="{FF2B5EF4-FFF2-40B4-BE49-F238E27FC236}">
-                <a16:creationId xmlns:a16="http://schemas.microsoft.com/office/drawing/2014/main" id="{AADC26E0-C3E8-4562-810B-1B45E516668D}"/>
+                <a16:creationId xmlns:a16="http://schemas.microsoft.com/office/drawing/2014/main" id="{5F77ABC6-5FA2-47C3-90AB-311604D64216}"/>
               </a:ext>
             </a:extLst>
           </p:cNvPr>
@@ -2726,7 +2726,7 @@
           <p:cNvPr id="6" name="">
             <a:extLst xmlns:a="http://schemas.openxmlformats.org/drawingml/2006/main">
               <a:ext uri="{FF2B5EF4-FFF2-40B4-BE49-F238E27FC236}">
-                <a16:creationId xmlns:a16="http://schemas.microsoft.com/office/drawing/2014/main" id="{7AF09C30-7FBB-4457-9EB8-10C98C67337A}"/>
+                <a16:creationId xmlns:a16="http://schemas.microsoft.com/office/drawing/2014/main" id="{E93E3BD8-9801-46F0-B905-52C91A9D60F6}"/>
               </a:ext>
             </a:extLst>
           </p:cNvPr>
@@ -2776,7 +2776,7 @@
           <p:cNvPr id="7" name="">
             <a:extLst xmlns:a="http://schemas.openxmlformats.org/drawingml/2006/main">
               <a:ext uri="{FF2B5EF4-FFF2-40B4-BE49-F238E27FC236}">
-                <a16:creationId xmlns:a16="http://schemas.microsoft.com/office/drawing/2014/main" id="{44B28240-C55D-4CFA-9885-B95C2FA5C0A4}"/>
+                <a16:creationId xmlns:a16="http://schemas.microsoft.com/office/drawing/2014/main" id="{0109362C-7E21-4647-8319-7259EC51DD64}"/>
               </a:ext>
             </a:extLst>
           </p:cNvPr>
@@ -2826,7 +2826,7 @@
           <p:cNvPr id="8" name="">
             <a:extLst xmlns:a="http://schemas.openxmlformats.org/drawingml/2006/main">
               <a:ext uri="{FF2B5EF4-FFF2-40B4-BE49-F238E27FC236}">
-                <a16:creationId xmlns:a16="http://schemas.microsoft.com/office/drawing/2014/main" id="{01B7E37D-2B30-46A3-A455-E052AD665891}"/>
+                <a16:creationId xmlns:a16="http://schemas.microsoft.com/office/drawing/2014/main" id="{C79AAEFB-54FF-414A-BEFA-C38936E6128E}"/>
               </a:ext>
             </a:extLst>
           </p:cNvPr>
@@ -2861,7 +2861,7 @@
           <p:cNvPr id="9" name="">
             <a:extLst xmlns:a="http://schemas.openxmlformats.org/drawingml/2006/main">
               <a:ext uri="{FF2B5EF4-FFF2-40B4-BE49-F238E27FC236}">
-                <a16:creationId xmlns:a16="http://schemas.microsoft.com/office/drawing/2014/main" id="{B1BCF881-762C-4B7A-B458-55511B275A0F}"/>
+                <a16:creationId xmlns:a16="http://schemas.microsoft.com/office/drawing/2014/main" id="{E3BAC4C0-4B90-4246-BDD4-7E0AA4EA6CA6}"/>
               </a:ext>
             </a:extLst>
           </p:cNvPr>
@@ -2911,7 +2911,7 @@
           <p:cNvPr id="10" name="">
             <a:extLst xmlns:a="http://schemas.openxmlformats.org/drawingml/2006/main">
               <a:ext uri="{FF2B5EF4-FFF2-40B4-BE49-F238E27FC236}">
-                <a16:creationId xmlns:a16="http://schemas.microsoft.com/office/drawing/2014/main" id="{F917D029-50A7-4C90-AA66-5089C6FFEAB9}"/>
+                <a16:creationId xmlns:a16="http://schemas.microsoft.com/office/drawing/2014/main" id="{CE375823-57AB-496E-836F-F320781440E6}"/>
               </a:ext>
             </a:extLst>
           </p:cNvPr>
@@ -2961,7 +2961,7 @@
           <p:cNvPr id="11" name="">
             <a:extLst xmlns:a="http://schemas.openxmlformats.org/drawingml/2006/main">
               <a:ext uri="{FF2B5EF4-FFF2-40B4-BE49-F238E27FC236}">
-                <a16:creationId xmlns:a16="http://schemas.microsoft.com/office/drawing/2014/main" id="{5DE122BB-409B-4F93-937E-6A45A7E11C18}"/>
+                <a16:creationId xmlns:a16="http://schemas.microsoft.com/office/drawing/2014/main" id="{07B91229-8DA7-47D0-8BDD-15BB3914A30F}"/>
               </a:ext>
             </a:extLst>
           </p:cNvPr>
@@ -2996,7 +2996,7 @@
           <p:cNvPr id="12" name="">
             <a:extLst xmlns:a="http://schemas.openxmlformats.org/drawingml/2006/main">
               <a:ext uri="{FF2B5EF4-FFF2-40B4-BE49-F238E27FC236}">
-                <a16:creationId xmlns:a16="http://schemas.microsoft.com/office/drawing/2014/main" id="{9677731B-266B-4C7E-BA14-D99A1CCA8E28}"/>
+                <a16:creationId xmlns:a16="http://schemas.microsoft.com/office/drawing/2014/main" id="{761BB564-B233-4D86-B523-B8808DE52DE4}"/>
               </a:ext>
             </a:extLst>
           </p:cNvPr>
@@ -3046,7 +3046,7 @@
           <p:cNvPr id="13" name="">
             <a:extLst xmlns:a="http://schemas.openxmlformats.org/drawingml/2006/main">
               <a:ext uri="{FF2B5EF4-FFF2-40B4-BE49-F238E27FC236}">
-                <a16:creationId xmlns:a16="http://schemas.microsoft.com/office/drawing/2014/main" id="{1F9E0165-906C-44AE-9259-3841EC7B5442}"/>
+                <a16:creationId xmlns:a16="http://schemas.microsoft.com/office/drawing/2014/main" id="{CB9F032F-FABD-4238-9F3C-100699E2721B}"/>
               </a:ext>
             </a:extLst>
           </p:cNvPr>
@@ -3096,7 +3096,7 @@
           <p:cNvPr id="14" name="">
             <a:extLst xmlns:a="http://schemas.openxmlformats.org/drawingml/2006/main">
               <a:ext uri="{FF2B5EF4-FFF2-40B4-BE49-F238E27FC236}">
-                <a16:creationId xmlns:a16="http://schemas.microsoft.com/office/drawing/2014/main" id="{9C4BF41D-216E-467C-A846-B8D605D17264}"/>
+                <a16:creationId xmlns:a16="http://schemas.microsoft.com/office/drawing/2014/main" id="{E0C87802-6AB9-4072-87FC-E0B3700EE6BB}"/>
               </a:ext>
             </a:extLst>
           </p:cNvPr>
@@ -3131,7 +3131,7 @@
           <p:cNvPr id="15" name="">
             <a:extLst xmlns:a="http://schemas.openxmlformats.org/drawingml/2006/main">
               <a:ext uri="{FF2B5EF4-FFF2-40B4-BE49-F238E27FC236}">
-                <a16:creationId xmlns:a16="http://schemas.microsoft.com/office/drawing/2014/main" id="{66135D47-FC69-4B61-90FA-4F2AA8897298}"/>
+                <a16:creationId xmlns:a16="http://schemas.microsoft.com/office/drawing/2014/main" id="{0B4C7DE8-E346-4B75-A430-16368CE84D47}"/>
               </a:ext>
             </a:extLst>
           </p:cNvPr>
@@ -3181,7 +3181,7 @@
           <p:cNvPr id="16" name="">
             <a:extLst xmlns:a="http://schemas.openxmlformats.org/drawingml/2006/main">
               <a:ext uri="{FF2B5EF4-FFF2-40B4-BE49-F238E27FC236}">
-                <a16:creationId xmlns:a16="http://schemas.microsoft.com/office/drawing/2014/main" id="{EB2D78BB-37AB-47D1-AC37-75DEDCB1B926}"/>
+                <a16:creationId xmlns:a16="http://schemas.microsoft.com/office/drawing/2014/main" id="{BE7AFABD-06CB-4698-A3BE-4001444888B2}"/>
               </a:ext>
             </a:extLst>
           </p:cNvPr>
@@ -3231,7 +3231,7 @@
           <p:cNvPr id="17" name="">
             <a:extLst xmlns:a="http://schemas.openxmlformats.org/drawingml/2006/main">
               <a:ext uri="{FF2B5EF4-FFF2-40B4-BE49-F238E27FC236}">
-                <a16:creationId xmlns:a16="http://schemas.microsoft.com/office/drawing/2014/main" id="{55BE6304-6F49-46E8-93BD-8E8E3B18ED03}"/>
+                <a16:creationId xmlns:a16="http://schemas.microsoft.com/office/drawing/2014/main" id="{9C2FDF00-A7AD-4133-9A04-49E929F34DE4}"/>
               </a:ext>
             </a:extLst>
           </p:cNvPr>
@@ -3279,7 +3279,7 @@
     </p:spTree>
     <p:extLst>
       <p:ext uri="{BB962C8B-B14F-4D97-AF65-F5344CB8AC3E}">
-        <p14:creationId xmlns:p14="http://schemas.microsoft.com/office/powerpoint/2010/main" val="458363803"/>
+        <p14:creationId xmlns:p14="http://schemas.microsoft.com/office/powerpoint/2010/main" val="650771523"/>
       </p:ext>
     </p:extLst>
   </p:cSld>
@@ -3310,7 +3310,7 @@
           <p:cNvPr id="1" name="">
             <a:extLst xmlns:a="http://schemas.openxmlformats.org/drawingml/2006/main">
               <a:ext uri="{FF2B5EF4-FFF2-40B4-BE49-F238E27FC236}">
-                <a16:creationId xmlns:a16="http://schemas.microsoft.com/office/drawing/2014/main" id="{1EAD47E6-1F2C-44DE-AEC0-8B0580D825F2}"/>
+                <a16:creationId xmlns:a16="http://schemas.microsoft.com/office/drawing/2014/main" id="{8D29CCF8-F9B1-4638-8031-255B6D754AFB}"/>
               </a:ext>
             </a:extLst>
           </p:cNvPr>
@@ -3360,7 +3360,7 @@
           <p:cNvPr id="2" name="">
             <a:extLst xmlns:a="http://schemas.openxmlformats.org/drawingml/2006/main">
               <a:ext uri="{FF2B5EF4-FFF2-40B4-BE49-F238E27FC236}">
-                <a16:creationId xmlns:a16="http://schemas.microsoft.com/office/drawing/2014/main" id="{2DE1EE9A-4DA0-4649-AE84-636DD89D45C4}"/>
+                <a16:creationId xmlns:a16="http://schemas.microsoft.com/office/drawing/2014/main" id="{D2C8D886-E906-4748-AFCA-3BE02A437A8B}"/>
               </a:ext>
             </a:extLst>
           </p:cNvPr>
@@ -3410,7 +3410,7 @@
           <p:cNvPr id="3" name="">
             <a:extLst xmlns:a="http://schemas.openxmlformats.org/drawingml/2006/main">
               <a:ext uri="{FF2B5EF4-FFF2-40B4-BE49-F238E27FC236}">
-                <a16:creationId xmlns:a16="http://schemas.microsoft.com/office/drawing/2014/main" id="{612E2416-8E3F-40A9-A02E-108CFD14A26A}"/>
+                <a16:creationId xmlns:a16="http://schemas.microsoft.com/office/drawing/2014/main" id="{66E5F677-00FB-453C-8224-33D76A521064}"/>
               </a:ext>
             </a:extLst>
           </p:cNvPr>
@@ -3443,7 +3443,7 @@
           <p:cNvPr id="4" name="">
             <a:extLst xmlns:a="http://schemas.openxmlformats.org/drawingml/2006/main">
               <a:ext uri="{FF2B5EF4-FFF2-40B4-BE49-F238E27FC236}">
-                <a16:creationId xmlns:a16="http://schemas.microsoft.com/office/drawing/2014/main" id="{5E844C12-91F3-40A4-9771-C23EEA6A8476}"/>
+                <a16:creationId xmlns:a16="http://schemas.microsoft.com/office/drawing/2014/main" id="{9C79258F-52FF-41F9-9997-F27330E377AB}"/>
               </a:ext>
             </a:extLst>
           </p:cNvPr>
@@ -3493,7 +3493,7 @@
           <p:cNvPr id="5" name="">
             <a:extLst xmlns:a="http://schemas.openxmlformats.org/drawingml/2006/main">
               <a:ext uri="{FF2B5EF4-FFF2-40B4-BE49-F238E27FC236}">
-                <a16:creationId xmlns:a16="http://schemas.microsoft.com/office/drawing/2014/main" id="{46824491-C899-4546-806B-1954753AFC1C}"/>
+                <a16:creationId xmlns:a16="http://schemas.microsoft.com/office/drawing/2014/main" id="{9044DAA4-9C28-4435-A038-3CA69B93B411}"/>
               </a:ext>
             </a:extLst>
           </p:cNvPr>
@@ -3547,7 +3547,7 @@
           <p:nvPr/>
         </p:nvPicPr>
         <p:blipFill>
-          <a:blip xmlns:r="http://schemas.openxmlformats.org/officeDocument/2006/relationships" xmlns:a="http://schemas.openxmlformats.org/drawingml/2006/main" r:embed="R3c5cec4f5a524cb2"/>
+          <a:blip xmlns:r="http://schemas.openxmlformats.org/officeDocument/2006/relationships" xmlns:a="http://schemas.openxmlformats.org/drawingml/2006/main" r:embed="Recf761995ce5460e"/>
           <a:srcRect xmlns:a="http://schemas.openxmlformats.org/drawingml/2006/main" l="0" t="13" r="0" b="13"/>
           <a:stretch xmlns:a="http://schemas.openxmlformats.org/drawingml/2006/main">
             <a:fillRect l="0" t="0" r="0" b="0"/>
@@ -3568,7 +3568,7 @@
     </p:spTree>
     <p:extLst>
       <p:ext uri="{BB962C8B-B14F-4D97-AF65-F5344CB8AC3E}">
-        <p14:creationId xmlns:p14="http://schemas.microsoft.com/office/powerpoint/2010/main" val="1666208560"/>
+        <p14:creationId xmlns:p14="http://schemas.microsoft.com/office/powerpoint/2010/main" val="2067273823"/>
       </p:ext>
     </p:extLst>
   </p:cSld>
@@ -3599,7 +3599,7 @@
           <p:cNvPr id="1" name="">
             <a:extLst xmlns:a="http://schemas.openxmlformats.org/drawingml/2006/main">
               <a:ext uri="{FF2B5EF4-FFF2-40B4-BE49-F238E27FC236}">
-                <a16:creationId xmlns:a16="http://schemas.microsoft.com/office/drawing/2014/main" id="{5E5BFDC8-A1BC-4A0A-952F-A6C8C997E6BE}"/>
+                <a16:creationId xmlns:a16="http://schemas.microsoft.com/office/drawing/2014/main" id="{1AB6EB19-C7A8-4F6F-8725-10DC9DF365DF}"/>
               </a:ext>
             </a:extLst>
           </p:cNvPr>
@@ -3649,7 +3649,7 @@
           <p:cNvPr id="2" name="">
             <a:extLst xmlns:a="http://schemas.openxmlformats.org/drawingml/2006/main">
               <a:ext uri="{FF2B5EF4-FFF2-40B4-BE49-F238E27FC236}">
-                <a16:creationId xmlns:a16="http://schemas.microsoft.com/office/drawing/2014/main" id="{489D04C2-61B7-4011-BF24-52F3EA3DCF82}"/>
+                <a16:creationId xmlns:a16="http://schemas.microsoft.com/office/drawing/2014/main" id="{1683E5C7-2456-4ED8-B0FE-1D3BCEEC30B0}"/>
               </a:ext>
             </a:extLst>
           </p:cNvPr>
@@ -3699,7 +3699,7 @@
           <p:cNvPr id="3" name="">
             <a:extLst xmlns:a="http://schemas.openxmlformats.org/drawingml/2006/main">
               <a:ext uri="{FF2B5EF4-FFF2-40B4-BE49-F238E27FC236}">
-                <a16:creationId xmlns:a16="http://schemas.microsoft.com/office/drawing/2014/main" id="{EE6729FC-ECD5-4C14-B13F-16219F3FED07}"/>
+                <a16:creationId xmlns:a16="http://schemas.microsoft.com/office/drawing/2014/main" id="{ABE3A97A-ED53-4CF9-B1D5-B5D90950522E}"/>
               </a:ext>
             </a:extLst>
           </p:cNvPr>
@@ -3732,7 +3732,7 @@
           <p:cNvPr id="4" name="">
             <a:extLst xmlns:a="http://schemas.openxmlformats.org/drawingml/2006/main">
               <a:ext uri="{FF2B5EF4-FFF2-40B4-BE49-F238E27FC236}">
-                <a16:creationId xmlns:a16="http://schemas.microsoft.com/office/drawing/2014/main" id="{364224CB-6AB9-4932-BF80-05121D52DF70}"/>
+                <a16:creationId xmlns:a16="http://schemas.microsoft.com/office/drawing/2014/main" id="{4CFAE442-D1EA-4F31-8CE7-0F58D0D75B9A}"/>
               </a:ext>
             </a:extLst>
           </p:cNvPr>
@@ -3786,7 +3786,7 @@
           <p:nvPr/>
         </p:nvPicPr>
         <p:blipFill>
-          <a:blip xmlns:r="http://schemas.openxmlformats.org/officeDocument/2006/relationships" xmlns:a="http://schemas.openxmlformats.org/drawingml/2006/main" r:embed="R4f0c26c3e6db4168"/>
+          <a:blip xmlns:r="http://schemas.openxmlformats.org/officeDocument/2006/relationships" xmlns:a="http://schemas.openxmlformats.org/drawingml/2006/main" r:embed="Rfa4d4310f9c64f7e"/>
           <a:srcRect xmlns:a="http://schemas.openxmlformats.org/drawingml/2006/main" l="0" t="145" r="0" b="145"/>
           <a:stretch xmlns:a="http://schemas.openxmlformats.org/drawingml/2006/main">
             <a:fillRect l="0" t="0" r="0" b="0"/>
@@ -3809,7 +3809,7 @@
           <p:cNvPr id="6" name="">
             <a:extLst xmlns:a="http://schemas.openxmlformats.org/drawingml/2006/main">
               <a:ext uri="{FF2B5EF4-FFF2-40B4-BE49-F238E27FC236}">
-                <a16:creationId xmlns:a16="http://schemas.microsoft.com/office/drawing/2014/main" id="{83CA5DB1-1294-4F24-8DAA-E130C08C855F}"/>
+                <a16:creationId xmlns:a16="http://schemas.microsoft.com/office/drawing/2014/main" id="{087D46D7-9846-4348-B389-71E8F527C6B5}"/>
               </a:ext>
             </a:extLst>
           </p:cNvPr>
@@ -3842,7 +3842,7 @@
           <p:cNvPr id="7" name="">
             <a:extLst xmlns:a="http://schemas.openxmlformats.org/drawingml/2006/main">
               <a:ext uri="{FF2B5EF4-FFF2-40B4-BE49-F238E27FC236}">
-                <a16:creationId xmlns:a16="http://schemas.microsoft.com/office/drawing/2014/main" id="{53AFB8CB-7CB9-4ECF-84EF-1C217F006258}"/>
+                <a16:creationId xmlns:a16="http://schemas.microsoft.com/office/drawing/2014/main" id="{669018AB-03D0-431B-BB41-00539F1F4398}"/>
               </a:ext>
             </a:extLst>
           </p:cNvPr>
@@ -3892,7 +3892,7 @@
           <p:cNvPr id="8" name="">
             <a:extLst xmlns:a="http://schemas.openxmlformats.org/drawingml/2006/main">
               <a:ext uri="{FF2B5EF4-FFF2-40B4-BE49-F238E27FC236}">
-                <a16:creationId xmlns:a16="http://schemas.microsoft.com/office/drawing/2014/main" id="{6A36B3F8-AD00-4B9E-9250-17B9A59EBBC1}"/>
+                <a16:creationId xmlns:a16="http://schemas.microsoft.com/office/drawing/2014/main" id="{0F808DCD-4517-4D52-B263-CEABBE9B288F}"/>
               </a:ext>
             </a:extLst>
           </p:cNvPr>
@@ -3925,7 +3925,7 @@
           <p:cNvPr id="9" name="">
             <a:extLst xmlns:a="http://schemas.openxmlformats.org/drawingml/2006/main">
               <a:ext uri="{FF2B5EF4-FFF2-40B4-BE49-F238E27FC236}">
-                <a16:creationId xmlns:a16="http://schemas.microsoft.com/office/drawing/2014/main" id="{DFA34389-60CA-413E-90E8-16C4B72ED385}"/>
+                <a16:creationId xmlns:a16="http://schemas.microsoft.com/office/drawing/2014/main" id="{CA3C23DB-EFB9-4D2A-A4FB-4C0DED5DE921}"/>
               </a:ext>
             </a:extLst>
           </p:cNvPr>
@@ -3975,7 +3975,7 @@
           <p:cNvPr id="10" name="">
             <a:extLst xmlns:a="http://schemas.openxmlformats.org/drawingml/2006/main">
               <a:ext uri="{FF2B5EF4-FFF2-40B4-BE49-F238E27FC236}">
-                <a16:creationId xmlns:a16="http://schemas.microsoft.com/office/drawing/2014/main" id="{F35D76BD-52FB-4691-82EB-7FD338E0AC11}"/>
+                <a16:creationId xmlns:a16="http://schemas.microsoft.com/office/drawing/2014/main" id="{7E2BFDD7-2A5E-4A99-A0FF-13CD8B6EF53B}"/>
               </a:ext>
             </a:extLst>
           </p:cNvPr>
@@ -4008,7 +4008,7 @@
           <p:cNvPr id="11" name="">
             <a:extLst xmlns:a="http://schemas.openxmlformats.org/drawingml/2006/main">
               <a:ext uri="{FF2B5EF4-FFF2-40B4-BE49-F238E27FC236}">
-                <a16:creationId xmlns:a16="http://schemas.microsoft.com/office/drawing/2014/main" id="{25EFB354-25F8-46BE-9846-EC851D450E6D}"/>
+                <a16:creationId xmlns:a16="http://schemas.microsoft.com/office/drawing/2014/main" id="{6873AA01-AC0E-49E5-811B-740507695AF1}"/>
               </a:ext>
             </a:extLst>
           </p:cNvPr>
@@ -4058,7 +4058,7 @@
           <p:cNvPr id="12" name="">
             <a:extLst xmlns:a="http://schemas.openxmlformats.org/drawingml/2006/main">
               <a:ext uri="{FF2B5EF4-FFF2-40B4-BE49-F238E27FC236}">
-                <a16:creationId xmlns:a16="http://schemas.microsoft.com/office/drawing/2014/main" id="{368DF633-11D1-4A4E-8CE9-E7A55A377A3E}"/>
+                <a16:creationId xmlns:a16="http://schemas.microsoft.com/office/drawing/2014/main" id="{EB51B02B-DDA3-4F0B-AC60-557659329199}"/>
               </a:ext>
             </a:extLst>
           </p:cNvPr>
@@ -4091,7 +4091,7 @@
           <p:cNvPr id="13" name="">
             <a:extLst xmlns:a="http://schemas.openxmlformats.org/drawingml/2006/main">
               <a:ext uri="{FF2B5EF4-FFF2-40B4-BE49-F238E27FC236}">
-                <a16:creationId xmlns:a16="http://schemas.microsoft.com/office/drawing/2014/main" id="{E9BD0979-3F35-4F2E-A958-6D0595E2303C}"/>
+                <a16:creationId xmlns:a16="http://schemas.microsoft.com/office/drawing/2014/main" id="{4B88CBFA-F10D-470A-A37A-F4D64A2BF1E4}"/>
               </a:ext>
             </a:extLst>
           </p:cNvPr>
@@ -4139,7 +4139,7 @@
     </p:spTree>
     <p:extLst>
       <p:ext uri="{BB962C8B-B14F-4D97-AF65-F5344CB8AC3E}">
-        <p14:creationId xmlns:p14="http://schemas.microsoft.com/office/powerpoint/2010/main" val="772780203"/>
+        <p14:creationId xmlns:p14="http://schemas.microsoft.com/office/powerpoint/2010/main" val="1112444734"/>
       </p:ext>
     </p:extLst>
   </p:cSld>
@@ -4170,7 +4170,7 @@
           <p:cNvPr id="1" name="">
             <a:extLst xmlns:a="http://schemas.openxmlformats.org/drawingml/2006/main">
               <a:ext uri="{FF2B5EF4-FFF2-40B4-BE49-F238E27FC236}">
-                <a16:creationId xmlns:a16="http://schemas.microsoft.com/office/drawing/2014/main" id="{2110CCD8-1214-496B-9EC4-EA99BE97D77D}"/>
+                <a16:creationId xmlns:a16="http://schemas.microsoft.com/office/drawing/2014/main" id="{71F24081-0F01-4F52-B19F-85F32657867D}"/>
               </a:ext>
             </a:extLst>
           </p:cNvPr>
@@ -4220,7 +4220,7 @@
           <p:cNvPr id="2" name="">
             <a:extLst xmlns:a="http://schemas.openxmlformats.org/drawingml/2006/main">
               <a:ext uri="{FF2B5EF4-FFF2-40B4-BE49-F238E27FC236}">
-                <a16:creationId xmlns:a16="http://schemas.microsoft.com/office/drawing/2014/main" id="{0207081A-742D-4345-923E-AB3F17AD6882}"/>
+                <a16:creationId xmlns:a16="http://schemas.microsoft.com/office/drawing/2014/main" id="{2E820166-A3F7-4313-A2B8-C56341ADF4A5}"/>
               </a:ext>
             </a:extLst>
           </p:cNvPr>
@@ -4270,7 +4270,7 @@
           <p:cNvPr id="3" name="">
             <a:extLst xmlns:a="http://schemas.openxmlformats.org/drawingml/2006/main">
               <a:ext uri="{FF2B5EF4-FFF2-40B4-BE49-F238E27FC236}">
-                <a16:creationId xmlns:a16="http://schemas.microsoft.com/office/drawing/2014/main" id="{65E0663A-ABEA-40BA-B9AA-A5908F3261A9}"/>
+                <a16:creationId xmlns:a16="http://schemas.microsoft.com/office/drawing/2014/main" id="{07E44798-56CF-4B36-8B7B-3C4F167ABC62}"/>
               </a:ext>
             </a:extLst>
           </p:cNvPr>
@@ -4303,7 +4303,7 @@
           <p:cNvPr id="4" name="">
             <a:extLst xmlns:a="http://schemas.openxmlformats.org/drawingml/2006/main">
               <a:ext uri="{FF2B5EF4-FFF2-40B4-BE49-F238E27FC236}">
-                <a16:creationId xmlns:a16="http://schemas.microsoft.com/office/drawing/2014/main" id="{24B867D3-6D5C-46AF-86DA-406E74C7C29A}"/>
+                <a16:creationId xmlns:a16="http://schemas.microsoft.com/office/drawing/2014/main" id="{C706BF59-027C-4F95-9F95-4CC33E17B2FD}"/>
               </a:ext>
             </a:extLst>
           </p:cNvPr>
@@ -4353,7 +4353,7 @@
           <p:cNvPr id="5" name="">
             <a:extLst xmlns:a="http://schemas.openxmlformats.org/drawingml/2006/main">
               <a:ext uri="{FF2B5EF4-FFF2-40B4-BE49-F238E27FC236}">
-                <a16:creationId xmlns:a16="http://schemas.microsoft.com/office/drawing/2014/main" id="{17C78A78-A43F-4E8F-86D9-008F4288A301}"/>
+                <a16:creationId xmlns:a16="http://schemas.microsoft.com/office/drawing/2014/main" id="{CF567CB3-4E03-4374-9E99-8BE7A6729963}"/>
               </a:ext>
             </a:extLst>
           </p:cNvPr>
@@ -4386,7 +4386,7 @@
           <p:cNvPr id="6" name="">
             <a:extLst xmlns:a="http://schemas.openxmlformats.org/drawingml/2006/main">
               <a:ext uri="{FF2B5EF4-FFF2-40B4-BE49-F238E27FC236}">
-                <a16:creationId xmlns:a16="http://schemas.microsoft.com/office/drawing/2014/main" id="{98FDCA4E-BA72-4346-A9D1-B9B13D3D3FE0}"/>
+                <a16:creationId xmlns:a16="http://schemas.microsoft.com/office/drawing/2014/main" id="{D8D0113F-66D0-4AD0-BC52-2DCE38BFEE8B}"/>
               </a:ext>
             </a:extLst>
           </p:cNvPr>
@@ -4436,7 +4436,7 @@
           <p:cNvPr id="7" name="">
             <a:extLst xmlns:a="http://schemas.openxmlformats.org/drawingml/2006/main">
               <a:ext uri="{FF2B5EF4-FFF2-40B4-BE49-F238E27FC236}">
-                <a16:creationId xmlns:a16="http://schemas.microsoft.com/office/drawing/2014/main" id="{14DA0594-1FD9-42A1-908D-8E67F4D7E707}"/>
+                <a16:creationId xmlns:a16="http://schemas.microsoft.com/office/drawing/2014/main" id="{AC00A1F9-DABF-4362-A441-9A960CEFD31B}"/>
               </a:ext>
             </a:extLst>
           </p:cNvPr>
@@ -4469,7 +4469,7 @@
           <p:cNvPr id="8" name="">
             <a:extLst xmlns:a="http://schemas.openxmlformats.org/drawingml/2006/main">
               <a:ext uri="{FF2B5EF4-FFF2-40B4-BE49-F238E27FC236}">
-                <a16:creationId xmlns:a16="http://schemas.microsoft.com/office/drawing/2014/main" id="{92B647AB-4E22-4CCA-BAF4-ADD59059B5E6}"/>
+                <a16:creationId xmlns:a16="http://schemas.microsoft.com/office/drawing/2014/main" id="{19215624-CA36-46EE-9C6F-3C2D7FEE9BEA}"/>
               </a:ext>
             </a:extLst>
           </p:cNvPr>
@@ -4519,7 +4519,7 @@
           <p:cNvPr id="9" name="">
             <a:extLst xmlns:a="http://schemas.openxmlformats.org/drawingml/2006/main">
               <a:ext uri="{FF2B5EF4-FFF2-40B4-BE49-F238E27FC236}">
-                <a16:creationId xmlns:a16="http://schemas.microsoft.com/office/drawing/2014/main" id="{46924515-70CB-4D37-99A5-B63C9433698A}"/>
+                <a16:creationId xmlns:a16="http://schemas.microsoft.com/office/drawing/2014/main" id="{3BAEA474-9821-4E96-A53D-AE10ED816501}"/>
               </a:ext>
             </a:extLst>
           </p:cNvPr>
@@ -4552,7 +4552,7 @@
           <p:cNvPr id="10" name="">
             <a:extLst xmlns:a="http://schemas.openxmlformats.org/drawingml/2006/main">
               <a:ext uri="{FF2B5EF4-FFF2-40B4-BE49-F238E27FC236}">
-                <a16:creationId xmlns:a16="http://schemas.microsoft.com/office/drawing/2014/main" id="{1298261B-3F26-4514-BAFD-ACCF3EAD3FB5}"/>
+                <a16:creationId xmlns:a16="http://schemas.microsoft.com/office/drawing/2014/main" id="{AE815100-ECE0-48A8-AFF1-22CCDFFDF747}"/>
               </a:ext>
             </a:extLst>
           </p:cNvPr>
@@ -4602,7 +4602,7 @@
           <p:cNvPr id="11" name="">
             <a:extLst xmlns:a="http://schemas.openxmlformats.org/drawingml/2006/main">
               <a:ext uri="{FF2B5EF4-FFF2-40B4-BE49-F238E27FC236}">
-                <a16:creationId xmlns:a16="http://schemas.microsoft.com/office/drawing/2014/main" id="{3E91A57C-E818-4285-BECF-1B344B394DEE}"/>
+                <a16:creationId xmlns:a16="http://schemas.microsoft.com/office/drawing/2014/main" id="{7853A924-FC17-4A5D-AFDC-AEEFDDC63206}"/>
               </a:ext>
             </a:extLst>
           </p:cNvPr>
@@ -4637,7 +4637,7 @@
           <p:cNvPr id="12" name="">
             <a:extLst xmlns:a="http://schemas.openxmlformats.org/drawingml/2006/main">
               <a:ext uri="{FF2B5EF4-FFF2-40B4-BE49-F238E27FC236}">
-                <a16:creationId xmlns:a16="http://schemas.microsoft.com/office/drawing/2014/main" id="{655859E5-F00F-4CFE-9C4F-1108BC65C400}"/>
+                <a16:creationId xmlns:a16="http://schemas.microsoft.com/office/drawing/2014/main" id="{8858946C-7578-4630-9540-57652EA2D95F}"/>
               </a:ext>
             </a:extLst>
           </p:cNvPr>
@@ -4687,7 +4687,7 @@
           <p:cNvPr id="13" name="">
             <a:extLst xmlns:a="http://schemas.openxmlformats.org/drawingml/2006/main">
               <a:ext uri="{FF2B5EF4-FFF2-40B4-BE49-F238E27FC236}">
-                <a16:creationId xmlns:a16="http://schemas.microsoft.com/office/drawing/2014/main" id="{5902E503-49B8-49FE-A862-FB220C61D655}"/>
+                <a16:creationId xmlns:a16="http://schemas.microsoft.com/office/drawing/2014/main" id="{ECB3BB6D-A7D2-466F-A67D-6468C62BC96F}"/>
               </a:ext>
             </a:extLst>
           </p:cNvPr>
@@ -4735,7 +4735,7 @@
     </p:spTree>
     <p:extLst>
       <p:ext uri="{BB962C8B-B14F-4D97-AF65-F5344CB8AC3E}">
-        <p14:creationId xmlns:p14="http://schemas.microsoft.com/office/powerpoint/2010/main" val="1880794745"/>
+        <p14:creationId xmlns:p14="http://schemas.microsoft.com/office/powerpoint/2010/main" val="1825868970"/>
       </p:ext>
     </p:extLst>
   </p:cSld>
@@ -4766,7 +4766,7 @@
           <p:cNvPr id="1" name="">
             <a:extLst xmlns:a="http://schemas.openxmlformats.org/drawingml/2006/main">
               <a:ext uri="{FF2B5EF4-FFF2-40B4-BE49-F238E27FC236}">
-                <a16:creationId xmlns:a16="http://schemas.microsoft.com/office/drawing/2014/main" id="{9254891B-0C38-4B53-9F9F-8E4CB2121B04}"/>
+                <a16:creationId xmlns:a16="http://schemas.microsoft.com/office/drawing/2014/main" id="{7FC737C2-BBEB-43A8-8EEB-69EAC12E06A7}"/>
               </a:ext>
             </a:extLst>
           </p:cNvPr>
@@ -4816,7 +4816,7 @@
           <p:cNvPr id="2" name="">
             <a:extLst xmlns:a="http://schemas.openxmlformats.org/drawingml/2006/main">
               <a:ext uri="{FF2B5EF4-FFF2-40B4-BE49-F238E27FC236}">
-                <a16:creationId xmlns:a16="http://schemas.microsoft.com/office/drawing/2014/main" id="{44A995C1-6B81-47A1-96CD-B0A19A5B52F7}"/>
+                <a16:creationId xmlns:a16="http://schemas.microsoft.com/office/drawing/2014/main" id="{4A0B4B86-E8E0-4DB6-8FC7-E4E7D541F694}"/>
               </a:ext>
             </a:extLst>
           </p:cNvPr>
@@ -4866,7 +4866,7 @@
           <p:cNvPr id="3" name="">
             <a:extLst xmlns:a="http://schemas.openxmlformats.org/drawingml/2006/main">
               <a:ext uri="{FF2B5EF4-FFF2-40B4-BE49-F238E27FC236}">
-                <a16:creationId xmlns:a16="http://schemas.microsoft.com/office/drawing/2014/main" id="{A4737906-625A-49A9-91C8-68A66F2042CD}"/>
+                <a16:creationId xmlns:a16="http://schemas.microsoft.com/office/drawing/2014/main" id="{355BC8E0-F2B6-46CD-A0F9-1213C69BD050}"/>
               </a:ext>
             </a:extLst>
           </p:cNvPr>
@@ -4899,7 +4899,7 @@
           <p:cNvPr id="4" name="">
             <a:extLst xmlns:a="http://schemas.openxmlformats.org/drawingml/2006/main">
               <a:ext uri="{FF2B5EF4-FFF2-40B4-BE49-F238E27FC236}">
-                <a16:creationId xmlns:a16="http://schemas.microsoft.com/office/drawing/2014/main" id="{539D5621-D198-4570-8EEC-B8DB4A38C683}"/>
+                <a16:creationId xmlns:a16="http://schemas.microsoft.com/office/drawing/2014/main" id="{05B1D7F1-51F6-41C6-BB5E-03FED23639BA}"/>
               </a:ext>
             </a:extLst>
           </p:cNvPr>
@@ -4953,7 +4953,7 @@
           <p:nvPr/>
         </p:nvPicPr>
         <p:blipFill>
-          <a:blip xmlns:r="http://schemas.openxmlformats.org/officeDocument/2006/relationships" xmlns:a="http://schemas.openxmlformats.org/drawingml/2006/main" r:embed="Ra4120dbf3fdb4534"/>
+          <a:blip xmlns:r="http://schemas.openxmlformats.org/officeDocument/2006/relationships" xmlns:a="http://schemas.openxmlformats.org/drawingml/2006/main" r:embed="R22607d4a15db4fa8"/>
           <a:srcRect xmlns:a="http://schemas.openxmlformats.org/drawingml/2006/main" l="0" t="334" r="0" b="334"/>
           <a:stretch xmlns:a="http://schemas.openxmlformats.org/drawingml/2006/main">
             <a:fillRect l="0" t="0" r="0" b="0"/>
@@ -4980,7 +4980,7 @@
           <p:nvPr/>
         </p:nvPicPr>
         <p:blipFill>
-          <a:blip xmlns:r="http://schemas.openxmlformats.org/officeDocument/2006/relationships" xmlns:a="http://schemas.openxmlformats.org/drawingml/2006/main" r:embed="R004a0b33c70d4b4e"/>
+          <a:blip xmlns:r="http://schemas.openxmlformats.org/officeDocument/2006/relationships" xmlns:a="http://schemas.openxmlformats.org/drawingml/2006/main" r:embed="Rb2c2c6ba4bb54f2f"/>
           <a:srcRect xmlns:a="http://schemas.openxmlformats.org/drawingml/2006/main" l="0" t="334" r="0" b="334"/>
           <a:stretch xmlns:a="http://schemas.openxmlformats.org/drawingml/2006/main">
             <a:fillRect l="0" t="0" r="0" b="0"/>
@@ -5003,7 +5003,7 @@
           <p:cNvPr id="7" name="">
             <a:extLst xmlns:a="http://schemas.openxmlformats.org/drawingml/2006/main">
               <a:ext uri="{FF2B5EF4-FFF2-40B4-BE49-F238E27FC236}">
-                <a16:creationId xmlns:a16="http://schemas.microsoft.com/office/drawing/2014/main" id="{70FFA2FB-C488-4F0A-9D34-3620A1ED7C1D}"/>
+                <a16:creationId xmlns:a16="http://schemas.microsoft.com/office/drawing/2014/main" id="{7021DF34-C1DC-4A78-AB1A-0E5FD7AC01D1}"/>
               </a:ext>
             </a:extLst>
           </p:cNvPr>
@@ -5051,7 +5051,7 @@
     </p:spTree>
     <p:extLst>
       <p:ext uri="{BB962C8B-B14F-4D97-AF65-F5344CB8AC3E}">
-        <p14:creationId xmlns:p14="http://schemas.microsoft.com/office/powerpoint/2010/main" val="1992094288"/>
+        <p14:creationId xmlns:p14="http://schemas.microsoft.com/office/powerpoint/2010/main" val="389412723"/>
       </p:ext>
     </p:extLst>
   </p:cSld>
@@ -5082,7 +5082,7 @@
           <p:cNvPr id="1" name="">
             <a:extLst xmlns:a="http://schemas.openxmlformats.org/drawingml/2006/main">
               <a:ext uri="{FF2B5EF4-FFF2-40B4-BE49-F238E27FC236}">
-                <a16:creationId xmlns:a16="http://schemas.microsoft.com/office/drawing/2014/main" id="{7F0926F4-46A3-41F4-B6A9-C52F8F1CCD4E}"/>
+                <a16:creationId xmlns:a16="http://schemas.microsoft.com/office/drawing/2014/main" id="{EF5C33F8-55A6-4007-A7E4-8A1EAE98ED2C}"/>
               </a:ext>
             </a:extLst>
           </p:cNvPr>
@@ -5132,7 +5132,7 @@
           <p:cNvPr id="2" name="">
             <a:extLst xmlns:a="http://schemas.openxmlformats.org/drawingml/2006/main">
               <a:ext uri="{FF2B5EF4-FFF2-40B4-BE49-F238E27FC236}">
-                <a16:creationId xmlns:a16="http://schemas.microsoft.com/office/drawing/2014/main" id="{9DAA5AE3-410B-4DCF-BB49-0D2C096E9AE5}"/>
+                <a16:creationId xmlns:a16="http://schemas.microsoft.com/office/drawing/2014/main" id="{0A5974BB-6FD1-42D4-9CB1-8D28542A86C8}"/>
               </a:ext>
             </a:extLst>
           </p:cNvPr>
@@ -5182,7 +5182,7 @@
           <p:cNvPr id="3" name="">
             <a:extLst xmlns:a="http://schemas.openxmlformats.org/drawingml/2006/main">
               <a:ext uri="{FF2B5EF4-FFF2-40B4-BE49-F238E27FC236}">
-                <a16:creationId xmlns:a16="http://schemas.microsoft.com/office/drawing/2014/main" id="{6085E347-C1FE-446B-A2F7-B01B1384046B}"/>
+                <a16:creationId xmlns:a16="http://schemas.microsoft.com/office/drawing/2014/main" id="{37EECBEE-68B9-494E-9A64-45EF0DEA059A}"/>
               </a:ext>
             </a:extLst>
           </p:cNvPr>
@@ -5215,7 +5215,7 @@
           <p:cNvPr id="4" name="">
             <a:extLst xmlns:a="http://schemas.openxmlformats.org/drawingml/2006/main">
               <a:ext uri="{FF2B5EF4-FFF2-40B4-BE49-F238E27FC236}">
-                <a16:creationId xmlns:a16="http://schemas.microsoft.com/office/drawing/2014/main" id="{C4D28E4A-C3C6-4393-8C95-1B9430FF7B82}"/>
+                <a16:creationId xmlns:a16="http://schemas.microsoft.com/office/drawing/2014/main" id="{CB851648-020B-4D54-BC25-3C5AC31638B6}"/>
               </a:ext>
             </a:extLst>
           </p:cNvPr>
@@ -5265,7 +5265,7 @@
           <p:cNvPr id="5" name="">
             <a:extLst xmlns:a="http://schemas.openxmlformats.org/drawingml/2006/main">
               <a:ext uri="{FF2B5EF4-FFF2-40B4-BE49-F238E27FC236}">
-                <a16:creationId xmlns:a16="http://schemas.microsoft.com/office/drawing/2014/main" id="{C7B9EF7F-B1FE-4C2D-8A39-91C75DC8C819}"/>
+                <a16:creationId xmlns:a16="http://schemas.microsoft.com/office/drawing/2014/main" id="{3505CD6D-E922-4B32-B79B-93FFDE89F7C1}"/>
               </a:ext>
             </a:extLst>
           </p:cNvPr>
@@ -5298,7 +5298,7 @@
           <p:cNvPr id="6" name="">
             <a:extLst xmlns:a="http://schemas.openxmlformats.org/drawingml/2006/main">
               <a:ext uri="{FF2B5EF4-FFF2-40B4-BE49-F238E27FC236}">
-                <a16:creationId xmlns:a16="http://schemas.microsoft.com/office/drawing/2014/main" id="{66A2338B-9F15-4C77-8BAF-4D34A9A88F97}"/>
+                <a16:creationId xmlns:a16="http://schemas.microsoft.com/office/drawing/2014/main" id="{2A8C19A8-CFB2-4521-8741-5E4F61AECB0A}"/>
               </a:ext>
             </a:extLst>
           </p:cNvPr>
@@ -5348,7 +5348,7 @@
           <p:cNvPr id="7" name="">
             <a:extLst xmlns:a="http://schemas.openxmlformats.org/drawingml/2006/main">
               <a:ext uri="{FF2B5EF4-FFF2-40B4-BE49-F238E27FC236}">
-                <a16:creationId xmlns:a16="http://schemas.microsoft.com/office/drawing/2014/main" id="{F64FC067-FB94-4276-8550-D58BFF5E3F63}"/>
+                <a16:creationId xmlns:a16="http://schemas.microsoft.com/office/drawing/2014/main" id="{B7A3A306-0050-47F7-9786-C9F9FDFBE03E}"/>
               </a:ext>
             </a:extLst>
           </p:cNvPr>
@@ -5381,7 +5381,7 @@
           <p:cNvPr id="8" name="">
             <a:extLst xmlns:a="http://schemas.openxmlformats.org/drawingml/2006/main">
               <a:ext uri="{FF2B5EF4-FFF2-40B4-BE49-F238E27FC236}">
-                <a16:creationId xmlns:a16="http://schemas.microsoft.com/office/drawing/2014/main" id="{0C06335B-9F4C-4A7E-89D0-81ED80A4025D}"/>
+                <a16:creationId xmlns:a16="http://schemas.microsoft.com/office/drawing/2014/main" id="{23E5E560-34AE-4E46-AC29-48FA99BC5D70}"/>
               </a:ext>
             </a:extLst>
           </p:cNvPr>
@@ -5431,7 +5431,7 @@
           <p:cNvPr id="9" name="">
             <a:extLst xmlns:a="http://schemas.openxmlformats.org/drawingml/2006/main">
               <a:ext uri="{FF2B5EF4-FFF2-40B4-BE49-F238E27FC236}">
-                <a16:creationId xmlns:a16="http://schemas.microsoft.com/office/drawing/2014/main" id="{2578FC78-5EB9-4C13-8714-C886A3B4C65A}"/>
+                <a16:creationId xmlns:a16="http://schemas.microsoft.com/office/drawing/2014/main" id="{EC988F80-83AF-42BE-AF05-EAFFAB4BFE18}"/>
               </a:ext>
             </a:extLst>
           </p:cNvPr>
@@ -5464,7 +5464,7 @@
           <p:cNvPr id="10" name="">
             <a:extLst xmlns:a="http://schemas.openxmlformats.org/drawingml/2006/main">
               <a:ext uri="{FF2B5EF4-FFF2-40B4-BE49-F238E27FC236}">
-                <a16:creationId xmlns:a16="http://schemas.microsoft.com/office/drawing/2014/main" id="{9BD9AD77-C0B5-4B41-87F0-B9C32C9A4318}"/>
+                <a16:creationId xmlns:a16="http://schemas.microsoft.com/office/drawing/2014/main" id="{A9DEA4AE-434D-46B9-8878-82CFDD37F79A}"/>
               </a:ext>
             </a:extLst>
           </p:cNvPr>
@@ -5514,7 +5514,7 @@
           <p:cNvPr id="11" name="">
             <a:extLst xmlns:a="http://schemas.openxmlformats.org/drawingml/2006/main">
               <a:ext uri="{FF2B5EF4-FFF2-40B4-BE49-F238E27FC236}">
-                <a16:creationId xmlns:a16="http://schemas.microsoft.com/office/drawing/2014/main" id="{EEB73B5F-9212-48B7-9A81-2C3F9C5176F1}"/>
+                <a16:creationId xmlns:a16="http://schemas.microsoft.com/office/drawing/2014/main" id="{2AD89597-665B-420C-8539-015BA49ADDD0}"/>
               </a:ext>
             </a:extLst>
           </p:cNvPr>
@@ -5547,7 +5547,7 @@
           <p:cNvPr id="12" name="">
             <a:extLst xmlns:a="http://schemas.openxmlformats.org/drawingml/2006/main">
               <a:ext uri="{FF2B5EF4-FFF2-40B4-BE49-F238E27FC236}">
-                <a16:creationId xmlns:a16="http://schemas.microsoft.com/office/drawing/2014/main" id="{A0A9BA01-1989-4FF9-A96A-70380EDC7A44}"/>
+                <a16:creationId xmlns:a16="http://schemas.microsoft.com/office/drawing/2014/main" id="{818C0607-24F2-40D7-B357-0AFC247992F0}"/>
               </a:ext>
             </a:extLst>
           </p:cNvPr>
@@ -5597,7 +5597,7 @@
           <p:cNvPr id="13" name="">
             <a:extLst xmlns:a="http://schemas.openxmlformats.org/drawingml/2006/main">
               <a:ext uri="{FF2B5EF4-FFF2-40B4-BE49-F238E27FC236}">
-                <a16:creationId xmlns:a16="http://schemas.microsoft.com/office/drawing/2014/main" id="{C1F6E6E5-00A0-4F47-89BD-5FC737F2CE6A}"/>
+                <a16:creationId xmlns:a16="http://schemas.microsoft.com/office/drawing/2014/main" id="{5E22B51D-EEAB-4D3D-9D0D-7540269E9C65}"/>
               </a:ext>
             </a:extLst>
           </p:cNvPr>
@@ -5632,7 +5632,7 @@
           <p:cNvPr id="14" name="">
             <a:extLst xmlns:a="http://schemas.openxmlformats.org/drawingml/2006/main">
               <a:ext uri="{FF2B5EF4-FFF2-40B4-BE49-F238E27FC236}">
-                <a16:creationId xmlns:a16="http://schemas.microsoft.com/office/drawing/2014/main" id="{2BA3307C-9FF5-4580-8972-8375013BC501}"/>
+                <a16:creationId xmlns:a16="http://schemas.microsoft.com/office/drawing/2014/main" id="{0011E932-3AD8-4B4A-9447-133DB976C044}"/>
               </a:ext>
             </a:extLst>
           </p:cNvPr>
@@ -5680,7 +5680,7 @@
     </p:spTree>
     <p:extLst>
       <p:ext uri="{BB962C8B-B14F-4D97-AF65-F5344CB8AC3E}">
-        <p14:creationId xmlns:p14="http://schemas.microsoft.com/office/powerpoint/2010/main" val="1405614250"/>
+        <p14:creationId xmlns:p14="http://schemas.microsoft.com/office/powerpoint/2010/main" val="1136490352"/>
       </p:ext>
     </p:extLst>
   </p:cSld>

</xml_diff>